<commit_message>
Brighten original 28-slide deck for AVM Morgan's actual presentation: bright sky-blue panels + white text, military-tech radar background, and lightening overlays on 4 slides that had genuinely dark tactical photos (cover, slide 5, slide 9, closing) - full brightness QA pass, zero corruption
</commit_message>
<xml_diff>
--- a/avm_morgan_docs/AVM_MORGAN_SECURITY_KEYNOTE_30MIN_v3_WITH_REFERENCES.pptx
+++ b/avm_morgan_docs/AVM_MORGAN_SECURITY_KEYNOTE_30MIN_v3_WITH_REFERENCES.pptx
@@ -3127,6 +3127,30 @@
       </p:grpSpPr>
       <p:pic>
         <p:nvPicPr>
+          <p:cNvPr id="8" name="Picture 7" descr="bg_military_tech_169.png"/>
+          <p:cNvPicPr>
+            <a:picLocks noChangeAspect="1"/>
+          </p:cNvPicPr>
+          <p:nvPr/>
+        </p:nvPicPr>
+        <p:blipFill>
+          <a:blip r:embed="rId3"/>
+          <a:stretch>
+            <a:fillRect/>
+          </a:stretch>
+        </p:blipFill>
+        <p:spPr>
+          <a:xfrm>
+            <a:off x="0" y="0"/>
+            <a:ext cx="12192000" cy="6858000"/>
+          </a:xfrm>
+          <a:prstGeom prst="rect">
+            <a:avLst/>
+          </a:prstGeom>
+        </p:spPr>
+      </p:pic>
+      <p:pic>
+        <p:nvPicPr>
           <p:cNvPr id="2" name="Picture 1" descr="opening_3d.png"/>
           <p:cNvPicPr>
             <a:picLocks noChangeAspect="1"/>
@@ -3151,6 +3175,51 @@
       </p:pic>
       <p:sp>
         <p:nvSpPr>
+          <p:cNvPr id="9" name="Rectangle 8"/>
+          <p:cNvSpPr/>
+          <p:nvPr/>
+        </p:nvSpPr>
+        <p:spPr>
+          <a:xfrm>
+            <a:off x="-619260" y="-1"/>
+            <a:ext cx="12810956" cy="7206343"/>
+          </a:xfrm>
+          <a:prstGeom prst="rect">
+            <a:avLst/>
+          </a:prstGeom>
+          <a:solidFill>
+            <a:srgbClr val="F0F7FF">
+              <a:alpha val="60000"/>
+            </a:srgbClr>
+          </a:solidFill>
+          <a:ln>
+            <a:noFill/>
+          </a:ln>
+        </p:spPr>
+        <p:style>
+          <a:lnRef idx="1">
+            <a:schemeClr val="accent1"/>
+          </a:lnRef>
+          <a:fillRef idx="3">
+            <a:schemeClr val="accent1"/>
+          </a:fillRef>
+          <a:effectRef idx="2">
+            <a:schemeClr val="accent1"/>
+          </a:effectRef>
+          <a:fontRef idx="minor">
+            <a:schemeClr val="lt1"/>
+          </a:fontRef>
+        </p:style>
+        <p:txBody>
+          <a:bodyPr rtlCol="0" anchor="ctr"/>
+          <a:lstStyle/>
+          <a:p>
+            <a:pPr algn="ctr"/>
+          </a:p>
+        </p:txBody>
+      </p:sp>
+      <p:sp>
+        <p:nvSpPr>
           <p:cNvPr id="3" name="Rectangle 2"/>
           <p:cNvSpPr/>
           <p:nvPr/>
@@ -3164,7 +3233,7 @@
             <a:avLst/>
           </a:prstGeom>
           <a:solidFill>
-            <a:srgbClr val="0B1F3A">
+            <a:srgbClr val="0EA5E9">
               <a:alpha val="75000"/>
             </a:srgbClr>
           </a:solidFill>
@@ -3386,6 +3455,30 @@
           <a:chExt cx="0" cy="0"/>
         </a:xfrm>
       </p:grpSpPr>
+      <p:pic>
+        <p:nvPicPr>
+          <p:cNvPr id="24" name="Picture 23" descr="bg_military_tech_169.png"/>
+          <p:cNvPicPr>
+            <a:picLocks noChangeAspect="1"/>
+          </p:cNvPicPr>
+          <p:nvPr/>
+        </p:nvPicPr>
+        <p:blipFill>
+          <a:blip r:embed="rId2"/>
+          <a:stretch>
+            <a:fillRect/>
+          </a:stretch>
+        </p:blipFill>
+        <p:spPr>
+          <a:xfrm>
+            <a:off x="0" y="0"/>
+            <a:ext cx="12192000" cy="6858000"/>
+          </a:xfrm>
+          <a:prstGeom prst="rect">
+            <a:avLst/>
+          </a:prstGeom>
+        </p:spPr>
+      </p:pic>
       <p:sp>
         <p:nvSpPr>
           <p:cNvPr id="2" name="Rectangle 1"/>
@@ -3401,7 +3494,7 @@
             <a:avLst/>
           </a:prstGeom>
           <a:solidFill>
-            <a:srgbClr val="132C52"/>
+            <a:srgbClr val="0EA5E9"/>
           </a:solidFill>
           <a:ln>
             <a:noFill/>
@@ -3804,7 +3897,7 @@
             <a:avLst/>
           </a:prstGeom>
           <a:solidFill>
-            <a:srgbClr val="132C52"/>
+            <a:srgbClr val="0EA5E9"/>
           </a:solidFill>
           <a:ln>
             <a:noFill/>
@@ -3888,7 +3981,7 @@
             <a:avLst/>
           </a:prstGeom>
           <a:solidFill>
-            <a:srgbClr val="0B1F3A"/>
+            <a:srgbClr val="0EA5E9"/>
           </a:solidFill>
           <a:ln>
             <a:noFill/>
@@ -3972,7 +4065,7 @@
             <a:avLst/>
           </a:prstGeom>
           <a:solidFill>
-            <a:srgbClr val="0B1F3A"/>
+            <a:srgbClr val="0EA5E9"/>
           </a:solidFill>
           <a:ln>
             <a:noFill/>
@@ -4056,7 +4149,7 @@
             <a:avLst/>
           </a:prstGeom>
           <a:solidFill>
-            <a:srgbClr val="0B1F3A"/>
+            <a:srgbClr val="0EA5E9"/>
           </a:solidFill>
           <a:ln>
             <a:noFill/>
@@ -4140,7 +4233,7 @@
             <a:avLst/>
           </a:prstGeom>
           <a:solidFill>
-            <a:srgbClr val="0B1F3A"/>
+            <a:srgbClr val="0EA5E9"/>
           </a:solidFill>
           <a:ln>
             <a:noFill/>
@@ -4224,7 +4317,7 @@
             <a:avLst/>
           </a:prstGeom>
           <a:solidFill>
-            <a:srgbClr val="0B1F3A"/>
+            <a:srgbClr val="0EA5E9"/>
           </a:solidFill>
           <a:ln>
             <a:noFill/>
@@ -4308,7 +4401,7 @@
             <a:avLst/>
           </a:prstGeom>
           <a:solidFill>
-            <a:srgbClr val="0B1F3A"/>
+            <a:srgbClr val="0EA5E9"/>
           </a:solidFill>
           <a:ln>
             <a:noFill/>
@@ -4410,6 +4503,30 @@
           <a:chExt cx="0" cy="0"/>
         </a:xfrm>
       </p:grpSpPr>
+      <p:pic>
+        <p:nvPicPr>
+          <p:cNvPr id="17" name="Picture 16" descr="bg_military_tech_169.png"/>
+          <p:cNvPicPr>
+            <a:picLocks noChangeAspect="1"/>
+          </p:cNvPicPr>
+          <p:nvPr/>
+        </p:nvPicPr>
+        <p:blipFill>
+          <a:blip r:embed="rId2"/>
+          <a:stretch>
+            <a:fillRect/>
+          </a:stretch>
+        </p:blipFill>
+        <p:spPr>
+          <a:xfrm>
+            <a:off x="0" y="0"/>
+            <a:ext cx="12192000" cy="6858000"/>
+          </a:xfrm>
+          <a:prstGeom prst="rect">
+            <a:avLst/>
+          </a:prstGeom>
+        </p:spPr>
+      </p:pic>
       <p:sp>
         <p:nvSpPr>
           <p:cNvPr id="2" name="Rectangle 1"/>
@@ -4425,7 +4542,7 @@
             <a:avLst/>
           </a:prstGeom>
           <a:solidFill>
-            <a:srgbClr val="132C52"/>
+            <a:srgbClr val="0EA5E9"/>
           </a:solidFill>
           <a:ln>
             <a:noFill/>
@@ -4749,7 +4866,7 @@
             <a:avLst/>
           </a:prstGeom>
           <a:solidFill>
-            <a:srgbClr val="132C52"/>
+            <a:srgbClr val="0EA5E9"/>
           </a:solidFill>
           <a:ln w="12700">
             <a:solidFill>
@@ -4803,7 +4920,7 @@
             <a:avLst/>
           </a:prstGeom>
           <a:solidFill>
-            <a:srgbClr val="132C52"/>
+            <a:srgbClr val="0EA5E9"/>
           </a:solidFill>
           <a:ln w="12700">
             <a:solidFill>
@@ -4857,7 +4974,7 @@
             <a:avLst/>
           </a:prstGeom>
           <a:solidFill>
-            <a:srgbClr val="132C52"/>
+            <a:srgbClr val="0EA5E9"/>
           </a:solidFill>
           <a:ln w="12700">
             <a:solidFill>
@@ -4911,7 +5028,7 @@
             <a:avLst/>
           </a:prstGeom>
           <a:solidFill>
-            <a:srgbClr val="132C52"/>
+            <a:srgbClr val="0EA5E9"/>
           </a:solidFill>
           <a:ln w="12700">
             <a:solidFill>
@@ -4965,7 +5082,7 @@
             <a:avLst/>
           </a:prstGeom>
           <a:solidFill>
-            <a:srgbClr val="132C52"/>
+            <a:srgbClr val="0EA5E9"/>
           </a:solidFill>
           <a:ln w="12700">
             <a:solidFill>
@@ -5019,7 +5136,7 @@
             <a:avLst/>
           </a:prstGeom>
           <a:solidFill>
-            <a:srgbClr val="132C52"/>
+            <a:srgbClr val="0EA5E9"/>
           </a:solidFill>
           <a:ln w="12700">
             <a:solidFill>
@@ -5130,6 +5247,30 @@
           <a:chExt cx="0" cy="0"/>
         </a:xfrm>
       </p:grpSpPr>
+      <p:pic>
+        <p:nvPicPr>
+          <p:cNvPr id="14" name="Picture 13" descr="bg_military_tech_169.png"/>
+          <p:cNvPicPr>
+            <a:picLocks noChangeAspect="1"/>
+          </p:cNvPicPr>
+          <p:nvPr/>
+        </p:nvPicPr>
+        <p:blipFill>
+          <a:blip r:embed="rId2"/>
+          <a:stretch>
+            <a:fillRect/>
+          </a:stretch>
+        </p:blipFill>
+        <p:spPr>
+          <a:xfrm>
+            <a:off x="0" y="0"/>
+            <a:ext cx="12192000" cy="6858000"/>
+          </a:xfrm>
+          <a:prstGeom prst="rect">
+            <a:avLst/>
+          </a:prstGeom>
+        </p:spPr>
+      </p:pic>
       <p:sp>
         <p:nvSpPr>
           <p:cNvPr id="2" name="Rectangle 1"/>
@@ -5145,7 +5286,7 @@
             <a:avLst/>
           </a:prstGeom>
           <a:solidFill>
-            <a:srgbClr val="132C52"/>
+            <a:srgbClr val="0EA5E9"/>
           </a:solidFill>
           <a:ln>
             <a:noFill/>
@@ -5770,6 +5911,30 @@
           <a:chExt cx="0" cy="0"/>
         </a:xfrm>
       </p:grpSpPr>
+      <p:pic>
+        <p:nvPicPr>
+          <p:cNvPr id="19" name="Picture 18" descr="bg_military_tech_169.png"/>
+          <p:cNvPicPr>
+            <a:picLocks noChangeAspect="1"/>
+          </p:cNvPicPr>
+          <p:nvPr/>
+        </p:nvPicPr>
+        <p:blipFill>
+          <a:blip r:embed="rId2"/>
+          <a:stretch>
+            <a:fillRect/>
+          </a:stretch>
+        </p:blipFill>
+        <p:spPr>
+          <a:xfrm>
+            <a:off x="0" y="0"/>
+            <a:ext cx="12192000" cy="6858000"/>
+          </a:xfrm>
+          <a:prstGeom prst="rect">
+            <a:avLst/>
+          </a:prstGeom>
+        </p:spPr>
+      </p:pic>
       <p:sp>
         <p:nvSpPr>
           <p:cNvPr id="2" name="Rectangle 1"/>
@@ -5785,7 +5950,7 @@
             <a:avLst/>
           </a:prstGeom>
           <a:solidFill>
-            <a:srgbClr val="132C52"/>
+            <a:srgbClr val="0EA5E9"/>
           </a:solidFill>
           <a:ln>
             <a:noFill/>
@@ -6070,7 +6235,7 @@
             <a:avLst/>
           </a:prstGeom>
           <a:solidFill>
-            <a:srgbClr val="132C52"/>
+            <a:srgbClr val="0EA5E9"/>
           </a:solidFill>
           <a:ln w="9525">
             <a:solidFill>
@@ -6125,7 +6290,7 @@
             <a:avLst/>
           </a:prstGeom>
           <a:solidFill>
-            <a:srgbClr val="132C52"/>
+            <a:srgbClr val="0EA5E9"/>
           </a:solidFill>
           <a:ln w="9525">
             <a:solidFill>
@@ -6180,7 +6345,7 @@
             <a:avLst/>
           </a:prstGeom>
           <a:solidFill>
-            <a:srgbClr val="132C52"/>
+            <a:srgbClr val="0EA5E9"/>
           </a:solidFill>
           <a:ln w="9525">
             <a:solidFill>
@@ -6235,7 +6400,7 @@
             <a:avLst/>
           </a:prstGeom>
           <a:solidFill>
-            <a:srgbClr val="132C52"/>
+            <a:srgbClr val="0EA5E9"/>
           </a:solidFill>
           <a:ln w="9525">
             <a:solidFill>
@@ -6290,7 +6455,7 @@
             <a:avLst/>
           </a:prstGeom>
           <a:solidFill>
-            <a:srgbClr val="132C52"/>
+            <a:srgbClr val="0EA5E9"/>
           </a:solidFill>
           <a:ln w="9525">
             <a:solidFill>
@@ -6345,7 +6510,7 @@
             <a:avLst/>
           </a:prstGeom>
           <a:solidFill>
-            <a:srgbClr val="132C52"/>
+            <a:srgbClr val="0EA5E9"/>
           </a:solidFill>
           <a:ln w="9525">
             <a:solidFill>
@@ -6400,7 +6565,7 @@
             <a:avLst/>
           </a:prstGeom>
           <a:solidFill>
-            <a:srgbClr val="132C52"/>
+            <a:srgbClr val="0EA5E9"/>
           </a:solidFill>
           <a:ln w="9525">
             <a:solidFill>
@@ -6455,7 +6620,7 @@
             <a:avLst/>
           </a:prstGeom>
           <a:solidFill>
-            <a:srgbClr val="132C52"/>
+            <a:srgbClr val="0EA5E9"/>
           </a:solidFill>
           <a:ln w="9525">
             <a:solidFill>
@@ -6510,7 +6675,7 @@
             <a:avLst/>
           </a:prstGeom>
           <a:solidFill>
-            <a:srgbClr val="132C52"/>
+            <a:srgbClr val="0EA5E9"/>
           </a:solidFill>
           <a:ln w="9525">
             <a:solidFill>
@@ -6622,6 +6787,30 @@
           <a:chExt cx="0" cy="0"/>
         </a:xfrm>
       </p:grpSpPr>
+      <p:pic>
+        <p:nvPicPr>
+          <p:cNvPr id="14" name="Picture 13" descr="bg_military_tech_169.png"/>
+          <p:cNvPicPr>
+            <a:picLocks noChangeAspect="1"/>
+          </p:cNvPicPr>
+          <p:nvPr/>
+        </p:nvPicPr>
+        <p:blipFill>
+          <a:blip r:embed="rId2"/>
+          <a:stretch>
+            <a:fillRect/>
+          </a:stretch>
+        </p:blipFill>
+        <p:spPr>
+          <a:xfrm>
+            <a:off x="0" y="0"/>
+            <a:ext cx="12192000" cy="6858000"/>
+          </a:xfrm>
+          <a:prstGeom prst="rect">
+            <a:avLst/>
+          </a:prstGeom>
+        </p:spPr>
+      </p:pic>
       <p:sp>
         <p:nvSpPr>
           <p:cNvPr id="2" name="Rectangle 1"/>
@@ -6637,7 +6826,7 @@
             <a:avLst/>
           </a:prstGeom>
           <a:solidFill>
-            <a:srgbClr val="132C52"/>
+            <a:srgbClr val="0EA5E9"/>
           </a:solidFill>
           <a:ln>
             <a:noFill/>
@@ -7002,7 +7191,7 @@
             <a:avLst/>
           </a:prstGeom>
           <a:solidFill>
-            <a:srgbClr val="132C52"/>
+            <a:srgbClr val="0EA5E9"/>
           </a:solidFill>
           <a:ln>
             <a:noFill/>
@@ -7143,7 +7332,7 @@
             <a:r>
               <a:rPr sz="2000" b="0" i="0">
                 <a:solidFill>
-                  <a:srgbClr val="E8EAEE"/>
+                  <a:srgbClr val="FFFFFF"/>
                 </a:solidFill>
                 <a:latin typeface="Calibri"/>
               </a:rPr>
@@ -7188,6 +7377,30 @@
           <a:chExt cx="0" cy="0"/>
         </a:xfrm>
       </p:grpSpPr>
+      <p:pic>
+        <p:nvPicPr>
+          <p:cNvPr id="28" name="Picture 27" descr="bg_military_tech_169.png"/>
+          <p:cNvPicPr>
+            <a:picLocks noChangeAspect="1"/>
+          </p:cNvPicPr>
+          <p:nvPr/>
+        </p:nvPicPr>
+        <p:blipFill>
+          <a:blip r:embed="rId2"/>
+          <a:stretch>
+            <a:fillRect/>
+          </a:stretch>
+        </p:blipFill>
+        <p:spPr>
+          <a:xfrm>
+            <a:off x="0" y="0"/>
+            <a:ext cx="12192000" cy="6858000"/>
+          </a:xfrm>
+          <a:prstGeom prst="rect">
+            <a:avLst/>
+          </a:prstGeom>
+        </p:spPr>
+      </p:pic>
       <p:sp>
         <p:nvSpPr>
           <p:cNvPr id="2" name="Rectangle 1"/>
@@ -7203,7 +7416,7 @@
             <a:avLst/>
           </a:prstGeom>
           <a:solidFill>
-            <a:srgbClr val="132C52"/>
+            <a:srgbClr val="0EA5E9"/>
           </a:solidFill>
           <a:ln>
             <a:noFill/>
@@ -8247,6 +8460,30 @@
           <a:chExt cx="0" cy="0"/>
         </a:xfrm>
       </p:grpSpPr>
+      <p:pic>
+        <p:nvPicPr>
+          <p:cNvPr id="20" name="Picture 19" descr="bg_military_tech_169.png"/>
+          <p:cNvPicPr>
+            <a:picLocks noChangeAspect="1"/>
+          </p:cNvPicPr>
+          <p:nvPr/>
+        </p:nvPicPr>
+        <p:blipFill>
+          <a:blip r:embed="rId2"/>
+          <a:stretch>
+            <a:fillRect/>
+          </a:stretch>
+        </p:blipFill>
+        <p:spPr>
+          <a:xfrm>
+            <a:off x="0" y="0"/>
+            <a:ext cx="12192000" cy="6858000"/>
+          </a:xfrm>
+          <a:prstGeom prst="rect">
+            <a:avLst/>
+          </a:prstGeom>
+        </p:spPr>
+      </p:pic>
       <p:sp>
         <p:nvSpPr>
           <p:cNvPr id="2" name="Rectangle 1"/>
@@ -8262,7 +8499,7 @@
             <a:avLst/>
           </a:prstGeom>
           <a:solidFill>
-            <a:srgbClr val="132C52"/>
+            <a:srgbClr val="0EA5E9"/>
           </a:solidFill>
           <a:ln>
             <a:noFill/>
@@ -8586,7 +8823,7 @@
             <a:avLst/>
           </a:prstGeom>
           <a:solidFill>
-            <a:srgbClr val="132C52"/>
+            <a:srgbClr val="0EA5E9"/>
           </a:solidFill>
           <a:ln w="9525">
             <a:solidFill>
@@ -8640,7 +8877,7 @@
             <a:avLst/>
           </a:prstGeom>
           <a:solidFill>
-            <a:srgbClr val="132C52"/>
+            <a:srgbClr val="0EA5E9"/>
           </a:solidFill>
           <a:ln w="9525">
             <a:solidFill>
@@ -8694,7 +8931,7 @@
             <a:avLst/>
           </a:prstGeom>
           <a:solidFill>
-            <a:srgbClr val="132C52"/>
+            <a:srgbClr val="0EA5E9"/>
           </a:solidFill>
           <a:ln w="9525">
             <a:solidFill>
@@ -8748,7 +8985,7 @@
             <a:avLst/>
           </a:prstGeom>
           <a:solidFill>
-            <a:srgbClr val="132C52"/>
+            <a:srgbClr val="0EA5E9"/>
           </a:solidFill>
           <a:ln w="9525">
             <a:solidFill>
@@ -8802,7 +9039,7 @@
             <a:avLst/>
           </a:prstGeom>
           <a:solidFill>
-            <a:srgbClr val="132C52"/>
+            <a:srgbClr val="0EA5E9"/>
           </a:solidFill>
           <a:ln w="9525">
             <a:solidFill>
@@ -8856,7 +9093,7 @@
             <a:avLst/>
           </a:prstGeom>
           <a:solidFill>
-            <a:srgbClr val="132C52"/>
+            <a:srgbClr val="0EA5E9"/>
           </a:solidFill>
           <a:ln w="9525">
             <a:solidFill>
@@ -8910,7 +9147,7 @@
             <a:avLst/>
           </a:prstGeom>
           <a:solidFill>
-            <a:srgbClr val="132C52"/>
+            <a:srgbClr val="0EA5E9"/>
           </a:solidFill>
           <a:ln w="9525">
             <a:solidFill>
@@ -8964,7 +9201,7 @@
             <a:avLst/>
           </a:prstGeom>
           <a:solidFill>
-            <a:srgbClr val="132C52"/>
+            <a:srgbClr val="0EA5E9"/>
           </a:solidFill>
           <a:ln w="9525">
             <a:solidFill>
@@ -9018,7 +9255,7 @@
             <a:avLst/>
           </a:prstGeom>
           <a:solidFill>
-            <a:srgbClr val="132C52"/>
+            <a:srgbClr val="0EA5E9"/>
           </a:solidFill>
           <a:ln w="12700">
             <a:solidFill>
@@ -9125,6 +9362,30 @@
           <a:chExt cx="0" cy="0"/>
         </a:xfrm>
       </p:grpSpPr>
+      <p:pic>
+        <p:nvPicPr>
+          <p:cNvPr id="19" name="Picture 18" descr="bg_military_tech_169.png"/>
+          <p:cNvPicPr>
+            <a:picLocks noChangeAspect="1"/>
+          </p:cNvPicPr>
+          <p:nvPr/>
+        </p:nvPicPr>
+        <p:blipFill>
+          <a:blip r:embed="rId2"/>
+          <a:stretch>
+            <a:fillRect/>
+          </a:stretch>
+        </p:blipFill>
+        <p:spPr>
+          <a:xfrm>
+            <a:off x="0" y="0"/>
+            <a:ext cx="12192000" cy="6858000"/>
+          </a:xfrm>
+          <a:prstGeom prst="rect">
+            <a:avLst/>
+          </a:prstGeom>
+        </p:spPr>
+      </p:pic>
       <p:sp>
         <p:nvSpPr>
           <p:cNvPr id="2" name="Rectangle 1"/>
@@ -9140,7 +9401,7 @@
             <a:avLst/>
           </a:prstGeom>
           <a:solidFill>
-            <a:srgbClr val="132C52"/>
+            <a:srgbClr val="0EA5E9"/>
           </a:solidFill>
           <a:ln>
             <a:noFill/>
@@ -9954,6 +10215,30 @@
           <a:chExt cx="0" cy="0"/>
         </a:xfrm>
       </p:grpSpPr>
+      <p:pic>
+        <p:nvPicPr>
+          <p:cNvPr id="15" name="Picture 14" descr="bg_military_tech_169.png"/>
+          <p:cNvPicPr>
+            <a:picLocks noChangeAspect="1"/>
+          </p:cNvPicPr>
+          <p:nvPr/>
+        </p:nvPicPr>
+        <p:blipFill>
+          <a:blip r:embed="rId2"/>
+          <a:stretch>
+            <a:fillRect/>
+          </a:stretch>
+        </p:blipFill>
+        <p:spPr>
+          <a:xfrm>
+            <a:off x="0" y="0"/>
+            <a:ext cx="12192000" cy="6858000"/>
+          </a:xfrm>
+          <a:prstGeom prst="rect">
+            <a:avLst/>
+          </a:prstGeom>
+        </p:spPr>
+      </p:pic>
       <p:sp>
         <p:nvSpPr>
           <p:cNvPr id="2" name="Rectangle 1"/>
@@ -9969,7 +10254,7 @@
             <a:avLst/>
           </a:prstGeom>
           <a:solidFill>
-            <a:srgbClr val="132C52"/>
+            <a:srgbClr val="0EA5E9"/>
           </a:solidFill>
           <a:ln>
             <a:noFill/>
@@ -10254,7 +10539,7 @@
             <a:avLst/>
           </a:prstGeom>
           <a:solidFill>
-            <a:srgbClr val="132C52"/>
+            <a:srgbClr val="0EA5E9"/>
           </a:solidFill>
           <a:ln>
             <a:noFill/>
@@ -10314,7 +10599,7 @@
             <a:r>
               <a:rPr sz="2000" b="1" i="0">
                 <a:solidFill>
-                  <a:srgbClr val="D4AF37"/>
+                  <a:srgbClr val="FFFFFF"/>
                 </a:solidFill>
                 <a:latin typeface="Calibri"/>
               </a:rPr>
@@ -10456,7 +10741,7 @@
             <a:avLst/>
           </a:prstGeom>
           <a:solidFill>
-            <a:srgbClr val="132C52"/>
+            <a:srgbClr val="0EA5E9"/>
           </a:solidFill>
           <a:ln>
             <a:noFill/>
@@ -10516,7 +10801,7 @@
             <a:r>
               <a:rPr sz="2000" b="1" i="0">
                 <a:solidFill>
-                  <a:srgbClr val="D4AF37"/>
+                  <a:srgbClr val="FFFFFF"/>
                 </a:solidFill>
                 <a:latin typeface="Calibri"/>
               </a:rPr>
@@ -10676,6 +10961,30 @@
           <a:chExt cx="0" cy="0"/>
         </a:xfrm>
       </p:grpSpPr>
+      <p:pic>
+        <p:nvPicPr>
+          <p:cNvPr id="16" name="Picture 15" descr="bg_military_tech_169.png"/>
+          <p:cNvPicPr>
+            <a:picLocks noChangeAspect="1"/>
+          </p:cNvPicPr>
+          <p:nvPr/>
+        </p:nvPicPr>
+        <p:blipFill>
+          <a:blip r:embed="rId2"/>
+          <a:stretch>
+            <a:fillRect/>
+          </a:stretch>
+        </p:blipFill>
+        <p:spPr>
+          <a:xfrm>
+            <a:off x="0" y="0"/>
+            <a:ext cx="12192000" cy="6858000"/>
+          </a:xfrm>
+          <a:prstGeom prst="rect">
+            <a:avLst/>
+          </a:prstGeom>
+        </p:spPr>
+      </p:pic>
       <p:sp>
         <p:nvSpPr>
           <p:cNvPr id="2" name="Rectangle 1"/>
@@ -10691,7 +11000,7 @@
             <a:avLst/>
           </a:prstGeom>
           <a:solidFill>
-            <a:srgbClr val="132C52"/>
+            <a:srgbClr val="0EA5E9"/>
           </a:solidFill>
           <a:ln>
             <a:noFill/>
@@ -11016,7 +11325,7 @@
             <a:avLst/>
           </a:prstGeom>
           <a:solidFill>
-            <a:srgbClr val="132C52"/>
+            <a:srgbClr val="0EA5E9"/>
           </a:solidFill>
           <a:ln w="12700">
             <a:solidFill>
@@ -11071,7 +11380,7 @@
             <a:avLst/>
           </a:prstGeom>
           <a:solidFill>
-            <a:srgbClr val="132C52"/>
+            <a:srgbClr val="0EA5E9"/>
           </a:solidFill>
           <a:ln w="12700">
             <a:solidFill>
@@ -11126,7 +11435,7 @@
             <a:avLst/>
           </a:prstGeom>
           <a:solidFill>
-            <a:srgbClr val="132C52"/>
+            <a:srgbClr val="0EA5E9"/>
           </a:solidFill>
           <a:ln w="12700">
             <a:solidFill>
@@ -11181,7 +11490,7 @@
             <a:avLst/>
           </a:prstGeom>
           <a:solidFill>
-            <a:srgbClr val="132C52"/>
+            <a:srgbClr val="0EA5E9"/>
           </a:solidFill>
           <a:ln w="12700">
             <a:solidFill>
@@ -11236,7 +11545,7 @@
             <a:avLst/>
           </a:prstGeom>
           <a:solidFill>
-            <a:srgbClr val="132C52"/>
+            <a:srgbClr val="0EA5E9"/>
           </a:solidFill>
           <a:ln w="12700">
             <a:solidFill>
@@ -11291,7 +11600,7 @@
             <a:avLst/>
           </a:prstGeom>
           <a:solidFill>
-            <a:srgbClr val="132C52"/>
+            <a:srgbClr val="0EA5E9"/>
           </a:solidFill>
           <a:ln w="12700">
             <a:solidFill>
@@ -11364,6 +11673,30 @@
           <a:chExt cx="0" cy="0"/>
         </a:xfrm>
       </p:grpSpPr>
+      <p:pic>
+        <p:nvPicPr>
+          <p:cNvPr id="14" name="Picture 13" descr="bg_military_tech_169.png"/>
+          <p:cNvPicPr>
+            <a:picLocks noChangeAspect="1"/>
+          </p:cNvPicPr>
+          <p:nvPr/>
+        </p:nvPicPr>
+        <p:blipFill>
+          <a:blip r:embed="rId2"/>
+          <a:stretch>
+            <a:fillRect/>
+          </a:stretch>
+        </p:blipFill>
+        <p:spPr>
+          <a:xfrm>
+            <a:off x="0" y="0"/>
+            <a:ext cx="12192000" cy="6858000"/>
+          </a:xfrm>
+          <a:prstGeom prst="rect">
+            <a:avLst/>
+          </a:prstGeom>
+        </p:spPr>
+      </p:pic>
       <p:sp>
         <p:nvSpPr>
           <p:cNvPr id="2" name="Rectangle 1"/>
@@ -11379,7 +11712,7 @@
             <a:avLst/>
           </a:prstGeom>
           <a:solidFill>
-            <a:srgbClr val="132C52"/>
+            <a:srgbClr val="0EA5E9"/>
           </a:solidFill>
           <a:ln>
             <a:noFill/>
@@ -11664,7 +11997,7 @@
             <a:avLst/>
           </a:prstGeom>
           <a:solidFill>
-            <a:srgbClr val="132C52"/>
+            <a:srgbClr val="0EA5E9"/>
           </a:solidFill>
           <a:ln>
             <a:noFill/>
@@ -11899,7 +12232,7 @@
             <a:avLst/>
           </a:prstGeom>
           <a:solidFill>
-            <a:srgbClr val="132C52"/>
+            <a:srgbClr val="0EA5E9"/>
           </a:solidFill>
           <a:ln>
             <a:noFill/>
@@ -11959,7 +12292,7 @@
             <a:r>
               <a:rPr sz="2000" b="1" i="0">
                 <a:solidFill>
-                  <a:srgbClr val="D4AF37"/>
+                  <a:srgbClr val="FFFFFF"/>
                 </a:solidFill>
                 <a:latin typeface="Calibri"/>
               </a:rPr>
@@ -12045,6 +12378,30 @@
           <a:chExt cx="0" cy="0"/>
         </a:xfrm>
       </p:grpSpPr>
+      <p:pic>
+        <p:nvPicPr>
+          <p:cNvPr id="16" name="Picture 15" descr="bg_military_tech_169.png"/>
+          <p:cNvPicPr>
+            <a:picLocks noChangeAspect="1"/>
+          </p:cNvPicPr>
+          <p:nvPr/>
+        </p:nvPicPr>
+        <p:blipFill>
+          <a:blip r:embed="rId2"/>
+          <a:stretch>
+            <a:fillRect/>
+          </a:stretch>
+        </p:blipFill>
+        <p:spPr>
+          <a:xfrm>
+            <a:off x="0" y="0"/>
+            <a:ext cx="12192000" cy="6858000"/>
+          </a:xfrm>
+          <a:prstGeom prst="rect">
+            <a:avLst/>
+          </a:prstGeom>
+        </p:spPr>
+      </p:pic>
       <p:sp>
         <p:nvSpPr>
           <p:cNvPr id="2" name="Rectangle 1"/>
@@ -12060,7 +12417,7 @@
             <a:avLst/>
           </a:prstGeom>
           <a:solidFill>
-            <a:srgbClr val="132C52"/>
+            <a:srgbClr val="0EA5E9"/>
           </a:solidFill>
           <a:ln>
             <a:noFill/>
@@ -12345,7 +12702,7 @@
             <a:avLst/>
           </a:prstGeom>
           <a:solidFill>
-            <a:srgbClr val="132C52"/>
+            <a:srgbClr val="0EA5E9"/>
           </a:solidFill>
           <a:ln>
             <a:noFill/>
@@ -12512,7 +12869,7 @@
             <a:avLst/>
           </a:prstGeom>
           <a:solidFill>
-            <a:srgbClr val="132C52"/>
+            <a:srgbClr val="0EA5E9"/>
           </a:solidFill>
           <a:ln>
             <a:noFill/>
@@ -12732,6 +13089,30 @@
           <a:chExt cx="0" cy="0"/>
         </a:xfrm>
       </p:grpSpPr>
+      <p:pic>
+        <p:nvPicPr>
+          <p:cNvPr id="13" name="Picture 12" descr="bg_military_tech_169.png"/>
+          <p:cNvPicPr>
+            <a:picLocks noChangeAspect="1"/>
+          </p:cNvPicPr>
+          <p:nvPr/>
+        </p:nvPicPr>
+        <p:blipFill>
+          <a:blip r:embed="rId2"/>
+          <a:stretch>
+            <a:fillRect/>
+          </a:stretch>
+        </p:blipFill>
+        <p:spPr>
+          <a:xfrm>
+            <a:off x="0" y="0"/>
+            <a:ext cx="12192000" cy="6858000"/>
+          </a:xfrm>
+          <a:prstGeom prst="rect">
+            <a:avLst/>
+          </a:prstGeom>
+        </p:spPr>
+      </p:pic>
       <p:sp>
         <p:nvSpPr>
           <p:cNvPr id="2" name="Rectangle 1"/>
@@ -12747,7 +13128,7 @@
             <a:avLst/>
           </a:prstGeom>
           <a:solidFill>
-            <a:srgbClr val="132C52"/>
+            <a:srgbClr val="0EA5E9"/>
           </a:solidFill>
           <a:ln>
             <a:noFill/>
@@ -13097,7 +13478,7 @@
             <a:avLst/>
           </a:prstGeom>
           <a:solidFill>
-            <a:srgbClr val="132C52"/>
+            <a:srgbClr val="0EA5E9"/>
           </a:solidFill>
           <a:ln w="12700">
             <a:solidFill>
@@ -13139,7 +13520,7 @@
             <a:r>
               <a:rPr sz="2000">
                 <a:solidFill>
-                  <a:srgbClr val="E8EAEE"/>
+                  <a:srgbClr val="FFFFFF"/>
                 </a:solidFill>
               </a:rPr>
               <a:t>Police • DSS • NSCDC • Analysis &amp; Coordination</a:t>
@@ -13162,7 +13543,7 @@
             <a:avLst/>
           </a:prstGeom>
           <a:solidFill>
-            <a:srgbClr val="132C52"/>
+            <a:srgbClr val="0EA5E9"/>
           </a:solidFill>
           <a:ln w="12700">
             <a:solidFill>
@@ -13204,7 +13585,7 @@
             <a:r>
               <a:rPr sz="2000">
                 <a:solidFill>
-                  <a:srgbClr val="E8EAEE"/>
+                  <a:srgbClr val="FFFFFF"/>
                 </a:solidFill>
               </a:rPr>
               <a:t>Traditional Rulers • Citizens • Local Govt • Early Warning</a:t>
@@ -13284,6 +13665,30 @@
           <a:chExt cx="0" cy="0"/>
         </a:xfrm>
       </p:grpSpPr>
+      <p:pic>
+        <p:nvPicPr>
+          <p:cNvPr id="14" name="Picture 13" descr="bg_military_tech_169.png"/>
+          <p:cNvPicPr>
+            <a:picLocks noChangeAspect="1"/>
+          </p:cNvPicPr>
+          <p:nvPr/>
+        </p:nvPicPr>
+        <p:blipFill>
+          <a:blip r:embed="rId2"/>
+          <a:stretch>
+            <a:fillRect/>
+          </a:stretch>
+        </p:blipFill>
+        <p:spPr>
+          <a:xfrm>
+            <a:off x="0" y="0"/>
+            <a:ext cx="12192000" cy="6858000"/>
+          </a:xfrm>
+          <a:prstGeom prst="rect">
+            <a:avLst/>
+          </a:prstGeom>
+        </p:spPr>
+      </p:pic>
       <p:sp>
         <p:nvSpPr>
           <p:cNvPr id="2" name="Rectangle 1"/>
@@ -13299,7 +13704,7 @@
             <a:avLst/>
           </a:prstGeom>
           <a:solidFill>
-            <a:srgbClr val="132C52"/>
+            <a:srgbClr val="0EA5E9"/>
           </a:solidFill>
           <a:ln>
             <a:noFill/>
@@ -13584,7 +13989,7 @@
             <a:avLst/>
           </a:prstGeom>
           <a:solidFill>
-            <a:srgbClr val="132C52"/>
+            <a:srgbClr val="0EA5E9"/>
           </a:solidFill>
           <a:ln w="12700">
             <a:solidFill>
@@ -13615,7 +14020,7 @@
             <a:r>
               <a:rPr sz="2000" b="1" dirty="0">
                 <a:solidFill>
-                  <a:srgbClr val="D4AF37"/>
+                  <a:srgbClr val="FFFFFF"/>
                 </a:solidFill>
               </a:rPr>
               <a:t>00:00 – 06:00</a:t>
@@ -13650,7 +14055,7 @@
             <a:avLst/>
           </a:prstGeom>
           <a:solidFill>
-            <a:srgbClr val="132C52"/>
+            <a:srgbClr val="0EA5E9"/>
           </a:solidFill>
           <a:ln w="12700">
             <a:solidFill>
@@ -13681,7 +14086,7 @@
             <a:r>
               <a:rPr sz="2000" b="1">
                 <a:solidFill>
-                  <a:srgbClr val="D4AF37"/>
+                  <a:srgbClr val="FFFFFF"/>
                 </a:solidFill>
               </a:rPr>
               <a:t>06:00 – 12:00</a:t>
@@ -13716,7 +14121,7 @@
             <a:avLst/>
           </a:prstGeom>
           <a:solidFill>
-            <a:srgbClr val="132C52"/>
+            <a:srgbClr val="0EA5E9"/>
           </a:solidFill>
           <a:ln w="12700">
             <a:solidFill>
@@ -13747,7 +14152,7 @@
             <a:r>
               <a:rPr sz="2000" b="1">
                 <a:solidFill>
-                  <a:srgbClr val="D4AF37"/>
+                  <a:srgbClr val="FFFFFF"/>
                 </a:solidFill>
               </a:rPr>
               <a:t>12:00 – 18:00</a:t>
@@ -13782,7 +14187,7 @@
             <a:avLst/>
           </a:prstGeom>
           <a:solidFill>
-            <a:srgbClr val="132C52"/>
+            <a:srgbClr val="0EA5E9"/>
           </a:solidFill>
           <a:ln w="12700">
             <a:solidFill>
@@ -13813,7 +14218,7 @@
             <a:r>
               <a:rPr sz="2000" b="1">
                 <a:solidFill>
-                  <a:srgbClr val="D4AF37"/>
+                  <a:srgbClr val="FFFFFF"/>
                 </a:solidFill>
               </a:rPr>
               <a:t>18:00 – 00:00</a:t>
@@ -13863,7 +14268,7 @@
             <a:r>
               <a:rPr sz="2000" b="0" i="1">
                 <a:solidFill>
-                  <a:srgbClr val="D4AF37"/>
+                  <a:srgbClr val="FFFFFF"/>
                 </a:solidFill>
                 <a:latin typeface="Calibri"/>
               </a:rPr>
@@ -13905,6 +14310,30 @@
           <a:chExt cx="0" cy="0"/>
         </a:xfrm>
       </p:grpSpPr>
+      <p:pic>
+        <p:nvPicPr>
+          <p:cNvPr id="19" name="Picture 18" descr="bg_military_tech_169.png"/>
+          <p:cNvPicPr>
+            <a:picLocks noChangeAspect="1"/>
+          </p:cNvPicPr>
+          <p:nvPr/>
+        </p:nvPicPr>
+        <p:blipFill>
+          <a:blip r:embed="rId2"/>
+          <a:stretch>
+            <a:fillRect/>
+          </a:stretch>
+        </p:blipFill>
+        <p:spPr>
+          <a:xfrm>
+            <a:off x="0" y="0"/>
+            <a:ext cx="12192000" cy="6858000"/>
+          </a:xfrm>
+          <a:prstGeom prst="rect">
+            <a:avLst/>
+          </a:prstGeom>
+        </p:spPr>
+      </p:pic>
       <p:sp>
         <p:nvSpPr>
           <p:cNvPr id="2" name="Rectangle 1"/>
@@ -13920,7 +14349,7 @@
             <a:avLst/>
           </a:prstGeom>
           <a:solidFill>
-            <a:srgbClr val="132C52"/>
+            <a:srgbClr val="0EA5E9"/>
           </a:solidFill>
           <a:ln>
             <a:noFill/>
@@ -14205,7 +14634,7 @@
             <a:avLst/>
           </a:prstGeom>
           <a:solidFill>
-            <a:srgbClr val="132C52"/>
+            <a:srgbClr val="0EA5E9"/>
           </a:solidFill>
           <a:ln w="9525">
             <a:solidFill>
@@ -14236,7 +14665,7 @@
             <a:r>
               <a:rPr sz="1400" b="1">
                 <a:solidFill>
-                  <a:srgbClr val="D4AF37"/>
+                  <a:srgbClr val="FFFFFF"/>
                 </a:solidFill>
               </a:rPr>
               <a:t>1.  </a:t>
@@ -14267,7 +14696,7 @@
             <a:avLst/>
           </a:prstGeom>
           <a:solidFill>
-            <a:srgbClr val="132C52"/>
+            <a:srgbClr val="0EA5E9"/>
           </a:solidFill>
           <a:ln w="9525">
             <a:solidFill>
@@ -14298,7 +14727,7 @@
             <a:r>
               <a:rPr sz="1400" b="1">
                 <a:solidFill>
-                  <a:srgbClr val="D4AF37"/>
+                  <a:srgbClr val="FFFFFF"/>
                 </a:solidFill>
               </a:rPr>
               <a:t>2.  </a:t>
@@ -14329,7 +14758,7 @@
             <a:avLst/>
           </a:prstGeom>
           <a:solidFill>
-            <a:srgbClr val="132C52"/>
+            <a:srgbClr val="0EA5E9"/>
           </a:solidFill>
           <a:ln w="9525">
             <a:solidFill>
@@ -14360,7 +14789,7 @@
             <a:r>
               <a:rPr sz="1400" b="1">
                 <a:solidFill>
-                  <a:srgbClr val="D4AF37"/>
+                  <a:srgbClr val="FFFFFF"/>
                 </a:solidFill>
               </a:rPr>
               <a:t>3.  </a:t>
@@ -14391,7 +14820,7 @@
             <a:avLst/>
           </a:prstGeom>
           <a:solidFill>
-            <a:srgbClr val="132C52"/>
+            <a:srgbClr val="0EA5E9"/>
           </a:solidFill>
           <a:ln w="9525">
             <a:solidFill>
@@ -14422,7 +14851,7 @@
             <a:r>
               <a:rPr sz="1400" b="1">
                 <a:solidFill>
-                  <a:srgbClr val="D4AF37"/>
+                  <a:srgbClr val="FFFFFF"/>
                 </a:solidFill>
               </a:rPr>
               <a:t>4.  </a:t>
@@ -14453,7 +14882,7 @@
             <a:avLst/>
           </a:prstGeom>
           <a:solidFill>
-            <a:srgbClr val="132C52"/>
+            <a:srgbClr val="0EA5E9"/>
           </a:solidFill>
           <a:ln w="9525">
             <a:solidFill>
@@ -14484,7 +14913,7 @@
             <a:r>
               <a:rPr sz="1400" b="1">
                 <a:solidFill>
-                  <a:srgbClr val="D4AF37"/>
+                  <a:srgbClr val="FFFFFF"/>
                 </a:solidFill>
               </a:rPr>
               <a:t>5.  </a:t>
@@ -14515,7 +14944,7 @@
             <a:avLst/>
           </a:prstGeom>
           <a:solidFill>
-            <a:srgbClr val="132C52"/>
+            <a:srgbClr val="0EA5E9"/>
           </a:solidFill>
           <a:ln w="9525">
             <a:solidFill>
@@ -14546,7 +14975,7 @@
             <a:r>
               <a:rPr sz="1400" b="1">
                 <a:solidFill>
-                  <a:srgbClr val="D4AF37"/>
+                  <a:srgbClr val="FFFFFF"/>
                 </a:solidFill>
               </a:rPr>
               <a:t>6.  </a:t>
@@ -14577,7 +15006,7 @@
             <a:avLst/>
           </a:prstGeom>
           <a:solidFill>
-            <a:srgbClr val="132C52"/>
+            <a:srgbClr val="0EA5E9"/>
           </a:solidFill>
           <a:ln w="9525">
             <a:solidFill>
@@ -14608,7 +15037,7 @@
             <a:r>
               <a:rPr sz="1400" b="1">
                 <a:solidFill>
-                  <a:srgbClr val="D4AF37"/>
+                  <a:srgbClr val="FFFFFF"/>
                 </a:solidFill>
               </a:rPr>
               <a:t>7.  </a:t>
@@ -14639,7 +15068,7 @@
             <a:avLst/>
           </a:prstGeom>
           <a:solidFill>
-            <a:srgbClr val="132C52"/>
+            <a:srgbClr val="0EA5E9"/>
           </a:solidFill>
           <a:ln w="9525">
             <a:solidFill>
@@ -14670,7 +15099,7 @@
             <a:r>
               <a:rPr sz="1400" b="1">
                 <a:solidFill>
-                  <a:srgbClr val="D4AF37"/>
+                  <a:srgbClr val="FFFFFF"/>
                 </a:solidFill>
               </a:rPr>
               <a:t>8.  </a:t>
@@ -14701,7 +15130,7 @@
             <a:avLst/>
           </a:prstGeom>
           <a:solidFill>
-            <a:srgbClr val="132C52"/>
+            <a:srgbClr val="0EA5E9"/>
           </a:solidFill>
           <a:ln w="9525">
             <a:solidFill>
@@ -14732,7 +15161,7 @@
             <a:r>
               <a:rPr sz="1400" b="1">
                 <a:solidFill>
-                  <a:srgbClr val="D4AF37"/>
+                  <a:srgbClr val="FFFFFF"/>
                 </a:solidFill>
               </a:rPr>
               <a:t>9.  </a:t>
@@ -14763,7 +15192,7 @@
             <a:avLst/>
           </a:prstGeom>
           <a:solidFill>
-            <a:srgbClr val="132C52"/>
+            <a:srgbClr val="0EA5E9"/>
           </a:solidFill>
           <a:ln w="9525">
             <a:solidFill>
@@ -14794,7 +15223,7 @@
             <a:r>
               <a:rPr sz="1400" b="1">
                 <a:solidFill>
-                  <a:srgbClr val="D4AF37"/>
+                  <a:srgbClr val="FFFFFF"/>
                 </a:solidFill>
               </a:rPr>
               <a:t>10.  </a:t>
@@ -14843,6 +15272,30 @@
           <a:chExt cx="0" cy="0"/>
         </a:xfrm>
       </p:grpSpPr>
+      <p:pic>
+        <p:nvPicPr>
+          <p:cNvPr id="16" name="Picture 15" descr="bg_military_tech_169.png"/>
+          <p:cNvPicPr>
+            <a:picLocks noChangeAspect="1"/>
+          </p:cNvPicPr>
+          <p:nvPr/>
+        </p:nvPicPr>
+        <p:blipFill>
+          <a:blip r:embed="rId2"/>
+          <a:stretch>
+            <a:fillRect/>
+          </a:stretch>
+        </p:blipFill>
+        <p:spPr>
+          <a:xfrm>
+            <a:off x="0" y="0"/>
+            <a:ext cx="12192000" cy="6858000"/>
+          </a:xfrm>
+          <a:prstGeom prst="rect">
+            <a:avLst/>
+          </a:prstGeom>
+        </p:spPr>
+      </p:pic>
       <p:sp>
         <p:nvSpPr>
           <p:cNvPr id="2" name="Rectangle 1"/>
@@ -14858,7 +15311,7 @@
             <a:avLst/>
           </a:prstGeom>
           <a:solidFill>
-            <a:srgbClr val="132C52"/>
+            <a:srgbClr val="0EA5E9"/>
           </a:solidFill>
           <a:ln>
             <a:noFill/>
@@ -15143,7 +15596,7 @@
             <a:avLst/>
           </a:prstGeom>
           <a:solidFill>
-            <a:srgbClr val="132C52"/>
+            <a:srgbClr val="0EA5E9"/>
           </a:solidFill>
           <a:ln w="12700">
             <a:solidFill>
@@ -15174,7 +15627,7 @@
             <a:r>
               <a:rPr sz="2600" b="1">
                 <a:solidFill>
-                  <a:srgbClr val="D4AF37"/>
+                  <a:srgbClr val="FFFFFF"/>
                 </a:solidFill>
               </a:rPr>
               <a:t>1</a:t>
@@ -15196,7 +15649,7 @@
             <a:r>
               <a:rPr sz="1050">
                 <a:solidFill>
-                  <a:srgbClr val="E8EAEE"/>
+                  <a:srgbClr val="FFFFFF"/>
                 </a:solidFill>
               </a:rPr>
               <a:t>We share intelligence</a:t>
@@ -15219,7 +15672,7 @@
             <a:avLst/>
           </a:prstGeom>
           <a:solidFill>
-            <a:srgbClr val="132C52"/>
+            <a:srgbClr val="0EA5E9"/>
           </a:solidFill>
           <a:ln w="12700">
             <a:solidFill>
@@ -15250,7 +15703,7 @@
             <a:r>
               <a:rPr sz="2600" b="1">
                 <a:solidFill>
-                  <a:srgbClr val="D4AF37"/>
+                  <a:srgbClr val="FFFFFF"/>
                 </a:solidFill>
               </a:rPr>
               <a:t>2</a:t>
@@ -15272,7 +15725,7 @@
             <a:r>
               <a:rPr sz="1050">
                 <a:solidFill>
-                  <a:srgbClr val="E8EAEE"/>
+                  <a:srgbClr val="FFFFFF"/>
                 </a:solidFill>
               </a:rPr>
               <a:t>We listen to communities</a:t>
@@ -15295,7 +15748,7 @@
             <a:avLst/>
           </a:prstGeom>
           <a:solidFill>
-            <a:srgbClr val="132C52"/>
+            <a:srgbClr val="0EA5E9"/>
           </a:solidFill>
           <a:ln w="12700">
             <a:solidFill>
@@ -15326,7 +15779,7 @@
             <a:r>
               <a:rPr sz="2600" b="1">
                 <a:solidFill>
-                  <a:srgbClr val="D4AF37"/>
+                  <a:srgbClr val="FFFFFF"/>
                 </a:solidFill>
               </a:rPr>
               <a:t>3</a:t>
@@ -15348,7 +15801,7 @@
             <a:r>
               <a:rPr sz="1050">
                 <a:solidFill>
-                  <a:srgbClr val="E8EAEE"/>
+                  <a:srgbClr val="FFFFFF"/>
                 </a:solidFill>
               </a:rPr>
               <a:t>We respond before massacres</a:t>
@@ -15371,7 +15824,7 @@
             <a:avLst/>
           </a:prstGeom>
           <a:solidFill>
-            <a:srgbClr val="132C52"/>
+            <a:srgbClr val="0EA5E9"/>
           </a:solidFill>
           <a:ln w="12700">
             <a:solidFill>
@@ -15402,7 +15855,7 @@
             <a:r>
               <a:rPr sz="2600" b="1">
                 <a:solidFill>
-                  <a:srgbClr val="D4AF37"/>
+                  <a:srgbClr val="FFFFFF"/>
                 </a:solidFill>
               </a:rPr>
               <a:t>4</a:t>
@@ -15424,7 +15877,7 @@
             <a:r>
               <a:rPr sz="1050">
                 <a:solidFill>
-                  <a:srgbClr val="E8EAEE"/>
+                  <a:srgbClr val="FFFFFF"/>
                 </a:solidFill>
               </a:rPr>
               <a:t>Discipline, law, dignity</a:t>
@@ -15447,7 +15900,7 @@
             <a:avLst/>
           </a:prstGeom>
           <a:solidFill>
-            <a:srgbClr val="132C52"/>
+            <a:srgbClr val="0EA5E9"/>
           </a:solidFill>
           <a:ln w="12700">
             <a:solidFill>
@@ -15478,7 +15931,7 @@
             <a:r>
               <a:rPr sz="2600" b="1">
                 <a:solidFill>
-                  <a:srgbClr val="D4AF37"/>
+                  <a:srgbClr val="FFFFFF"/>
                 </a:solidFill>
               </a:rPr>
               <a:t>5</a:t>
@@ -15500,7 +15953,7 @@
             <a:r>
               <a:rPr sz="1050">
                 <a:solidFill>
-                  <a:srgbClr val="E8EAEE"/>
+                  <a:srgbClr val="FFFFFF"/>
                 </a:solidFill>
               </a:rPr>
               <a:t>No exploiting state boundaries</a:t>
@@ -15523,7 +15976,7 @@
             <a:avLst/>
           </a:prstGeom>
           <a:solidFill>
-            <a:srgbClr val="132C52"/>
+            <a:srgbClr val="0EA5E9"/>
           </a:solidFill>
           <a:ln w="12700">
             <a:solidFill>
@@ -15554,7 +16007,7 @@
             <a:r>
               <a:rPr sz="2600" b="1">
                 <a:solidFill>
-                  <a:srgbClr val="D4AF37"/>
+                  <a:srgbClr val="FFFFFF"/>
                 </a:solidFill>
               </a:rPr>
               <a:t>6</a:t>
@@ -15576,7 +16029,7 @@
             <a:r>
               <a:rPr sz="1050">
                 <a:solidFill>
-                  <a:srgbClr val="E8EAEE"/>
+                  <a:srgbClr val="FFFFFF"/>
                 </a:solidFill>
               </a:rPr>
               <a:t>Secure &amp; rebuild together</a:t>
@@ -15693,6 +16146,30 @@
           <a:chExt cx="0" cy="0"/>
         </a:xfrm>
       </p:grpSpPr>
+      <p:pic>
+        <p:nvPicPr>
+          <p:cNvPr id="11" name="Picture 10" descr="bg_military_tech_169.png"/>
+          <p:cNvPicPr>
+            <a:picLocks noChangeAspect="1"/>
+          </p:cNvPicPr>
+          <p:nvPr/>
+        </p:nvPicPr>
+        <p:blipFill>
+          <a:blip r:embed="rId2"/>
+          <a:stretch>
+            <a:fillRect/>
+          </a:stretch>
+        </p:blipFill>
+        <p:spPr>
+          <a:xfrm>
+            <a:off x="0" y="0"/>
+            <a:ext cx="12192000" cy="6858000"/>
+          </a:xfrm>
+          <a:prstGeom prst="rect">
+            <a:avLst/>
+          </a:prstGeom>
+        </p:spPr>
+      </p:pic>
       <p:sp>
         <p:nvSpPr>
           <p:cNvPr id="2" name="Rectangle 1"/>
@@ -15708,7 +16185,7 @@
             <a:avLst/>
           </a:prstGeom>
           <a:solidFill>
-            <a:srgbClr val="132C52"/>
+            <a:srgbClr val="0EA5E9"/>
           </a:solidFill>
           <a:ln>
             <a:noFill/>
@@ -16247,6 +16724,30 @@
           <a:chExt cx="0" cy="0"/>
         </a:xfrm>
       </p:grpSpPr>
+      <p:pic>
+        <p:nvPicPr>
+          <p:cNvPr id="24" name="Picture 23" descr="bg_military_tech_169.png"/>
+          <p:cNvPicPr>
+            <a:picLocks noChangeAspect="1"/>
+          </p:cNvPicPr>
+          <p:nvPr/>
+        </p:nvPicPr>
+        <p:blipFill>
+          <a:blip r:embed="rId2"/>
+          <a:stretch>
+            <a:fillRect/>
+          </a:stretch>
+        </p:blipFill>
+        <p:spPr>
+          <a:xfrm>
+            <a:off x="0" y="0"/>
+            <a:ext cx="12192000" cy="6858000"/>
+          </a:xfrm>
+          <a:prstGeom prst="rect">
+            <a:avLst/>
+          </a:prstGeom>
+        </p:spPr>
+      </p:pic>
       <p:sp>
         <p:nvSpPr>
           <p:cNvPr id="2" name="Rectangle 1"/>
@@ -16262,7 +16763,7 @@
             <a:avLst/>
           </a:prstGeom>
           <a:solidFill>
-            <a:srgbClr val="132C52"/>
+            <a:srgbClr val="0EA5E9"/>
           </a:solidFill>
           <a:ln>
             <a:noFill/>
@@ -17192,6 +17693,30 @@
       </p:grpSpPr>
       <p:pic>
         <p:nvPicPr>
+          <p:cNvPr id="7" name="Picture 6" descr="bg_military_tech_169.png"/>
+          <p:cNvPicPr>
+            <a:picLocks noChangeAspect="1"/>
+          </p:cNvPicPr>
+          <p:nvPr/>
+        </p:nvPicPr>
+        <p:blipFill>
+          <a:blip r:embed="rId3"/>
+          <a:stretch>
+            <a:fillRect/>
+          </a:stretch>
+        </p:blipFill>
+        <p:spPr>
+          <a:xfrm>
+            <a:off x="0" y="0"/>
+            <a:ext cx="12192000" cy="6858000"/>
+          </a:xfrm>
+          <a:prstGeom prst="rect">
+            <a:avLst/>
+          </a:prstGeom>
+        </p:spPr>
+      </p:pic>
+      <p:pic>
+        <p:nvPicPr>
           <p:cNvPr id="2" name="Picture 1" descr="closing_3d.png"/>
           <p:cNvPicPr>
             <a:picLocks noChangeAspect="1"/>
@@ -17216,6 +17741,51 @@
       </p:pic>
       <p:sp>
         <p:nvSpPr>
+          <p:cNvPr id="8" name="Rectangle 7"/>
+          <p:cNvSpPr/>
+          <p:nvPr/>
+        </p:nvSpPr>
+        <p:spPr>
+          <a:xfrm>
+            <a:off x="0" y="0"/>
+            <a:ext cx="12191695" cy="6858000"/>
+          </a:xfrm>
+          <a:prstGeom prst="rect">
+            <a:avLst/>
+          </a:prstGeom>
+          <a:solidFill>
+            <a:srgbClr val="F0F7FF">
+              <a:alpha val="60000"/>
+            </a:srgbClr>
+          </a:solidFill>
+          <a:ln>
+            <a:noFill/>
+          </a:ln>
+        </p:spPr>
+        <p:style>
+          <a:lnRef idx="1">
+            <a:schemeClr val="accent1"/>
+          </a:lnRef>
+          <a:fillRef idx="3">
+            <a:schemeClr val="accent1"/>
+          </a:fillRef>
+          <a:effectRef idx="2">
+            <a:schemeClr val="accent1"/>
+          </a:effectRef>
+          <a:fontRef idx="minor">
+            <a:schemeClr val="lt1"/>
+          </a:fontRef>
+        </p:style>
+        <p:txBody>
+          <a:bodyPr rtlCol="0" anchor="ctr"/>
+          <a:lstStyle/>
+          <a:p>
+            <a:pPr algn="ctr"/>
+          </a:p>
+        </p:txBody>
+      </p:sp>
+      <p:sp>
+        <p:nvSpPr>
           <p:cNvPr id="3" name="Rectangle 2"/>
           <p:cNvSpPr/>
           <p:nvPr/>
@@ -17229,7 +17799,7 @@
             <a:avLst/>
           </a:prstGeom>
           <a:solidFill>
-            <a:srgbClr val="0B1F3A">
+            <a:srgbClr val="0EA5E9">
               <a:alpha val="80000"/>
             </a:srgbClr>
           </a:solidFill>
@@ -17396,6 +17966,30 @@
         <p:nvPr/>
       </p:nvGrpSpPr>
       <p:grpSpPr/>
+      <p:pic>
+        <p:nvPicPr>
+          <p:cNvPr id="11" name="Picture 10" descr="bg_military_tech_169.png"/>
+          <p:cNvPicPr>
+            <a:picLocks noChangeAspect="1"/>
+          </p:cNvPicPr>
+          <p:nvPr/>
+        </p:nvPicPr>
+        <p:blipFill>
+          <a:blip r:embed="rId2"/>
+          <a:stretch>
+            <a:fillRect/>
+          </a:stretch>
+        </p:blipFill>
+        <p:spPr>
+          <a:xfrm>
+            <a:off x="0" y="0"/>
+            <a:ext cx="12192000" cy="6858000"/>
+          </a:xfrm>
+          <a:prstGeom prst="rect">
+            <a:avLst/>
+          </a:prstGeom>
+        </p:spPr>
+      </p:pic>
       <p:sp>
         <p:nvSpPr>
           <p:cNvPr id="2" name="Rectangle 1"/>
@@ -17411,7 +18005,7 @@
             <a:avLst/>
           </a:prstGeom>
           <a:solidFill>
-            <a:srgbClr val="132C52"/>
+            <a:srgbClr val="0EA5E9"/>
           </a:solidFill>
           <a:ln>
             <a:noFill/>
@@ -17848,6 +18442,30 @@
           <a:chExt cx="0" cy="0"/>
         </a:xfrm>
       </p:grpSpPr>
+      <p:pic>
+        <p:nvPicPr>
+          <p:cNvPr id="14" name="Picture 13" descr="bg_military_tech_169.png"/>
+          <p:cNvPicPr>
+            <a:picLocks noChangeAspect="1"/>
+          </p:cNvPicPr>
+          <p:nvPr/>
+        </p:nvPicPr>
+        <p:blipFill>
+          <a:blip r:embed="rId2"/>
+          <a:stretch>
+            <a:fillRect/>
+          </a:stretch>
+        </p:blipFill>
+        <p:spPr>
+          <a:xfrm>
+            <a:off x="0" y="0"/>
+            <a:ext cx="12192000" cy="6858000"/>
+          </a:xfrm>
+          <a:prstGeom prst="rect">
+            <a:avLst/>
+          </a:prstGeom>
+        </p:spPr>
+      </p:pic>
       <p:sp>
         <p:nvSpPr>
           <p:cNvPr id="2" name="Rectangle 1"/>
@@ -17863,7 +18481,7 @@
             <a:avLst/>
           </a:prstGeom>
           <a:solidFill>
-            <a:srgbClr val="132C52"/>
+            <a:srgbClr val="0EA5E9"/>
           </a:solidFill>
           <a:ln>
             <a:noFill/>
@@ -18324,7 +18942,7 @@
             <a:avLst/>
           </a:prstGeom>
           <a:solidFill>
-            <a:srgbClr val="132C52"/>
+            <a:srgbClr val="0EA5E9"/>
           </a:solidFill>
           <a:ln>
             <a:noFill/>
@@ -18384,7 +19002,7 @@
             <a:r>
               <a:rPr sz="2000" b="1" i="0">
                 <a:solidFill>
-                  <a:srgbClr val="D4AF37"/>
+                  <a:srgbClr val="FFFFFF"/>
                 </a:solidFill>
                 <a:latin typeface="Calibri"/>
               </a:rPr>
@@ -18473,6 +19091,30 @@
           <a:chExt cx="0" cy="0"/>
         </a:xfrm>
       </p:grpSpPr>
+      <p:pic>
+        <p:nvPicPr>
+          <p:cNvPr id="28" name="Picture 27" descr="bg_military_tech_169.png"/>
+          <p:cNvPicPr>
+            <a:picLocks noChangeAspect="1"/>
+          </p:cNvPicPr>
+          <p:nvPr/>
+        </p:nvPicPr>
+        <p:blipFill>
+          <a:blip r:embed="rId2"/>
+          <a:stretch>
+            <a:fillRect/>
+          </a:stretch>
+        </p:blipFill>
+        <p:spPr>
+          <a:xfrm>
+            <a:off x="0" y="0"/>
+            <a:ext cx="12192000" cy="6858000"/>
+          </a:xfrm>
+          <a:prstGeom prst="rect">
+            <a:avLst/>
+          </a:prstGeom>
+        </p:spPr>
+      </p:pic>
       <p:sp>
         <p:nvSpPr>
           <p:cNvPr id="2" name="Rectangle 1"/>
@@ -18488,7 +19130,7 @@
             <a:avLst/>
           </a:prstGeom>
           <a:solidFill>
-            <a:srgbClr val="132C52"/>
+            <a:srgbClr val="0EA5E9"/>
           </a:solidFill>
           <a:ln>
             <a:noFill/>
@@ -18773,7 +19415,7 @@
             <a:avLst/>
           </a:prstGeom>
           <a:solidFill>
-            <a:srgbClr val="132C52"/>
+            <a:srgbClr val="0EA5E9"/>
           </a:solidFill>
           <a:ln w="15875">
             <a:solidFill>
@@ -18873,7 +19515,7 @@
             <a:avLst/>
           </a:prstGeom>
           <a:solidFill>
-            <a:srgbClr val="132C52"/>
+            <a:srgbClr val="0EA5E9"/>
           </a:solidFill>
           <a:ln w="15875">
             <a:solidFill>
@@ -18973,7 +19615,7 @@
             <a:avLst/>
           </a:prstGeom>
           <a:solidFill>
-            <a:srgbClr val="132C52"/>
+            <a:srgbClr val="0EA5E9"/>
           </a:solidFill>
           <a:ln w="15875">
             <a:solidFill>
@@ -19073,7 +19715,7 @@
             <a:avLst/>
           </a:prstGeom>
           <a:solidFill>
-            <a:srgbClr val="132C52"/>
+            <a:srgbClr val="0EA5E9"/>
           </a:solidFill>
           <a:ln w="15875">
             <a:solidFill>
@@ -19173,7 +19815,7 @@
             <a:avLst/>
           </a:prstGeom>
           <a:solidFill>
-            <a:srgbClr val="132C52"/>
+            <a:srgbClr val="0EA5E9"/>
           </a:solidFill>
           <a:ln w="15875">
             <a:solidFill>
@@ -19273,7 +19915,7 @@
             <a:avLst/>
           </a:prstGeom>
           <a:solidFill>
-            <a:srgbClr val="132C52"/>
+            <a:srgbClr val="0EA5E9"/>
           </a:solidFill>
           <a:ln w="15875">
             <a:solidFill>
@@ -19373,7 +20015,7 @@
             <a:avLst/>
           </a:prstGeom>
           <a:solidFill>
-            <a:srgbClr val="132C52"/>
+            <a:srgbClr val="0EA5E9"/>
           </a:solidFill>
           <a:ln w="15875">
             <a:solidFill>
@@ -19511,7 +20153,7 @@
             <a:avLst/>
           </a:prstGeom>
           <a:solidFill>
-            <a:srgbClr val="132C52"/>
+            <a:srgbClr val="0EA5E9"/>
           </a:solidFill>
           <a:ln>
             <a:noFill/>
@@ -19597,7 +20239,7 @@
             <a:avLst/>
           </a:prstGeom>
           <a:solidFill>
-            <a:srgbClr val="132C52"/>
+            <a:srgbClr val="0EA5E9"/>
           </a:solidFill>
           <a:ln w="12700">
             <a:solidFill>
@@ -19706,6 +20348,30 @@
       </p:grpSpPr>
       <p:pic>
         <p:nvPicPr>
+          <p:cNvPr id="26" name="Picture 25" descr="bg_military_tech_169.png"/>
+          <p:cNvPicPr>
+            <a:picLocks noChangeAspect="1"/>
+          </p:cNvPicPr>
+          <p:nvPr/>
+        </p:nvPicPr>
+        <p:blipFill>
+          <a:blip r:embed="rId3"/>
+          <a:stretch>
+            <a:fillRect/>
+          </a:stretch>
+        </p:blipFill>
+        <p:spPr>
+          <a:xfrm>
+            <a:off x="0" y="0"/>
+            <a:ext cx="12192000" cy="6858000"/>
+          </a:xfrm>
+          <a:prstGeom prst="rect">
+            <a:avLst/>
+          </a:prstGeom>
+        </p:spPr>
+      </p:pic>
+      <p:pic>
+        <p:nvPicPr>
           <p:cNvPr id="2" name="Picture 1" descr="cycle_3d.png"/>
           <p:cNvPicPr>
             <a:picLocks noChangeAspect="1"/>
@@ -19730,6 +20396,51 @@
       </p:pic>
       <p:sp>
         <p:nvSpPr>
+          <p:cNvPr id="27" name="Rectangle 26"/>
+          <p:cNvSpPr/>
+          <p:nvPr/>
+        </p:nvSpPr>
+        <p:spPr>
+          <a:xfrm>
+            <a:off x="6675120" y="1051560"/>
+            <a:ext cx="5577840" cy="5577840"/>
+          </a:xfrm>
+          <a:prstGeom prst="rect">
+            <a:avLst/>
+          </a:prstGeom>
+          <a:solidFill>
+            <a:srgbClr val="F0F7FF">
+              <a:alpha val="70000"/>
+            </a:srgbClr>
+          </a:solidFill>
+          <a:ln>
+            <a:noFill/>
+          </a:ln>
+        </p:spPr>
+        <p:style>
+          <a:lnRef idx="1">
+            <a:schemeClr val="accent1"/>
+          </a:lnRef>
+          <a:fillRef idx="3">
+            <a:schemeClr val="accent1"/>
+          </a:fillRef>
+          <a:effectRef idx="2">
+            <a:schemeClr val="accent1"/>
+          </a:effectRef>
+          <a:fontRef idx="minor">
+            <a:schemeClr val="lt1"/>
+          </a:fontRef>
+        </p:style>
+        <p:txBody>
+          <a:bodyPr rtlCol="0" anchor="ctr"/>
+          <a:lstStyle/>
+          <a:p>
+            <a:pPr algn="ctr"/>
+          </a:p>
+        </p:txBody>
+      </p:sp>
+      <p:sp>
+        <p:nvSpPr>
           <p:cNvPr id="3" name="Rectangle 2"/>
           <p:cNvSpPr/>
           <p:nvPr/>
@@ -19743,7 +20454,7 @@
             <a:avLst/>
           </a:prstGeom>
           <a:solidFill>
-            <a:srgbClr val="132C52"/>
+            <a:srgbClr val="0EA5E9"/>
           </a:solidFill>
           <a:ln>
             <a:noFill/>
@@ -20701,6 +21412,30 @@
           <a:chExt cx="0" cy="0"/>
         </a:xfrm>
       </p:grpSpPr>
+      <p:pic>
+        <p:nvPicPr>
+          <p:cNvPr id="19" name="Picture 18" descr="bg_military_tech_169.png"/>
+          <p:cNvPicPr>
+            <a:picLocks noChangeAspect="1"/>
+          </p:cNvPicPr>
+          <p:nvPr/>
+        </p:nvPicPr>
+        <p:blipFill>
+          <a:blip r:embed="rId2"/>
+          <a:stretch>
+            <a:fillRect/>
+          </a:stretch>
+        </p:blipFill>
+        <p:spPr>
+          <a:xfrm>
+            <a:off x="0" y="0"/>
+            <a:ext cx="12192000" cy="6858000"/>
+          </a:xfrm>
+          <a:prstGeom prst="rect">
+            <a:avLst/>
+          </a:prstGeom>
+        </p:spPr>
+      </p:pic>
       <p:sp>
         <p:nvSpPr>
           <p:cNvPr id="2" name="Rectangle 1"/>
@@ -20716,7 +21451,7 @@
             <a:avLst/>
           </a:prstGeom>
           <a:solidFill>
-            <a:srgbClr val="132C52"/>
+            <a:srgbClr val="0EA5E9"/>
           </a:solidFill>
           <a:ln>
             <a:noFill/>
@@ -21001,7 +21736,7 @@
             <a:avLst/>
           </a:prstGeom>
           <a:solidFill>
-            <a:srgbClr val="132C52"/>
+            <a:srgbClr val="0EA5E9"/>
           </a:solidFill>
           <a:ln w="12700">
             <a:solidFill>
@@ -21056,7 +21791,7 @@
             <a:avLst/>
           </a:prstGeom>
           <a:solidFill>
-            <a:srgbClr val="132C52"/>
+            <a:srgbClr val="0EA5E9"/>
           </a:solidFill>
           <a:ln w="12700">
             <a:solidFill>
@@ -21111,7 +21846,7 @@
             <a:avLst/>
           </a:prstGeom>
           <a:solidFill>
-            <a:srgbClr val="132C52"/>
+            <a:srgbClr val="0EA5E9"/>
           </a:solidFill>
           <a:ln w="12700">
             <a:solidFill>
@@ -21165,7 +21900,7 @@
             <a:avLst/>
           </a:prstGeom>
           <a:solidFill>
-            <a:srgbClr val="132C52"/>
+            <a:srgbClr val="0EA5E9"/>
           </a:solidFill>
           <a:ln w="12700">
             <a:solidFill>
@@ -21219,7 +21954,7 @@
             <a:avLst/>
           </a:prstGeom>
           <a:solidFill>
-            <a:srgbClr val="132C52"/>
+            <a:srgbClr val="0EA5E9"/>
           </a:solidFill>
           <a:ln w="12700">
             <a:solidFill>
@@ -21274,7 +22009,7 @@
             <a:avLst/>
           </a:prstGeom>
           <a:solidFill>
-            <a:srgbClr val="132C52"/>
+            <a:srgbClr val="0EA5E9"/>
           </a:solidFill>
           <a:ln w="12700">
             <a:solidFill>
@@ -21330,7 +22065,7 @@
             <a:avLst/>
           </a:prstGeom>
           <a:solidFill>
-            <a:srgbClr val="132C52"/>
+            <a:srgbClr val="0EA5E9"/>
           </a:solidFill>
           <a:ln w="12700">
             <a:solidFill>
@@ -21385,7 +22120,7 @@
             <a:avLst/>
           </a:prstGeom>
           <a:solidFill>
-            <a:srgbClr val="132C52"/>
+            <a:srgbClr val="0EA5E9"/>
           </a:solidFill>
           <a:ln w="12700">
             <a:solidFill>
@@ -21440,7 +22175,7 @@
             <a:avLst/>
           </a:prstGeom>
           <a:solidFill>
-            <a:srgbClr val="132C52"/>
+            <a:srgbClr val="0EA5E9"/>
           </a:solidFill>
           <a:ln w="12700">
             <a:solidFill>
@@ -21554,6 +22289,30 @@
           <a:chExt cx="0" cy="0"/>
         </a:xfrm>
       </p:grpSpPr>
+      <p:pic>
+        <p:nvPicPr>
+          <p:cNvPr id="22" name="Picture 21" descr="bg_military_tech_169.png"/>
+          <p:cNvPicPr>
+            <a:picLocks noChangeAspect="1"/>
+          </p:cNvPicPr>
+          <p:nvPr/>
+        </p:nvPicPr>
+        <p:blipFill>
+          <a:blip r:embed="rId2"/>
+          <a:stretch>
+            <a:fillRect/>
+          </a:stretch>
+        </p:blipFill>
+        <p:spPr>
+          <a:xfrm>
+            <a:off x="0" y="0"/>
+            <a:ext cx="12192000" cy="6858000"/>
+          </a:xfrm>
+          <a:prstGeom prst="rect">
+            <a:avLst/>
+          </a:prstGeom>
+        </p:spPr>
+      </p:pic>
       <p:sp>
         <p:nvSpPr>
           <p:cNvPr id="2" name="Rectangle 1"/>
@@ -21569,7 +22328,7 @@
             <a:avLst/>
           </a:prstGeom>
           <a:solidFill>
-            <a:srgbClr val="132C52"/>
+            <a:srgbClr val="0EA5E9"/>
           </a:solidFill>
           <a:ln>
             <a:noFill/>
@@ -22309,7 +23068,7 @@
             <a:avLst/>
           </a:prstGeom>
           <a:solidFill>
-            <a:srgbClr val="132C52"/>
+            <a:srgbClr val="0EA5E9"/>
           </a:solidFill>
           <a:ln>
             <a:noFill/>
@@ -22548,6 +23307,30 @@
           <a:chExt cx="0" cy="0"/>
         </a:xfrm>
       </p:grpSpPr>
+      <p:pic>
+        <p:nvPicPr>
+          <p:cNvPr id="19" name="Picture 18" descr="bg_military_tech_169.png"/>
+          <p:cNvPicPr>
+            <a:picLocks noChangeAspect="1"/>
+          </p:cNvPicPr>
+          <p:nvPr/>
+        </p:nvPicPr>
+        <p:blipFill>
+          <a:blip r:embed="rId2"/>
+          <a:stretch>
+            <a:fillRect/>
+          </a:stretch>
+        </p:blipFill>
+        <p:spPr>
+          <a:xfrm>
+            <a:off x="0" y="0"/>
+            <a:ext cx="12192000" cy="6858000"/>
+          </a:xfrm>
+          <a:prstGeom prst="rect">
+            <a:avLst/>
+          </a:prstGeom>
+        </p:spPr>
+      </p:pic>
       <p:sp>
         <p:nvSpPr>
           <p:cNvPr id="2" name="Rectangle 1"/>
@@ -22563,7 +23346,7 @@
             <a:avLst/>
           </a:prstGeom>
           <a:solidFill>
-            <a:srgbClr val="132C52"/>
+            <a:srgbClr val="0EA5E9"/>
           </a:solidFill>
           <a:ln>
             <a:noFill/>
@@ -22887,7 +23670,7 @@
             <a:avLst/>
           </a:prstGeom>
           <a:solidFill>
-            <a:srgbClr val="132C52"/>
+            <a:srgbClr val="0EA5E9"/>
           </a:solidFill>
           <a:ln>
             <a:noFill/>
@@ -22992,7 +23775,7 @@
             <a:avLst/>
           </a:prstGeom>
           <a:solidFill>
-            <a:srgbClr val="132C52"/>
+            <a:srgbClr val="0EA5E9"/>
           </a:solidFill>
           <a:ln>
             <a:noFill/>
@@ -23098,7 +23881,7 @@
             <a:avLst/>
           </a:prstGeom>
           <a:solidFill>
-            <a:srgbClr val="132C52"/>
+            <a:srgbClr val="0EA5E9"/>
           </a:solidFill>
           <a:ln>
             <a:noFill/>
@@ -23204,7 +23987,7 @@
             <a:avLst/>
           </a:prstGeom>
           <a:solidFill>
-            <a:srgbClr val="132C52"/>
+            <a:srgbClr val="0EA5E9"/>
           </a:solidFill>
           <a:ln>
             <a:noFill/>
@@ -23257,7 +24040,7 @@
             <a:avLst/>
           </a:prstGeom>
           <a:solidFill>
-            <a:srgbClr val="132C52"/>
+            <a:srgbClr val="0EA5E9"/>
           </a:solidFill>
           <a:ln w="12700">
             <a:solidFill>
@@ -23364,6 +24147,30 @@
       </p:grpSpPr>
       <p:pic>
         <p:nvPicPr>
+          <p:cNvPr id="10" name="Picture 9" descr="bg_military_tech_169.png"/>
+          <p:cNvPicPr>
+            <a:picLocks noChangeAspect="1"/>
+          </p:cNvPicPr>
+          <p:nvPr/>
+        </p:nvPicPr>
+        <p:blipFill>
+          <a:blip r:embed="rId3"/>
+          <a:stretch>
+            <a:fillRect/>
+          </a:stretch>
+        </p:blipFill>
+        <p:spPr>
+          <a:xfrm>
+            <a:off x="0" y="0"/>
+            <a:ext cx="12192000" cy="6858000"/>
+          </a:xfrm>
+          <a:prstGeom prst="rect">
+            <a:avLst/>
+          </a:prstGeom>
+        </p:spPr>
+      </p:pic>
+      <p:pic>
+        <p:nvPicPr>
           <p:cNvPr id="2" name="Picture 1" descr="unity_3d.png"/>
           <p:cNvPicPr>
             <a:picLocks noChangeAspect="1"/>
@@ -23388,6 +24195,51 @@
       </p:pic>
       <p:sp>
         <p:nvSpPr>
+          <p:cNvPr id="11" name="Rectangle 10"/>
+          <p:cNvSpPr/>
+          <p:nvPr/>
+        </p:nvSpPr>
+        <p:spPr>
+          <a:xfrm>
+            <a:off x="0" y="0"/>
+            <a:ext cx="12191695" cy="6858000"/>
+          </a:xfrm>
+          <a:prstGeom prst="rect">
+            <a:avLst/>
+          </a:prstGeom>
+          <a:solidFill>
+            <a:srgbClr val="F0F7FF">
+              <a:alpha val="60000"/>
+            </a:srgbClr>
+          </a:solidFill>
+          <a:ln>
+            <a:noFill/>
+          </a:ln>
+        </p:spPr>
+        <p:style>
+          <a:lnRef idx="1">
+            <a:schemeClr val="accent1"/>
+          </a:lnRef>
+          <a:fillRef idx="3">
+            <a:schemeClr val="accent1"/>
+          </a:fillRef>
+          <a:effectRef idx="2">
+            <a:schemeClr val="accent1"/>
+          </a:effectRef>
+          <a:fontRef idx="minor">
+            <a:schemeClr val="lt1"/>
+          </a:fontRef>
+        </p:style>
+        <p:txBody>
+          <a:bodyPr rtlCol="0" anchor="ctr"/>
+          <a:lstStyle/>
+          <a:p>
+            <a:pPr algn="ctr"/>
+          </a:p>
+        </p:txBody>
+      </p:sp>
+      <p:sp>
+        <p:nvSpPr>
           <p:cNvPr id="3" name="Rectangle 2"/>
           <p:cNvSpPr/>
           <p:nvPr/>
@@ -23401,7 +24253,7 @@
             <a:avLst/>
           </a:prstGeom>
           <a:solidFill>
-            <a:srgbClr val="0B1F3A">
+            <a:srgbClr val="0EA5E9">
               <a:alpha val="85000"/>
             </a:srgbClr>
           </a:solidFill>
@@ -23487,7 +24339,7 @@
             <a:avLst/>
           </a:prstGeom>
           <a:solidFill>
-            <a:srgbClr val="0B1F3A">
+            <a:srgbClr val="0EA5E9">
               <a:alpha val="80000"/>
             </a:srgbClr>
           </a:solidFill>

</xml_diff>

<commit_message>
Add bold graphic elements: gold accent spine bar on left edge + bold numbered chip on every slide
</commit_message>
<xml_diff>
--- a/avm_morgan_docs/AVM_MORGAN_SECURITY_KEYNOTE_30MIN_v3_WITH_REFERENCES.pptx
+++ b/avm_morgan_docs/AVM_MORGAN_SECURITY_KEYNOTE_30MIN_v3_WITH_REFERENCES.pptx
@@ -3422,6 +3422,104 @@
           </a:p>
         </p:txBody>
       </p:sp>
+      <p:sp>
+        <p:nvSpPr>
+          <p:cNvPr id="10" name="Rectangle 9"/>
+          <p:cNvSpPr/>
+          <p:nvPr/>
+        </p:nvSpPr>
+        <p:spPr>
+          <a:xfrm>
+            <a:off x="0" y="0"/>
+            <a:ext cx="91440" cy="6858000"/>
+          </a:xfrm>
+          <a:prstGeom prst="rect">
+            <a:avLst/>
+          </a:prstGeom>
+          <a:solidFill>
+            <a:srgbClr val="D4AF37"/>
+          </a:solidFill>
+          <a:ln>
+            <a:noFill/>
+          </a:ln>
+          <a:effectLst/>
+        </p:spPr>
+        <p:style>
+          <a:lnRef idx="1">
+            <a:schemeClr val="accent1"/>
+          </a:lnRef>
+          <a:fillRef idx="3">
+            <a:schemeClr val="accent1"/>
+          </a:fillRef>
+          <a:effectRef idx="2">
+            <a:schemeClr val="accent1"/>
+          </a:effectRef>
+          <a:fontRef idx="minor">
+            <a:schemeClr val="lt1"/>
+          </a:fontRef>
+        </p:style>
+        <p:txBody>
+          <a:bodyPr rtlCol="0" anchor="ctr"/>
+          <a:lstStyle/>
+          <a:p>
+            <a:pPr algn="ctr"/>
+          </a:p>
+        </p:txBody>
+      </p:sp>
+      <p:sp>
+        <p:nvSpPr>
+          <p:cNvPr id="11" name="Rounded Rectangle 10"/>
+          <p:cNvSpPr/>
+          <p:nvPr/>
+        </p:nvSpPr>
+        <p:spPr>
+          <a:xfrm>
+            <a:off x="141440" y="6458000"/>
+            <a:ext cx="600000" cy="320000"/>
+          </a:xfrm>
+          <a:prstGeom prst="roundRect">
+            <a:avLst/>
+          </a:prstGeom>
+          <a:solidFill>
+            <a:srgbClr val="0EA5E9"/>
+          </a:solidFill>
+          <a:ln w="12700">
+            <a:solidFill>
+              <a:srgbClr val="D4AF37"/>
+            </a:solidFill>
+          </a:ln>
+          <a:effectLst/>
+        </p:spPr>
+        <p:style>
+          <a:lnRef idx="1">
+            <a:schemeClr val="accent1"/>
+          </a:lnRef>
+          <a:fillRef idx="3">
+            <a:schemeClr val="accent1"/>
+          </a:fillRef>
+          <a:effectRef idx="2">
+            <a:schemeClr val="accent1"/>
+          </a:effectRef>
+          <a:fontRef idx="minor">
+            <a:schemeClr val="lt1"/>
+          </a:fontRef>
+        </p:style>
+        <p:txBody>
+          <a:bodyPr rtlCol="0" anchor="ctr" lIns="0" rIns="0" tIns="0" bIns="0"/>
+          <a:lstStyle/>
+          <a:p>
+            <a:pPr algn="ctr"/>
+            <a:r>
+              <a:rPr b="1" sz="1400">
+                <a:solidFill>
+                  <a:srgbClr val="FFFFFF"/>
+                </a:solidFill>
+              </a:rPr>
+              <a:t>01</a:t>
+            </a:r>
+          </a:p>
+        </p:txBody>
+      </p:sp>
     </p:spTree>
   </p:cSld>
   <p:clrMapOvr>
@@ -4470,6 +4568,104 @@
           </a:p>
         </p:txBody>
       </p:sp>
+      <p:sp>
+        <p:nvSpPr>
+          <p:cNvPr id="25" name="Rectangle 24"/>
+          <p:cNvSpPr/>
+          <p:nvPr/>
+        </p:nvSpPr>
+        <p:spPr>
+          <a:xfrm>
+            <a:off x="0" y="0"/>
+            <a:ext cx="91440" cy="6858000"/>
+          </a:xfrm>
+          <a:prstGeom prst="rect">
+            <a:avLst/>
+          </a:prstGeom>
+          <a:solidFill>
+            <a:srgbClr val="D4AF37"/>
+          </a:solidFill>
+          <a:ln>
+            <a:noFill/>
+          </a:ln>
+          <a:effectLst/>
+        </p:spPr>
+        <p:style>
+          <a:lnRef idx="1">
+            <a:schemeClr val="accent1"/>
+          </a:lnRef>
+          <a:fillRef idx="3">
+            <a:schemeClr val="accent1"/>
+          </a:fillRef>
+          <a:effectRef idx="2">
+            <a:schemeClr val="accent1"/>
+          </a:effectRef>
+          <a:fontRef idx="minor">
+            <a:schemeClr val="lt1"/>
+          </a:fontRef>
+        </p:style>
+        <p:txBody>
+          <a:bodyPr rtlCol="0" anchor="ctr"/>
+          <a:lstStyle/>
+          <a:p>
+            <a:pPr algn="ctr"/>
+          </a:p>
+        </p:txBody>
+      </p:sp>
+      <p:sp>
+        <p:nvSpPr>
+          <p:cNvPr id="26" name="Rounded Rectangle 25"/>
+          <p:cNvSpPr/>
+          <p:nvPr/>
+        </p:nvSpPr>
+        <p:spPr>
+          <a:xfrm>
+            <a:off x="141440" y="6458000"/>
+            <a:ext cx="600000" cy="320000"/>
+          </a:xfrm>
+          <a:prstGeom prst="roundRect">
+            <a:avLst/>
+          </a:prstGeom>
+          <a:solidFill>
+            <a:srgbClr val="0EA5E9"/>
+          </a:solidFill>
+          <a:ln w="12700">
+            <a:solidFill>
+              <a:srgbClr val="D4AF37"/>
+            </a:solidFill>
+          </a:ln>
+          <a:effectLst/>
+        </p:spPr>
+        <p:style>
+          <a:lnRef idx="1">
+            <a:schemeClr val="accent1"/>
+          </a:lnRef>
+          <a:fillRef idx="3">
+            <a:schemeClr val="accent1"/>
+          </a:fillRef>
+          <a:effectRef idx="2">
+            <a:schemeClr val="accent1"/>
+          </a:effectRef>
+          <a:fontRef idx="minor">
+            <a:schemeClr val="lt1"/>
+          </a:fontRef>
+        </p:style>
+        <p:txBody>
+          <a:bodyPr rtlCol="0" anchor="ctr" lIns="0" rIns="0" tIns="0" bIns="0"/>
+          <a:lstStyle/>
+          <a:p>
+            <a:pPr algn="ctr"/>
+            <a:r>
+              <a:rPr b="1" sz="1400">
+                <a:solidFill>
+                  <a:srgbClr val="FFFFFF"/>
+                </a:solidFill>
+              </a:rPr>
+              <a:t>10</a:t>
+            </a:r>
+          </a:p>
+        </p:txBody>
+      </p:sp>
     </p:spTree>
   </p:cSld>
   <p:clrMapOvr>
@@ -5214,6 +5410,104 @@
           </a:p>
         </p:txBody>
       </p:sp>
+      <p:sp>
+        <p:nvSpPr>
+          <p:cNvPr id="18" name="Rectangle 17"/>
+          <p:cNvSpPr/>
+          <p:nvPr/>
+        </p:nvSpPr>
+        <p:spPr>
+          <a:xfrm>
+            <a:off x="0" y="0"/>
+            <a:ext cx="91440" cy="6858000"/>
+          </a:xfrm>
+          <a:prstGeom prst="rect">
+            <a:avLst/>
+          </a:prstGeom>
+          <a:solidFill>
+            <a:srgbClr val="D4AF37"/>
+          </a:solidFill>
+          <a:ln>
+            <a:noFill/>
+          </a:ln>
+          <a:effectLst/>
+        </p:spPr>
+        <p:style>
+          <a:lnRef idx="1">
+            <a:schemeClr val="accent1"/>
+          </a:lnRef>
+          <a:fillRef idx="3">
+            <a:schemeClr val="accent1"/>
+          </a:fillRef>
+          <a:effectRef idx="2">
+            <a:schemeClr val="accent1"/>
+          </a:effectRef>
+          <a:fontRef idx="minor">
+            <a:schemeClr val="lt1"/>
+          </a:fontRef>
+        </p:style>
+        <p:txBody>
+          <a:bodyPr rtlCol="0" anchor="ctr"/>
+          <a:lstStyle/>
+          <a:p>
+            <a:pPr algn="ctr"/>
+          </a:p>
+        </p:txBody>
+      </p:sp>
+      <p:sp>
+        <p:nvSpPr>
+          <p:cNvPr id="19" name="Rounded Rectangle 18"/>
+          <p:cNvSpPr/>
+          <p:nvPr/>
+        </p:nvSpPr>
+        <p:spPr>
+          <a:xfrm>
+            <a:off x="141440" y="6458000"/>
+            <a:ext cx="600000" cy="320000"/>
+          </a:xfrm>
+          <a:prstGeom prst="roundRect">
+            <a:avLst/>
+          </a:prstGeom>
+          <a:solidFill>
+            <a:srgbClr val="0EA5E9"/>
+          </a:solidFill>
+          <a:ln w="12700">
+            <a:solidFill>
+              <a:srgbClr val="D4AF37"/>
+            </a:solidFill>
+          </a:ln>
+          <a:effectLst/>
+        </p:spPr>
+        <p:style>
+          <a:lnRef idx="1">
+            <a:schemeClr val="accent1"/>
+          </a:lnRef>
+          <a:fillRef idx="3">
+            <a:schemeClr val="accent1"/>
+          </a:fillRef>
+          <a:effectRef idx="2">
+            <a:schemeClr val="accent1"/>
+          </a:effectRef>
+          <a:fontRef idx="minor">
+            <a:schemeClr val="lt1"/>
+          </a:fontRef>
+        </p:style>
+        <p:txBody>
+          <a:bodyPr rtlCol="0" anchor="ctr" lIns="0" rIns="0" tIns="0" bIns="0"/>
+          <a:lstStyle/>
+          <a:p>
+            <a:pPr algn="ctr"/>
+            <a:r>
+              <a:rPr b="1" sz="1400">
+                <a:solidFill>
+                  <a:srgbClr val="FFFFFF"/>
+                </a:solidFill>
+              </a:rPr>
+              <a:t>11</a:t>
+            </a:r>
+          </a:p>
+        </p:txBody>
+      </p:sp>
     </p:spTree>
   </p:cSld>
   <p:clrMapOvr>
@@ -5878,6 +6172,104 @@
           </a:p>
         </p:txBody>
       </p:sp>
+      <p:sp>
+        <p:nvSpPr>
+          <p:cNvPr id="15" name="Rectangle 14"/>
+          <p:cNvSpPr/>
+          <p:nvPr/>
+        </p:nvSpPr>
+        <p:spPr>
+          <a:xfrm>
+            <a:off x="0" y="0"/>
+            <a:ext cx="91440" cy="6858000"/>
+          </a:xfrm>
+          <a:prstGeom prst="rect">
+            <a:avLst/>
+          </a:prstGeom>
+          <a:solidFill>
+            <a:srgbClr val="D4AF37"/>
+          </a:solidFill>
+          <a:ln>
+            <a:noFill/>
+          </a:ln>
+          <a:effectLst/>
+        </p:spPr>
+        <p:style>
+          <a:lnRef idx="1">
+            <a:schemeClr val="accent1"/>
+          </a:lnRef>
+          <a:fillRef idx="3">
+            <a:schemeClr val="accent1"/>
+          </a:fillRef>
+          <a:effectRef idx="2">
+            <a:schemeClr val="accent1"/>
+          </a:effectRef>
+          <a:fontRef idx="minor">
+            <a:schemeClr val="lt1"/>
+          </a:fontRef>
+        </p:style>
+        <p:txBody>
+          <a:bodyPr rtlCol="0" anchor="ctr"/>
+          <a:lstStyle/>
+          <a:p>
+            <a:pPr algn="ctr"/>
+          </a:p>
+        </p:txBody>
+      </p:sp>
+      <p:sp>
+        <p:nvSpPr>
+          <p:cNvPr id="16" name="Rounded Rectangle 15"/>
+          <p:cNvSpPr/>
+          <p:nvPr/>
+        </p:nvSpPr>
+        <p:spPr>
+          <a:xfrm>
+            <a:off x="141440" y="6458000"/>
+            <a:ext cx="600000" cy="320000"/>
+          </a:xfrm>
+          <a:prstGeom prst="roundRect">
+            <a:avLst/>
+          </a:prstGeom>
+          <a:solidFill>
+            <a:srgbClr val="0EA5E9"/>
+          </a:solidFill>
+          <a:ln w="12700">
+            <a:solidFill>
+              <a:srgbClr val="D4AF37"/>
+            </a:solidFill>
+          </a:ln>
+          <a:effectLst/>
+        </p:spPr>
+        <p:style>
+          <a:lnRef idx="1">
+            <a:schemeClr val="accent1"/>
+          </a:lnRef>
+          <a:fillRef idx="3">
+            <a:schemeClr val="accent1"/>
+          </a:fillRef>
+          <a:effectRef idx="2">
+            <a:schemeClr val="accent1"/>
+          </a:effectRef>
+          <a:fontRef idx="minor">
+            <a:schemeClr val="lt1"/>
+          </a:fontRef>
+        </p:style>
+        <p:txBody>
+          <a:bodyPr rtlCol="0" anchor="ctr" lIns="0" rIns="0" tIns="0" bIns="0"/>
+          <a:lstStyle/>
+          <a:p>
+            <a:pPr algn="ctr"/>
+            <a:r>
+              <a:rPr b="1" sz="1400">
+                <a:solidFill>
+                  <a:srgbClr val="FFFFFF"/>
+                </a:solidFill>
+              </a:rPr>
+              <a:t>12</a:t>
+            </a:r>
+          </a:p>
+        </p:txBody>
+      </p:sp>
     </p:spTree>
   </p:cSld>
   <p:clrMapOvr>
@@ -6754,6 +7146,104 @@
           </a:p>
         </p:txBody>
       </p:sp>
+      <p:sp>
+        <p:nvSpPr>
+          <p:cNvPr id="20" name="Rectangle 19"/>
+          <p:cNvSpPr/>
+          <p:nvPr/>
+        </p:nvSpPr>
+        <p:spPr>
+          <a:xfrm>
+            <a:off x="0" y="0"/>
+            <a:ext cx="91440" cy="6858000"/>
+          </a:xfrm>
+          <a:prstGeom prst="rect">
+            <a:avLst/>
+          </a:prstGeom>
+          <a:solidFill>
+            <a:srgbClr val="D4AF37"/>
+          </a:solidFill>
+          <a:ln>
+            <a:noFill/>
+          </a:ln>
+          <a:effectLst/>
+        </p:spPr>
+        <p:style>
+          <a:lnRef idx="1">
+            <a:schemeClr val="accent1"/>
+          </a:lnRef>
+          <a:fillRef idx="3">
+            <a:schemeClr val="accent1"/>
+          </a:fillRef>
+          <a:effectRef idx="2">
+            <a:schemeClr val="accent1"/>
+          </a:effectRef>
+          <a:fontRef idx="minor">
+            <a:schemeClr val="lt1"/>
+          </a:fontRef>
+        </p:style>
+        <p:txBody>
+          <a:bodyPr rtlCol="0" anchor="ctr"/>
+          <a:lstStyle/>
+          <a:p>
+            <a:pPr algn="ctr"/>
+          </a:p>
+        </p:txBody>
+      </p:sp>
+      <p:sp>
+        <p:nvSpPr>
+          <p:cNvPr id="21" name="Rounded Rectangle 20"/>
+          <p:cNvSpPr/>
+          <p:nvPr/>
+        </p:nvSpPr>
+        <p:spPr>
+          <a:xfrm>
+            <a:off x="141440" y="6458000"/>
+            <a:ext cx="600000" cy="320000"/>
+          </a:xfrm>
+          <a:prstGeom prst="roundRect">
+            <a:avLst/>
+          </a:prstGeom>
+          <a:solidFill>
+            <a:srgbClr val="0EA5E9"/>
+          </a:solidFill>
+          <a:ln w="12700">
+            <a:solidFill>
+              <a:srgbClr val="D4AF37"/>
+            </a:solidFill>
+          </a:ln>
+          <a:effectLst/>
+        </p:spPr>
+        <p:style>
+          <a:lnRef idx="1">
+            <a:schemeClr val="accent1"/>
+          </a:lnRef>
+          <a:fillRef idx="3">
+            <a:schemeClr val="accent1"/>
+          </a:fillRef>
+          <a:effectRef idx="2">
+            <a:schemeClr val="accent1"/>
+          </a:effectRef>
+          <a:fontRef idx="minor">
+            <a:schemeClr val="lt1"/>
+          </a:fontRef>
+        </p:style>
+        <p:txBody>
+          <a:bodyPr rtlCol="0" anchor="ctr" lIns="0" rIns="0" tIns="0" bIns="0"/>
+          <a:lstStyle/>
+          <a:p>
+            <a:pPr algn="ctr"/>
+            <a:r>
+              <a:rPr b="1" sz="1400">
+                <a:solidFill>
+                  <a:srgbClr val="FFFFFF"/>
+                </a:solidFill>
+              </a:rPr>
+              <a:t>13</a:t>
+            </a:r>
+          </a:p>
+        </p:txBody>
+      </p:sp>
     </p:spTree>
   </p:cSld>
   <p:clrMapOvr>
@@ -7344,6 +7834,104 @@
           </a:p>
         </p:txBody>
       </p:sp>
+      <p:sp>
+        <p:nvSpPr>
+          <p:cNvPr id="15" name="Rectangle 14"/>
+          <p:cNvSpPr/>
+          <p:nvPr/>
+        </p:nvSpPr>
+        <p:spPr>
+          <a:xfrm>
+            <a:off x="0" y="0"/>
+            <a:ext cx="91440" cy="6858000"/>
+          </a:xfrm>
+          <a:prstGeom prst="rect">
+            <a:avLst/>
+          </a:prstGeom>
+          <a:solidFill>
+            <a:srgbClr val="D4AF37"/>
+          </a:solidFill>
+          <a:ln>
+            <a:noFill/>
+          </a:ln>
+          <a:effectLst/>
+        </p:spPr>
+        <p:style>
+          <a:lnRef idx="1">
+            <a:schemeClr val="accent1"/>
+          </a:lnRef>
+          <a:fillRef idx="3">
+            <a:schemeClr val="accent1"/>
+          </a:fillRef>
+          <a:effectRef idx="2">
+            <a:schemeClr val="accent1"/>
+          </a:effectRef>
+          <a:fontRef idx="minor">
+            <a:schemeClr val="lt1"/>
+          </a:fontRef>
+        </p:style>
+        <p:txBody>
+          <a:bodyPr rtlCol="0" anchor="ctr"/>
+          <a:lstStyle/>
+          <a:p>
+            <a:pPr algn="ctr"/>
+          </a:p>
+        </p:txBody>
+      </p:sp>
+      <p:sp>
+        <p:nvSpPr>
+          <p:cNvPr id="16" name="Rounded Rectangle 15"/>
+          <p:cNvSpPr/>
+          <p:nvPr/>
+        </p:nvSpPr>
+        <p:spPr>
+          <a:xfrm>
+            <a:off x="141440" y="6458000"/>
+            <a:ext cx="600000" cy="320000"/>
+          </a:xfrm>
+          <a:prstGeom prst="roundRect">
+            <a:avLst/>
+          </a:prstGeom>
+          <a:solidFill>
+            <a:srgbClr val="0EA5E9"/>
+          </a:solidFill>
+          <a:ln w="12700">
+            <a:solidFill>
+              <a:srgbClr val="D4AF37"/>
+            </a:solidFill>
+          </a:ln>
+          <a:effectLst/>
+        </p:spPr>
+        <p:style>
+          <a:lnRef idx="1">
+            <a:schemeClr val="accent1"/>
+          </a:lnRef>
+          <a:fillRef idx="3">
+            <a:schemeClr val="accent1"/>
+          </a:fillRef>
+          <a:effectRef idx="2">
+            <a:schemeClr val="accent1"/>
+          </a:effectRef>
+          <a:fontRef idx="minor">
+            <a:schemeClr val="lt1"/>
+          </a:fontRef>
+        </p:style>
+        <p:txBody>
+          <a:bodyPr rtlCol="0" anchor="ctr" lIns="0" rIns="0" tIns="0" bIns="0"/>
+          <a:lstStyle/>
+          <a:p>
+            <a:pPr algn="ctr"/>
+            <a:r>
+              <a:rPr b="1" sz="1400">
+                <a:solidFill>
+                  <a:srgbClr val="FFFFFF"/>
+                </a:solidFill>
+              </a:rPr>
+              <a:t>14</a:t>
+            </a:r>
+          </a:p>
+        </p:txBody>
+      </p:sp>
     </p:spTree>
   </p:cSld>
   <p:clrMapOvr>
@@ -8427,6 +9015,104 @@
           </a:p>
         </p:txBody>
       </p:sp>
+      <p:sp>
+        <p:nvSpPr>
+          <p:cNvPr id="29" name="Rectangle 28"/>
+          <p:cNvSpPr/>
+          <p:nvPr/>
+        </p:nvSpPr>
+        <p:spPr>
+          <a:xfrm>
+            <a:off x="0" y="0"/>
+            <a:ext cx="91440" cy="6858000"/>
+          </a:xfrm>
+          <a:prstGeom prst="rect">
+            <a:avLst/>
+          </a:prstGeom>
+          <a:solidFill>
+            <a:srgbClr val="D4AF37"/>
+          </a:solidFill>
+          <a:ln>
+            <a:noFill/>
+          </a:ln>
+          <a:effectLst/>
+        </p:spPr>
+        <p:style>
+          <a:lnRef idx="1">
+            <a:schemeClr val="accent1"/>
+          </a:lnRef>
+          <a:fillRef idx="3">
+            <a:schemeClr val="accent1"/>
+          </a:fillRef>
+          <a:effectRef idx="2">
+            <a:schemeClr val="accent1"/>
+          </a:effectRef>
+          <a:fontRef idx="minor">
+            <a:schemeClr val="lt1"/>
+          </a:fontRef>
+        </p:style>
+        <p:txBody>
+          <a:bodyPr rtlCol="0" anchor="ctr"/>
+          <a:lstStyle/>
+          <a:p>
+            <a:pPr algn="ctr"/>
+          </a:p>
+        </p:txBody>
+      </p:sp>
+      <p:sp>
+        <p:nvSpPr>
+          <p:cNvPr id="30" name="Rounded Rectangle 29"/>
+          <p:cNvSpPr/>
+          <p:nvPr/>
+        </p:nvSpPr>
+        <p:spPr>
+          <a:xfrm>
+            <a:off x="141440" y="6458000"/>
+            <a:ext cx="600000" cy="320000"/>
+          </a:xfrm>
+          <a:prstGeom prst="roundRect">
+            <a:avLst/>
+          </a:prstGeom>
+          <a:solidFill>
+            <a:srgbClr val="0EA5E9"/>
+          </a:solidFill>
+          <a:ln w="12700">
+            <a:solidFill>
+              <a:srgbClr val="D4AF37"/>
+            </a:solidFill>
+          </a:ln>
+          <a:effectLst/>
+        </p:spPr>
+        <p:style>
+          <a:lnRef idx="1">
+            <a:schemeClr val="accent1"/>
+          </a:lnRef>
+          <a:fillRef idx="3">
+            <a:schemeClr val="accent1"/>
+          </a:fillRef>
+          <a:effectRef idx="2">
+            <a:schemeClr val="accent1"/>
+          </a:effectRef>
+          <a:fontRef idx="minor">
+            <a:schemeClr val="lt1"/>
+          </a:fontRef>
+        </p:style>
+        <p:txBody>
+          <a:bodyPr rtlCol="0" anchor="ctr" lIns="0" rIns="0" tIns="0" bIns="0"/>
+          <a:lstStyle/>
+          <a:p>
+            <a:pPr algn="ctr"/>
+            <a:r>
+              <a:rPr b="1" sz="1400">
+                <a:solidFill>
+                  <a:srgbClr val="FFFFFF"/>
+                </a:solidFill>
+              </a:rPr>
+              <a:t>15</a:t>
+            </a:r>
+          </a:p>
+        </p:txBody>
+      </p:sp>
     </p:spTree>
   </p:cSld>
   <p:clrMapOvr>
@@ -9329,6 +10015,104 @@
           </a:p>
         </p:txBody>
       </p:sp>
+      <p:sp>
+        <p:nvSpPr>
+          <p:cNvPr id="21" name="Rectangle 20"/>
+          <p:cNvSpPr/>
+          <p:nvPr/>
+        </p:nvSpPr>
+        <p:spPr>
+          <a:xfrm>
+            <a:off x="0" y="0"/>
+            <a:ext cx="91440" cy="6858000"/>
+          </a:xfrm>
+          <a:prstGeom prst="rect">
+            <a:avLst/>
+          </a:prstGeom>
+          <a:solidFill>
+            <a:srgbClr val="D4AF37"/>
+          </a:solidFill>
+          <a:ln>
+            <a:noFill/>
+          </a:ln>
+          <a:effectLst/>
+        </p:spPr>
+        <p:style>
+          <a:lnRef idx="1">
+            <a:schemeClr val="accent1"/>
+          </a:lnRef>
+          <a:fillRef idx="3">
+            <a:schemeClr val="accent1"/>
+          </a:fillRef>
+          <a:effectRef idx="2">
+            <a:schemeClr val="accent1"/>
+          </a:effectRef>
+          <a:fontRef idx="minor">
+            <a:schemeClr val="lt1"/>
+          </a:fontRef>
+        </p:style>
+        <p:txBody>
+          <a:bodyPr rtlCol="0" anchor="ctr"/>
+          <a:lstStyle/>
+          <a:p>
+            <a:pPr algn="ctr"/>
+          </a:p>
+        </p:txBody>
+      </p:sp>
+      <p:sp>
+        <p:nvSpPr>
+          <p:cNvPr id="22" name="Rounded Rectangle 21"/>
+          <p:cNvSpPr/>
+          <p:nvPr/>
+        </p:nvSpPr>
+        <p:spPr>
+          <a:xfrm>
+            <a:off x="141440" y="6458000"/>
+            <a:ext cx="600000" cy="320000"/>
+          </a:xfrm>
+          <a:prstGeom prst="roundRect">
+            <a:avLst/>
+          </a:prstGeom>
+          <a:solidFill>
+            <a:srgbClr val="0EA5E9"/>
+          </a:solidFill>
+          <a:ln w="12700">
+            <a:solidFill>
+              <a:srgbClr val="D4AF37"/>
+            </a:solidFill>
+          </a:ln>
+          <a:effectLst/>
+        </p:spPr>
+        <p:style>
+          <a:lnRef idx="1">
+            <a:schemeClr val="accent1"/>
+          </a:lnRef>
+          <a:fillRef idx="3">
+            <a:schemeClr val="accent1"/>
+          </a:fillRef>
+          <a:effectRef idx="2">
+            <a:schemeClr val="accent1"/>
+          </a:effectRef>
+          <a:fontRef idx="minor">
+            <a:schemeClr val="lt1"/>
+          </a:fontRef>
+        </p:style>
+        <p:txBody>
+          <a:bodyPr rtlCol="0" anchor="ctr" lIns="0" rIns="0" tIns="0" bIns="0"/>
+          <a:lstStyle/>
+          <a:p>
+            <a:pPr algn="ctr"/>
+            <a:r>
+              <a:rPr b="1" sz="1400">
+                <a:solidFill>
+                  <a:srgbClr val="FFFFFF"/>
+                </a:solidFill>
+              </a:rPr>
+              <a:t>16</a:t>
+            </a:r>
+          </a:p>
+        </p:txBody>
+      </p:sp>
     </p:spTree>
   </p:cSld>
   <p:clrMapOvr>
@@ -10182,6 +10966,104 @@
           </a:p>
         </p:txBody>
       </p:sp>
+      <p:sp>
+        <p:nvSpPr>
+          <p:cNvPr id="20" name="Rectangle 19"/>
+          <p:cNvSpPr/>
+          <p:nvPr/>
+        </p:nvSpPr>
+        <p:spPr>
+          <a:xfrm>
+            <a:off x="0" y="0"/>
+            <a:ext cx="91440" cy="6858000"/>
+          </a:xfrm>
+          <a:prstGeom prst="rect">
+            <a:avLst/>
+          </a:prstGeom>
+          <a:solidFill>
+            <a:srgbClr val="D4AF37"/>
+          </a:solidFill>
+          <a:ln>
+            <a:noFill/>
+          </a:ln>
+          <a:effectLst/>
+        </p:spPr>
+        <p:style>
+          <a:lnRef idx="1">
+            <a:schemeClr val="accent1"/>
+          </a:lnRef>
+          <a:fillRef idx="3">
+            <a:schemeClr val="accent1"/>
+          </a:fillRef>
+          <a:effectRef idx="2">
+            <a:schemeClr val="accent1"/>
+          </a:effectRef>
+          <a:fontRef idx="minor">
+            <a:schemeClr val="lt1"/>
+          </a:fontRef>
+        </p:style>
+        <p:txBody>
+          <a:bodyPr rtlCol="0" anchor="ctr"/>
+          <a:lstStyle/>
+          <a:p>
+            <a:pPr algn="ctr"/>
+          </a:p>
+        </p:txBody>
+      </p:sp>
+      <p:sp>
+        <p:nvSpPr>
+          <p:cNvPr id="21" name="Rounded Rectangle 20"/>
+          <p:cNvSpPr/>
+          <p:nvPr/>
+        </p:nvSpPr>
+        <p:spPr>
+          <a:xfrm>
+            <a:off x="141440" y="6458000"/>
+            <a:ext cx="600000" cy="320000"/>
+          </a:xfrm>
+          <a:prstGeom prst="roundRect">
+            <a:avLst/>
+          </a:prstGeom>
+          <a:solidFill>
+            <a:srgbClr val="0EA5E9"/>
+          </a:solidFill>
+          <a:ln w="12700">
+            <a:solidFill>
+              <a:srgbClr val="D4AF37"/>
+            </a:solidFill>
+          </a:ln>
+          <a:effectLst/>
+        </p:spPr>
+        <p:style>
+          <a:lnRef idx="1">
+            <a:schemeClr val="accent1"/>
+          </a:lnRef>
+          <a:fillRef idx="3">
+            <a:schemeClr val="accent1"/>
+          </a:fillRef>
+          <a:effectRef idx="2">
+            <a:schemeClr val="accent1"/>
+          </a:effectRef>
+          <a:fontRef idx="minor">
+            <a:schemeClr val="lt1"/>
+          </a:fontRef>
+        </p:style>
+        <p:txBody>
+          <a:bodyPr rtlCol="0" anchor="ctr" lIns="0" rIns="0" tIns="0" bIns="0"/>
+          <a:lstStyle/>
+          <a:p>
+            <a:pPr algn="ctr"/>
+            <a:r>
+              <a:rPr b="1" sz="1400">
+                <a:solidFill>
+                  <a:srgbClr val="FFFFFF"/>
+                </a:solidFill>
+              </a:rPr>
+              <a:t>17</a:t>
+            </a:r>
+          </a:p>
+        </p:txBody>
+      </p:sp>
     </p:spTree>
   </p:cSld>
   <p:clrMapOvr>
@@ -10928,6 +11810,104 @@
           </a:p>
         </p:txBody>
       </p:sp>
+      <p:sp>
+        <p:nvSpPr>
+          <p:cNvPr id="16" name="Rectangle 15"/>
+          <p:cNvSpPr/>
+          <p:nvPr/>
+        </p:nvSpPr>
+        <p:spPr>
+          <a:xfrm>
+            <a:off x="0" y="0"/>
+            <a:ext cx="91440" cy="6858000"/>
+          </a:xfrm>
+          <a:prstGeom prst="rect">
+            <a:avLst/>
+          </a:prstGeom>
+          <a:solidFill>
+            <a:srgbClr val="D4AF37"/>
+          </a:solidFill>
+          <a:ln>
+            <a:noFill/>
+          </a:ln>
+          <a:effectLst/>
+        </p:spPr>
+        <p:style>
+          <a:lnRef idx="1">
+            <a:schemeClr val="accent1"/>
+          </a:lnRef>
+          <a:fillRef idx="3">
+            <a:schemeClr val="accent1"/>
+          </a:fillRef>
+          <a:effectRef idx="2">
+            <a:schemeClr val="accent1"/>
+          </a:effectRef>
+          <a:fontRef idx="minor">
+            <a:schemeClr val="lt1"/>
+          </a:fontRef>
+        </p:style>
+        <p:txBody>
+          <a:bodyPr rtlCol="0" anchor="ctr"/>
+          <a:lstStyle/>
+          <a:p>
+            <a:pPr algn="ctr"/>
+          </a:p>
+        </p:txBody>
+      </p:sp>
+      <p:sp>
+        <p:nvSpPr>
+          <p:cNvPr id="17" name="Rounded Rectangle 16"/>
+          <p:cNvSpPr/>
+          <p:nvPr/>
+        </p:nvSpPr>
+        <p:spPr>
+          <a:xfrm>
+            <a:off x="141440" y="6458000"/>
+            <a:ext cx="600000" cy="320000"/>
+          </a:xfrm>
+          <a:prstGeom prst="roundRect">
+            <a:avLst/>
+          </a:prstGeom>
+          <a:solidFill>
+            <a:srgbClr val="0EA5E9"/>
+          </a:solidFill>
+          <a:ln w="12700">
+            <a:solidFill>
+              <a:srgbClr val="D4AF37"/>
+            </a:solidFill>
+          </a:ln>
+          <a:effectLst/>
+        </p:spPr>
+        <p:style>
+          <a:lnRef idx="1">
+            <a:schemeClr val="accent1"/>
+          </a:lnRef>
+          <a:fillRef idx="3">
+            <a:schemeClr val="accent1"/>
+          </a:fillRef>
+          <a:effectRef idx="2">
+            <a:schemeClr val="accent1"/>
+          </a:effectRef>
+          <a:fontRef idx="minor">
+            <a:schemeClr val="lt1"/>
+          </a:fontRef>
+        </p:style>
+        <p:txBody>
+          <a:bodyPr rtlCol="0" anchor="ctr" lIns="0" rIns="0" tIns="0" bIns="0"/>
+          <a:lstStyle/>
+          <a:p>
+            <a:pPr algn="ctr"/>
+            <a:r>
+              <a:rPr b="1" sz="1400">
+                <a:solidFill>
+                  <a:srgbClr val="FFFFFF"/>
+                </a:solidFill>
+              </a:rPr>
+              <a:t>18</a:t>
+            </a:r>
+          </a:p>
+        </p:txBody>
+      </p:sp>
     </p:spTree>
   </p:cSld>
   <p:clrMapOvr>
@@ -11640,6 +12620,104 @@
           </a:p>
         </p:txBody>
       </p:sp>
+      <p:sp>
+        <p:nvSpPr>
+          <p:cNvPr id="17" name="Rectangle 16"/>
+          <p:cNvSpPr/>
+          <p:nvPr/>
+        </p:nvSpPr>
+        <p:spPr>
+          <a:xfrm>
+            <a:off x="0" y="0"/>
+            <a:ext cx="91440" cy="6858000"/>
+          </a:xfrm>
+          <a:prstGeom prst="rect">
+            <a:avLst/>
+          </a:prstGeom>
+          <a:solidFill>
+            <a:srgbClr val="D4AF37"/>
+          </a:solidFill>
+          <a:ln>
+            <a:noFill/>
+          </a:ln>
+          <a:effectLst/>
+        </p:spPr>
+        <p:style>
+          <a:lnRef idx="1">
+            <a:schemeClr val="accent1"/>
+          </a:lnRef>
+          <a:fillRef idx="3">
+            <a:schemeClr val="accent1"/>
+          </a:fillRef>
+          <a:effectRef idx="2">
+            <a:schemeClr val="accent1"/>
+          </a:effectRef>
+          <a:fontRef idx="minor">
+            <a:schemeClr val="lt1"/>
+          </a:fontRef>
+        </p:style>
+        <p:txBody>
+          <a:bodyPr rtlCol="0" anchor="ctr"/>
+          <a:lstStyle/>
+          <a:p>
+            <a:pPr algn="ctr"/>
+          </a:p>
+        </p:txBody>
+      </p:sp>
+      <p:sp>
+        <p:nvSpPr>
+          <p:cNvPr id="18" name="Rounded Rectangle 17"/>
+          <p:cNvSpPr/>
+          <p:nvPr/>
+        </p:nvSpPr>
+        <p:spPr>
+          <a:xfrm>
+            <a:off x="141440" y="6458000"/>
+            <a:ext cx="600000" cy="320000"/>
+          </a:xfrm>
+          <a:prstGeom prst="roundRect">
+            <a:avLst/>
+          </a:prstGeom>
+          <a:solidFill>
+            <a:srgbClr val="0EA5E9"/>
+          </a:solidFill>
+          <a:ln w="12700">
+            <a:solidFill>
+              <a:srgbClr val="D4AF37"/>
+            </a:solidFill>
+          </a:ln>
+          <a:effectLst/>
+        </p:spPr>
+        <p:style>
+          <a:lnRef idx="1">
+            <a:schemeClr val="accent1"/>
+          </a:lnRef>
+          <a:fillRef idx="3">
+            <a:schemeClr val="accent1"/>
+          </a:fillRef>
+          <a:effectRef idx="2">
+            <a:schemeClr val="accent1"/>
+          </a:effectRef>
+          <a:fontRef idx="minor">
+            <a:schemeClr val="lt1"/>
+          </a:fontRef>
+        </p:style>
+        <p:txBody>
+          <a:bodyPr rtlCol="0" anchor="ctr" lIns="0" rIns="0" tIns="0" bIns="0"/>
+          <a:lstStyle/>
+          <a:p>
+            <a:pPr algn="ctr"/>
+            <a:r>
+              <a:rPr b="1" sz="1400">
+                <a:solidFill>
+                  <a:srgbClr val="FFFFFF"/>
+                </a:solidFill>
+              </a:rPr>
+              <a:t>19</a:t>
+            </a:r>
+          </a:p>
+        </p:txBody>
+      </p:sp>
     </p:spTree>
   </p:cSld>
   <p:clrMapOvr>
@@ -12345,6 +13423,104 @@
           </a:p>
         </p:txBody>
       </p:sp>
+      <p:sp>
+        <p:nvSpPr>
+          <p:cNvPr id="15" name="Rectangle 14"/>
+          <p:cNvSpPr/>
+          <p:nvPr/>
+        </p:nvSpPr>
+        <p:spPr>
+          <a:xfrm>
+            <a:off x="0" y="0"/>
+            <a:ext cx="91440" cy="6858000"/>
+          </a:xfrm>
+          <a:prstGeom prst="rect">
+            <a:avLst/>
+          </a:prstGeom>
+          <a:solidFill>
+            <a:srgbClr val="D4AF37"/>
+          </a:solidFill>
+          <a:ln>
+            <a:noFill/>
+          </a:ln>
+          <a:effectLst/>
+        </p:spPr>
+        <p:style>
+          <a:lnRef idx="1">
+            <a:schemeClr val="accent1"/>
+          </a:lnRef>
+          <a:fillRef idx="3">
+            <a:schemeClr val="accent1"/>
+          </a:fillRef>
+          <a:effectRef idx="2">
+            <a:schemeClr val="accent1"/>
+          </a:effectRef>
+          <a:fontRef idx="minor">
+            <a:schemeClr val="lt1"/>
+          </a:fontRef>
+        </p:style>
+        <p:txBody>
+          <a:bodyPr rtlCol="0" anchor="ctr"/>
+          <a:lstStyle/>
+          <a:p>
+            <a:pPr algn="ctr"/>
+          </a:p>
+        </p:txBody>
+      </p:sp>
+      <p:sp>
+        <p:nvSpPr>
+          <p:cNvPr id="16" name="Rounded Rectangle 15"/>
+          <p:cNvSpPr/>
+          <p:nvPr/>
+        </p:nvSpPr>
+        <p:spPr>
+          <a:xfrm>
+            <a:off x="141440" y="6458000"/>
+            <a:ext cx="600000" cy="320000"/>
+          </a:xfrm>
+          <a:prstGeom prst="roundRect">
+            <a:avLst/>
+          </a:prstGeom>
+          <a:solidFill>
+            <a:srgbClr val="0EA5E9"/>
+          </a:solidFill>
+          <a:ln w="12700">
+            <a:solidFill>
+              <a:srgbClr val="D4AF37"/>
+            </a:solidFill>
+          </a:ln>
+          <a:effectLst/>
+        </p:spPr>
+        <p:style>
+          <a:lnRef idx="1">
+            <a:schemeClr val="accent1"/>
+          </a:lnRef>
+          <a:fillRef idx="3">
+            <a:schemeClr val="accent1"/>
+          </a:fillRef>
+          <a:effectRef idx="2">
+            <a:schemeClr val="accent1"/>
+          </a:effectRef>
+          <a:fontRef idx="minor">
+            <a:schemeClr val="lt1"/>
+          </a:fontRef>
+        </p:style>
+        <p:txBody>
+          <a:bodyPr rtlCol="0" anchor="ctr" lIns="0" rIns="0" tIns="0" bIns="0"/>
+          <a:lstStyle/>
+          <a:p>
+            <a:pPr algn="ctr"/>
+            <a:r>
+              <a:rPr b="1" sz="1400">
+                <a:solidFill>
+                  <a:srgbClr val="FFFFFF"/>
+                </a:solidFill>
+              </a:rPr>
+              <a:t>02</a:t>
+            </a:r>
+          </a:p>
+        </p:txBody>
+      </p:sp>
     </p:spTree>
   </p:cSld>
   <p:clrMapOvr>
@@ -13056,6 +14232,104 @@
           </a:p>
         </p:txBody>
       </p:sp>
+      <p:sp>
+        <p:nvSpPr>
+          <p:cNvPr id="17" name="Rectangle 16"/>
+          <p:cNvSpPr/>
+          <p:nvPr/>
+        </p:nvSpPr>
+        <p:spPr>
+          <a:xfrm>
+            <a:off x="0" y="0"/>
+            <a:ext cx="91440" cy="6858000"/>
+          </a:xfrm>
+          <a:prstGeom prst="rect">
+            <a:avLst/>
+          </a:prstGeom>
+          <a:solidFill>
+            <a:srgbClr val="D4AF37"/>
+          </a:solidFill>
+          <a:ln>
+            <a:noFill/>
+          </a:ln>
+          <a:effectLst/>
+        </p:spPr>
+        <p:style>
+          <a:lnRef idx="1">
+            <a:schemeClr val="accent1"/>
+          </a:lnRef>
+          <a:fillRef idx="3">
+            <a:schemeClr val="accent1"/>
+          </a:fillRef>
+          <a:effectRef idx="2">
+            <a:schemeClr val="accent1"/>
+          </a:effectRef>
+          <a:fontRef idx="minor">
+            <a:schemeClr val="lt1"/>
+          </a:fontRef>
+        </p:style>
+        <p:txBody>
+          <a:bodyPr rtlCol="0" anchor="ctr"/>
+          <a:lstStyle/>
+          <a:p>
+            <a:pPr algn="ctr"/>
+          </a:p>
+        </p:txBody>
+      </p:sp>
+      <p:sp>
+        <p:nvSpPr>
+          <p:cNvPr id="18" name="Rounded Rectangle 17"/>
+          <p:cNvSpPr/>
+          <p:nvPr/>
+        </p:nvSpPr>
+        <p:spPr>
+          <a:xfrm>
+            <a:off x="141440" y="6458000"/>
+            <a:ext cx="600000" cy="320000"/>
+          </a:xfrm>
+          <a:prstGeom prst="roundRect">
+            <a:avLst/>
+          </a:prstGeom>
+          <a:solidFill>
+            <a:srgbClr val="0EA5E9"/>
+          </a:solidFill>
+          <a:ln w="12700">
+            <a:solidFill>
+              <a:srgbClr val="D4AF37"/>
+            </a:solidFill>
+          </a:ln>
+          <a:effectLst/>
+        </p:spPr>
+        <p:style>
+          <a:lnRef idx="1">
+            <a:schemeClr val="accent1"/>
+          </a:lnRef>
+          <a:fillRef idx="3">
+            <a:schemeClr val="accent1"/>
+          </a:fillRef>
+          <a:effectRef idx="2">
+            <a:schemeClr val="accent1"/>
+          </a:effectRef>
+          <a:fontRef idx="minor">
+            <a:schemeClr val="lt1"/>
+          </a:fontRef>
+        </p:style>
+        <p:txBody>
+          <a:bodyPr rtlCol="0" anchor="ctr" lIns="0" rIns="0" tIns="0" bIns="0"/>
+          <a:lstStyle/>
+          <a:p>
+            <a:pPr algn="ctr"/>
+            <a:r>
+              <a:rPr b="1" sz="1400">
+                <a:solidFill>
+                  <a:srgbClr val="FFFFFF"/>
+                </a:solidFill>
+              </a:rPr>
+              <a:t>20</a:t>
+            </a:r>
+          </a:p>
+        </p:txBody>
+      </p:sp>
     </p:spTree>
   </p:cSld>
   <p:clrMapOvr>
@@ -13632,6 +14906,104 @@
           </a:p>
         </p:txBody>
       </p:sp>
+      <p:sp>
+        <p:nvSpPr>
+          <p:cNvPr id="14" name="Rectangle 13"/>
+          <p:cNvSpPr/>
+          <p:nvPr/>
+        </p:nvSpPr>
+        <p:spPr>
+          <a:xfrm>
+            <a:off x="0" y="0"/>
+            <a:ext cx="91440" cy="6858000"/>
+          </a:xfrm>
+          <a:prstGeom prst="rect">
+            <a:avLst/>
+          </a:prstGeom>
+          <a:solidFill>
+            <a:srgbClr val="D4AF37"/>
+          </a:solidFill>
+          <a:ln>
+            <a:noFill/>
+          </a:ln>
+          <a:effectLst/>
+        </p:spPr>
+        <p:style>
+          <a:lnRef idx="1">
+            <a:schemeClr val="accent1"/>
+          </a:lnRef>
+          <a:fillRef idx="3">
+            <a:schemeClr val="accent1"/>
+          </a:fillRef>
+          <a:effectRef idx="2">
+            <a:schemeClr val="accent1"/>
+          </a:effectRef>
+          <a:fontRef idx="minor">
+            <a:schemeClr val="lt1"/>
+          </a:fontRef>
+        </p:style>
+        <p:txBody>
+          <a:bodyPr rtlCol="0" anchor="ctr"/>
+          <a:lstStyle/>
+          <a:p>
+            <a:pPr algn="ctr"/>
+          </a:p>
+        </p:txBody>
+      </p:sp>
+      <p:sp>
+        <p:nvSpPr>
+          <p:cNvPr id="15" name="Rounded Rectangle 14"/>
+          <p:cNvSpPr/>
+          <p:nvPr/>
+        </p:nvSpPr>
+        <p:spPr>
+          <a:xfrm>
+            <a:off x="141440" y="6458000"/>
+            <a:ext cx="600000" cy="320000"/>
+          </a:xfrm>
+          <a:prstGeom prst="roundRect">
+            <a:avLst/>
+          </a:prstGeom>
+          <a:solidFill>
+            <a:srgbClr val="0EA5E9"/>
+          </a:solidFill>
+          <a:ln w="12700">
+            <a:solidFill>
+              <a:srgbClr val="D4AF37"/>
+            </a:solidFill>
+          </a:ln>
+          <a:effectLst/>
+        </p:spPr>
+        <p:style>
+          <a:lnRef idx="1">
+            <a:schemeClr val="accent1"/>
+          </a:lnRef>
+          <a:fillRef idx="3">
+            <a:schemeClr val="accent1"/>
+          </a:fillRef>
+          <a:effectRef idx="2">
+            <a:schemeClr val="accent1"/>
+          </a:effectRef>
+          <a:fontRef idx="minor">
+            <a:schemeClr val="lt1"/>
+          </a:fontRef>
+        </p:style>
+        <p:txBody>
+          <a:bodyPr rtlCol="0" anchor="ctr" lIns="0" rIns="0" tIns="0" bIns="0"/>
+          <a:lstStyle/>
+          <a:p>
+            <a:pPr algn="ctr"/>
+            <a:r>
+              <a:rPr b="1" sz="1400">
+                <a:solidFill>
+                  <a:srgbClr val="FFFFFF"/>
+                </a:solidFill>
+              </a:rPr>
+              <a:t>21</a:t>
+            </a:r>
+          </a:p>
+        </p:txBody>
+      </p:sp>
     </p:spTree>
   </p:cSld>
   <p:clrMapOvr>
@@ -14277,6 +15649,104 @@
           </a:p>
         </p:txBody>
       </p:sp>
+      <p:sp>
+        <p:nvSpPr>
+          <p:cNvPr id="15" name="Rectangle 14"/>
+          <p:cNvSpPr/>
+          <p:nvPr/>
+        </p:nvSpPr>
+        <p:spPr>
+          <a:xfrm>
+            <a:off x="0" y="0"/>
+            <a:ext cx="91440" cy="6858000"/>
+          </a:xfrm>
+          <a:prstGeom prst="rect">
+            <a:avLst/>
+          </a:prstGeom>
+          <a:solidFill>
+            <a:srgbClr val="D4AF37"/>
+          </a:solidFill>
+          <a:ln>
+            <a:noFill/>
+          </a:ln>
+          <a:effectLst/>
+        </p:spPr>
+        <p:style>
+          <a:lnRef idx="1">
+            <a:schemeClr val="accent1"/>
+          </a:lnRef>
+          <a:fillRef idx="3">
+            <a:schemeClr val="accent1"/>
+          </a:fillRef>
+          <a:effectRef idx="2">
+            <a:schemeClr val="accent1"/>
+          </a:effectRef>
+          <a:fontRef idx="minor">
+            <a:schemeClr val="lt1"/>
+          </a:fontRef>
+        </p:style>
+        <p:txBody>
+          <a:bodyPr rtlCol="0" anchor="ctr"/>
+          <a:lstStyle/>
+          <a:p>
+            <a:pPr algn="ctr"/>
+          </a:p>
+        </p:txBody>
+      </p:sp>
+      <p:sp>
+        <p:nvSpPr>
+          <p:cNvPr id="16" name="Rounded Rectangle 15"/>
+          <p:cNvSpPr/>
+          <p:nvPr/>
+        </p:nvSpPr>
+        <p:spPr>
+          <a:xfrm>
+            <a:off x="141440" y="6458000"/>
+            <a:ext cx="600000" cy="320000"/>
+          </a:xfrm>
+          <a:prstGeom prst="roundRect">
+            <a:avLst/>
+          </a:prstGeom>
+          <a:solidFill>
+            <a:srgbClr val="0EA5E9"/>
+          </a:solidFill>
+          <a:ln w="12700">
+            <a:solidFill>
+              <a:srgbClr val="D4AF37"/>
+            </a:solidFill>
+          </a:ln>
+          <a:effectLst/>
+        </p:spPr>
+        <p:style>
+          <a:lnRef idx="1">
+            <a:schemeClr val="accent1"/>
+          </a:lnRef>
+          <a:fillRef idx="3">
+            <a:schemeClr val="accent1"/>
+          </a:fillRef>
+          <a:effectRef idx="2">
+            <a:schemeClr val="accent1"/>
+          </a:effectRef>
+          <a:fontRef idx="minor">
+            <a:schemeClr val="lt1"/>
+          </a:fontRef>
+        </p:style>
+        <p:txBody>
+          <a:bodyPr rtlCol="0" anchor="ctr" lIns="0" rIns="0" tIns="0" bIns="0"/>
+          <a:lstStyle/>
+          <a:p>
+            <a:pPr algn="ctr"/>
+            <a:r>
+              <a:rPr b="1" sz="1400">
+                <a:solidFill>
+                  <a:srgbClr val="FFFFFF"/>
+                </a:solidFill>
+              </a:rPr>
+              <a:t>22</a:t>
+            </a:r>
+          </a:p>
+        </p:txBody>
+      </p:sp>
     </p:spTree>
   </p:cSld>
   <p:clrMapOvr>
@@ -15239,6 +16709,104 @@
           </a:p>
         </p:txBody>
       </p:sp>
+      <p:sp>
+        <p:nvSpPr>
+          <p:cNvPr id="20" name="Rectangle 19"/>
+          <p:cNvSpPr/>
+          <p:nvPr/>
+        </p:nvSpPr>
+        <p:spPr>
+          <a:xfrm>
+            <a:off x="0" y="0"/>
+            <a:ext cx="91440" cy="6858000"/>
+          </a:xfrm>
+          <a:prstGeom prst="rect">
+            <a:avLst/>
+          </a:prstGeom>
+          <a:solidFill>
+            <a:srgbClr val="D4AF37"/>
+          </a:solidFill>
+          <a:ln>
+            <a:noFill/>
+          </a:ln>
+          <a:effectLst/>
+        </p:spPr>
+        <p:style>
+          <a:lnRef idx="1">
+            <a:schemeClr val="accent1"/>
+          </a:lnRef>
+          <a:fillRef idx="3">
+            <a:schemeClr val="accent1"/>
+          </a:fillRef>
+          <a:effectRef idx="2">
+            <a:schemeClr val="accent1"/>
+          </a:effectRef>
+          <a:fontRef idx="minor">
+            <a:schemeClr val="lt1"/>
+          </a:fontRef>
+        </p:style>
+        <p:txBody>
+          <a:bodyPr rtlCol="0" anchor="ctr"/>
+          <a:lstStyle/>
+          <a:p>
+            <a:pPr algn="ctr"/>
+          </a:p>
+        </p:txBody>
+      </p:sp>
+      <p:sp>
+        <p:nvSpPr>
+          <p:cNvPr id="21" name="Rounded Rectangle 20"/>
+          <p:cNvSpPr/>
+          <p:nvPr/>
+        </p:nvSpPr>
+        <p:spPr>
+          <a:xfrm>
+            <a:off x="141440" y="6458000"/>
+            <a:ext cx="600000" cy="320000"/>
+          </a:xfrm>
+          <a:prstGeom prst="roundRect">
+            <a:avLst/>
+          </a:prstGeom>
+          <a:solidFill>
+            <a:srgbClr val="0EA5E9"/>
+          </a:solidFill>
+          <a:ln w="12700">
+            <a:solidFill>
+              <a:srgbClr val="D4AF37"/>
+            </a:solidFill>
+          </a:ln>
+          <a:effectLst/>
+        </p:spPr>
+        <p:style>
+          <a:lnRef idx="1">
+            <a:schemeClr val="accent1"/>
+          </a:lnRef>
+          <a:fillRef idx="3">
+            <a:schemeClr val="accent1"/>
+          </a:fillRef>
+          <a:effectRef idx="2">
+            <a:schemeClr val="accent1"/>
+          </a:effectRef>
+          <a:fontRef idx="minor">
+            <a:schemeClr val="lt1"/>
+          </a:fontRef>
+        </p:style>
+        <p:txBody>
+          <a:bodyPr rtlCol="0" anchor="ctr" lIns="0" rIns="0" tIns="0" bIns="0"/>
+          <a:lstStyle/>
+          <a:p>
+            <a:pPr algn="ctr"/>
+            <a:r>
+              <a:rPr b="1" sz="1400">
+                <a:solidFill>
+                  <a:srgbClr val="FFFFFF"/>
+                </a:solidFill>
+              </a:rPr>
+              <a:t>23</a:t>
+            </a:r>
+          </a:p>
+        </p:txBody>
+      </p:sp>
     </p:spTree>
   </p:cSld>
   <p:clrMapOvr>
@@ -16113,6 +17681,104 @@
           </a:p>
         </p:txBody>
       </p:sp>
+      <p:sp>
+        <p:nvSpPr>
+          <p:cNvPr id="17" name="Rectangle 16"/>
+          <p:cNvSpPr/>
+          <p:nvPr/>
+        </p:nvSpPr>
+        <p:spPr>
+          <a:xfrm>
+            <a:off x="0" y="0"/>
+            <a:ext cx="91440" cy="6858000"/>
+          </a:xfrm>
+          <a:prstGeom prst="rect">
+            <a:avLst/>
+          </a:prstGeom>
+          <a:solidFill>
+            <a:srgbClr val="D4AF37"/>
+          </a:solidFill>
+          <a:ln>
+            <a:noFill/>
+          </a:ln>
+          <a:effectLst/>
+        </p:spPr>
+        <p:style>
+          <a:lnRef idx="1">
+            <a:schemeClr val="accent1"/>
+          </a:lnRef>
+          <a:fillRef idx="3">
+            <a:schemeClr val="accent1"/>
+          </a:fillRef>
+          <a:effectRef idx="2">
+            <a:schemeClr val="accent1"/>
+          </a:effectRef>
+          <a:fontRef idx="minor">
+            <a:schemeClr val="lt1"/>
+          </a:fontRef>
+        </p:style>
+        <p:txBody>
+          <a:bodyPr rtlCol="0" anchor="ctr"/>
+          <a:lstStyle/>
+          <a:p>
+            <a:pPr algn="ctr"/>
+          </a:p>
+        </p:txBody>
+      </p:sp>
+      <p:sp>
+        <p:nvSpPr>
+          <p:cNvPr id="18" name="Rounded Rectangle 17"/>
+          <p:cNvSpPr/>
+          <p:nvPr/>
+        </p:nvSpPr>
+        <p:spPr>
+          <a:xfrm>
+            <a:off x="141440" y="6458000"/>
+            <a:ext cx="600000" cy="320000"/>
+          </a:xfrm>
+          <a:prstGeom prst="roundRect">
+            <a:avLst/>
+          </a:prstGeom>
+          <a:solidFill>
+            <a:srgbClr val="0EA5E9"/>
+          </a:solidFill>
+          <a:ln w="12700">
+            <a:solidFill>
+              <a:srgbClr val="D4AF37"/>
+            </a:solidFill>
+          </a:ln>
+          <a:effectLst/>
+        </p:spPr>
+        <p:style>
+          <a:lnRef idx="1">
+            <a:schemeClr val="accent1"/>
+          </a:lnRef>
+          <a:fillRef idx="3">
+            <a:schemeClr val="accent1"/>
+          </a:fillRef>
+          <a:effectRef idx="2">
+            <a:schemeClr val="accent1"/>
+          </a:effectRef>
+          <a:fontRef idx="minor">
+            <a:schemeClr val="lt1"/>
+          </a:fontRef>
+        </p:style>
+        <p:txBody>
+          <a:bodyPr rtlCol="0" anchor="ctr" lIns="0" rIns="0" tIns="0" bIns="0"/>
+          <a:lstStyle/>
+          <a:p>
+            <a:pPr algn="ctr"/>
+            <a:r>
+              <a:rPr b="1" sz="1400">
+                <a:solidFill>
+                  <a:srgbClr val="FFFFFF"/>
+                </a:solidFill>
+              </a:rPr>
+              <a:t>24</a:t>
+            </a:r>
+          </a:p>
+        </p:txBody>
+      </p:sp>
     </p:spTree>
   </p:cSld>
   <p:clrMapOvr>
@@ -16691,6 +18357,104 @@
           </a:p>
         </p:txBody>
       </p:sp>
+      <p:sp>
+        <p:nvSpPr>
+          <p:cNvPr id="12" name="Rectangle 11"/>
+          <p:cNvSpPr/>
+          <p:nvPr/>
+        </p:nvSpPr>
+        <p:spPr>
+          <a:xfrm>
+            <a:off x="0" y="0"/>
+            <a:ext cx="91440" cy="6858000"/>
+          </a:xfrm>
+          <a:prstGeom prst="rect">
+            <a:avLst/>
+          </a:prstGeom>
+          <a:solidFill>
+            <a:srgbClr val="D4AF37"/>
+          </a:solidFill>
+          <a:ln>
+            <a:noFill/>
+          </a:ln>
+          <a:effectLst/>
+        </p:spPr>
+        <p:style>
+          <a:lnRef idx="1">
+            <a:schemeClr val="accent1"/>
+          </a:lnRef>
+          <a:fillRef idx="3">
+            <a:schemeClr val="accent1"/>
+          </a:fillRef>
+          <a:effectRef idx="2">
+            <a:schemeClr val="accent1"/>
+          </a:effectRef>
+          <a:fontRef idx="minor">
+            <a:schemeClr val="lt1"/>
+          </a:fontRef>
+        </p:style>
+        <p:txBody>
+          <a:bodyPr rtlCol="0" anchor="ctr"/>
+          <a:lstStyle/>
+          <a:p>
+            <a:pPr algn="ctr"/>
+          </a:p>
+        </p:txBody>
+      </p:sp>
+      <p:sp>
+        <p:nvSpPr>
+          <p:cNvPr id="13" name="Rounded Rectangle 12"/>
+          <p:cNvSpPr/>
+          <p:nvPr/>
+        </p:nvSpPr>
+        <p:spPr>
+          <a:xfrm>
+            <a:off x="141440" y="6458000"/>
+            <a:ext cx="600000" cy="320000"/>
+          </a:xfrm>
+          <a:prstGeom prst="roundRect">
+            <a:avLst/>
+          </a:prstGeom>
+          <a:solidFill>
+            <a:srgbClr val="0EA5E9"/>
+          </a:solidFill>
+          <a:ln w="12700">
+            <a:solidFill>
+              <a:srgbClr val="D4AF37"/>
+            </a:solidFill>
+          </a:ln>
+          <a:effectLst/>
+        </p:spPr>
+        <p:style>
+          <a:lnRef idx="1">
+            <a:schemeClr val="accent1"/>
+          </a:lnRef>
+          <a:fillRef idx="3">
+            <a:schemeClr val="accent1"/>
+          </a:fillRef>
+          <a:effectRef idx="2">
+            <a:schemeClr val="accent1"/>
+          </a:effectRef>
+          <a:fontRef idx="minor">
+            <a:schemeClr val="lt1"/>
+          </a:fontRef>
+        </p:style>
+        <p:txBody>
+          <a:bodyPr rtlCol="0" anchor="ctr" lIns="0" rIns="0" tIns="0" bIns="0"/>
+          <a:lstStyle/>
+          <a:p>
+            <a:pPr algn="ctr"/>
+            <a:r>
+              <a:rPr b="1" sz="1400">
+                <a:solidFill>
+                  <a:srgbClr val="FFFFFF"/>
+                </a:solidFill>
+              </a:rPr>
+              <a:t>25</a:t>
+            </a:r>
+          </a:p>
+        </p:txBody>
+      </p:sp>
     </p:spTree>
   </p:cSld>
   <p:clrMapOvr>
@@ -17658,6 +19422,104 @@
           </a:p>
         </p:txBody>
       </p:sp>
+      <p:sp>
+        <p:nvSpPr>
+          <p:cNvPr id="25" name="Rectangle 24"/>
+          <p:cNvSpPr/>
+          <p:nvPr/>
+        </p:nvSpPr>
+        <p:spPr>
+          <a:xfrm>
+            <a:off x="0" y="0"/>
+            <a:ext cx="91440" cy="6858000"/>
+          </a:xfrm>
+          <a:prstGeom prst="rect">
+            <a:avLst/>
+          </a:prstGeom>
+          <a:solidFill>
+            <a:srgbClr val="D4AF37"/>
+          </a:solidFill>
+          <a:ln>
+            <a:noFill/>
+          </a:ln>
+          <a:effectLst/>
+        </p:spPr>
+        <p:style>
+          <a:lnRef idx="1">
+            <a:schemeClr val="accent1"/>
+          </a:lnRef>
+          <a:fillRef idx="3">
+            <a:schemeClr val="accent1"/>
+          </a:fillRef>
+          <a:effectRef idx="2">
+            <a:schemeClr val="accent1"/>
+          </a:effectRef>
+          <a:fontRef idx="minor">
+            <a:schemeClr val="lt1"/>
+          </a:fontRef>
+        </p:style>
+        <p:txBody>
+          <a:bodyPr rtlCol="0" anchor="ctr"/>
+          <a:lstStyle/>
+          <a:p>
+            <a:pPr algn="ctr"/>
+          </a:p>
+        </p:txBody>
+      </p:sp>
+      <p:sp>
+        <p:nvSpPr>
+          <p:cNvPr id="26" name="Rounded Rectangle 25"/>
+          <p:cNvSpPr/>
+          <p:nvPr/>
+        </p:nvSpPr>
+        <p:spPr>
+          <a:xfrm>
+            <a:off x="141440" y="6458000"/>
+            <a:ext cx="600000" cy="320000"/>
+          </a:xfrm>
+          <a:prstGeom prst="roundRect">
+            <a:avLst/>
+          </a:prstGeom>
+          <a:solidFill>
+            <a:srgbClr val="0EA5E9"/>
+          </a:solidFill>
+          <a:ln w="12700">
+            <a:solidFill>
+              <a:srgbClr val="D4AF37"/>
+            </a:solidFill>
+          </a:ln>
+          <a:effectLst/>
+        </p:spPr>
+        <p:style>
+          <a:lnRef idx="1">
+            <a:schemeClr val="accent1"/>
+          </a:lnRef>
+          <a:fillRef idx="3">
+            <a:schemeClr val="accent1"/>
+          </a:fillRef>
+          <a:effectRef idx="2">
+            <a:schemeClr val="accent1"/>
+          </a:effectRef>
+          <a:fontRef idx="minor">
+            <a:schemeClr val="lt1"/>
+          </a:fontRef>
+        </p:style>
+        <p:txBody>
+          <a:bodyPr rtlCol="0" anchor="ctr" lIns="0" rIns="0" tIns="0" bIns="0"/>
+          <a:lstStyle/>
+          <a:p>
+            <a:pPr algn="ctr"/>
+            <a:r>
+              <a:rPr b="1" sz="1400">
+                <a:solidFill>
+                  <a:srgbClr val="FFFFFF"/>
+                </a:solidFill>
+              </a:rPr>
+              <a:t>26</a:t>
+            </a:r>
+          </a:p>
+        </p:txBody>
+      </p:sp>
     </p:spTree>
   </p:cSld>
   <p:clrMapOvr>
@@ -17948,6 +19810,104 @@
           </a:p>
         </p:txBody>
       </p:sp>
+      <p:sp>
+        <p:nvSpPr>
+          <p:cNvPr id="9" name="Rectangle 8"/>
+          <p:cNvSpPr/>
+          <p:nvPr/>
+        </p:nvSpPr>
+        <p:spPr>
+          <a:xfrm>
+            <a:off x="0" y="0"/>
+            <a:ext cx="91440" cy="6858000"/>
+          </a:xfrm>
+          <a:prstGeom prst="rect">
+            <a:avLst/>
+          </a:prstGeom>
+          <a:solidFill>
+            <a:srgbClr val="D4AF37"/>
+          </a:solidFill>
+          <a:ln>
+            <a:noFill/>
+          </a:ln>
+          <a:effectLst/>
+        </p:spPr>
+        <p:style>
+          <a:lnRef idx="1">
+            <a:schemeClr val="accent1"/>
+          </a:lnRef>
+          <a:fillRef idx="3">
+            <a:schemeClr val="accent1"/>
+          </a:fillRef>
+          <a:effectRef idx="2">
+            <a:schemeClr val="accent1"/>
+          </a:effectRef>
+          <a:fontRef idx="minor">
+            <a:schemeClr val="lt1"/>
+          </a:fontRef>
+        </p:style>
+        <p:txBody>
+          <a:bodyPr rtlCol="0" anchor="ctr"/>
+          <a:lstStyle/>
+          <a:p>
+            <a:pPr algn="ctr"/>
+          </a:p>
+        </p:txBody>
+      </p:sp>
+      <p:sp>
+        <p:nvSpPr>
+          <p:cNvPr id="10" name="Rounded Rectangle 9"/>
+          <p:cNvSpPr/>
+          <p:nvPr/>
+        </p:nvSpPr>
+        <p:spPr>
+          <a:xfrm>
+            <a:off x="141440" y="6458000"/>
+            <a:ext cx="600000" cy="320000"/>
+          </a:xfrm>
+          <a:prstGeom prst="roundRect">
+            <a:avLst/>
+          </a:prstGeom>
+          <a:solidFill>
+            <a:srgbClr val="0EA5E9"/>
+          </a:solidFill>
+          <a:ln w="12700">
+            <a:solidFill>
+              <a:srgbClr val="D4AF37"/>
+            </a:solidFill>
+          </a:ln>
+          <a:effectLst/>
+        </p:spPr>
+        <p:style>
+          <a:lnRef idx="1">
+            <a:schemeClr val="accent1"/>
+          </a:lnRef>
+          <a:fillRef idx="3">
+            <a:schemeClr val="accent1"/>
+          </a:fillRef>
+          <a:effectRef idx="2">
+            <a:schemeClr val="accent1"/>
+          </a:effectRef>
+          <a:fontRef idx="minor">
+            <a:schemeClr val="lt1"/>
+          </a:fontRef>
+        </p:style>
+        <p:txBody>
+          <a:bodyPr rtlCol="0" anchor="ctr" lIns="0" rIns="0" tIns="0" bIns="0"/>
+          <a:lstStyle/>
+          <a:p>
+            <a:pPr algn="ctr"/>
+            <a:r>
+              <a:rPr b="1" sz="1400">
+                <a:solidFill>
+                  <a:srgbClr val="FFFFFF"/>
+                </a:solidFill>
+              </a:rPr>
+              <a:t>27</a:t>
+            </a:r>
+          </a:p>
+        </p:txBody>
+      </p:sp>
     </p:spTree>
   </p:cSld>
   <p:clrMapOvr>
@@ -18405,6 +20365,104 @@
             <a:r>
               <a:rPr sz="1300"/>
               <a:t>Kaduna State Government and Katsina State Government (2025) Early Warning and Early Response System: outcomes report. Kaduna/Katsina: State Governments.</a:t>
+            </a:r>
+          </a:p>
+        </p:txBody>
+      </p:sp>
+      <p:sp>
+        <p:nvSpPr>
+          <p:cNvPr id="12" name="Rectangle 11"/>
+          <p:cNvSpPr/>
+          <p:nvPr/>
+        </p:nvSpPr>
+        <p:spPr>
+          <a:xfrm>
+            <a:off x="0" y="0"/>
+            <a:ext cx="91440" cy="6858000"/>
+          </a:xfrm>
+          <a:prstGeom prst="rect">
+            <a:avLst/>
+          </a:prstGeom>
+          <a:solidFill>
+            <a:srgbClr val="D4AF37"/>
+          </a:solidFill>
+          <a:ln>
+            <a:noFill/>
+          </a:ln>
+          <a:effectLst/>
+        </p:spPr>
+        <p:style>
+          <a:lnRef idx="1">
+            <a:schemeClr val="accent1"/>
+          </a:lnRef>
+          <a:fillRef idx="3">
+            <a:schemeClr val="accent1"/>
+          </a:fillRef>
+          <a:effectRef idx="2">
+            <a:schemeClr val="accent1"/>
+          </a:effectRef>
+          <a:fontRef idx="minor">
+            <a:schemeClr val="lt1"/>
+          </a:fontRef>
+        </p:style>
+        <p:txBody>
+          <a:bodyPr rtlCol="0" anchor="ctr"/>
+          <a:lstStyle/>
+          <a:p>
+            <a:pPr algn="ctr"/>
+          </a:p>
+        </p:txBody>
+      </p:sp>
+      <p:sp>
+        <p:nvSpPr>
+          <p:cNvPr id="13" name="Rounded Rectangle 12"/>
+          <p:cNvSpPr/>
+          <p:nvPr/>
+        </p:nvSpPr>
+        <p:spPr>
+          <a:xfrm>
+            <a:off x="141440" y="6458000"/>
+            <a:ext cx="600000" cy="320000"/>
+          </a:xfrm>
+          <a:prstGeom prst="roundRect">
+            <a:avLst/>
+          </a:prstGeom>
+          <a:solidFill>
+            <a:srgbClr val="0EA5E9"/>
+          </a:solidFill>
+          <a:ln w="12700">
+            <a:solidFill>
+              <a:srgbClr val="D4AF37"/>
+            </a:solidFill>
+          </a:ln>
+          <a:effectLst/>
+        </p:spPr>
+        <p:style>
+          <a:lnRef idx="1">
+            <a:schemeClr val="accent1"/>
+          </a:lnRef>
+          <a:fillRef idx="3">
+            <a:schemeClr val="accent1"/>
+          </a:fillRef>
+          <a:effectRef idx="2">
+            <a:schemeClr val="accent1"/>
+          </a:effectRef>
+          <a:fontRef idx="minor">
+            <a:schemeClr val="lt1"/>
+          </a:fontRef>
+        </p:style>
+        <p:txBody>
+          <a:bodyPr rtlCol="0" anchor="ctr" lIns="0" rIns="0" tIns="0" bIns="0"/>
+          <a:lstStyle/>
+          <a:p>
+            <a:pPr algn="ctr"/>
+            <a:r>
+              <a:rPr b="1" sz="1400">
+                <a:solidFill>
+                  <a:srgbClr val="FFFFFF"/>
+                </a:solidFill>
+              </a:rPr>
+              <a:t>28</a:t>
             </a:r>
           </a:p>
         </p:txBody>
@@ -19058,6 +21116,104 @@
           </a:p>
         </p:txBody>
       </p:sp>
+      <p:sp>
+        <p:nvSpPr>
+          <p:cNvPr id="15" name="Rectangle 14"/>
+          <p:cNvSpPr/>
+          <p:nvPr/>
+        </p:nvSpPr>
+        <p:spPr>
+          <a:xfrm>
+            <a:off x="0" y="0"/>
+            <a:ext cx="91440" cy="6858000"/>
+          </a:xfrm>
+          <a:prstGeom prst="rect">
+            <a:avLst/>
+          </a:prstGeom>
+          <a:solidFill>
+            <a:srgbClr val="D4AF37"/>
+          </a:solidFill>
+          <a:ln>
+            <a:noFill/>
+          </a:ln>
+          <a:effectLst/>
+        </p:spPr>
+        <p:style>
+          <a:lnRef idx="1">
+            <a:schemeClr val="accent1"/>
+          </a:lnRef>
+          <a:fillRef idx="3">
+            <a:schemeClr val="accent1"/>
+          </a:fillRef>
+          <a:effectRef idx="2">
+            <a:schemeClr val="accent1"/>
+          </a:effectRef>
+          <a:fontRef idx="minor">
+            <a:schemeClr val="lt1"/>
+          </a:fontRef>
+        </p:style>
+        <p:txBody>
+          <a:bodyPr rtlCol="0" anchor="ctr"/>
+          <a:lstStyle/>
+          <a:p>
+            <a:pPr algn="ctr"/>
+          </a:p>
+        </p:txBody>
+      </p:sp>
+      <p:sp>
+        <p:nvSpPr>
+          <p:cNvPr id="16" name="Rounded Rectangle 15"/>
+          <p:cNvSpPr/>
+          <p:nvPr/>
+        </p:nvSpPr>
+        <p:spPr>
+          <a:xfrm>
+            <a:off x="141440" y="6458000"/>
+            <a:ext cx="600000" cy="320000"/>
+          </a:xfrm>
+          <a:prstGeom prst="roundRect">
+            <a:avLst/>
+          </a:prstGeom>
+          <a:solidFill>
+            <a:srgbClr val="0EA5E9"/>
+          </a:solidFill>
+          <a:ln w="12700">
+            <a:solidFill>
+              <a:srgbClr val="D4AF37"/>
+            </a:solidFill>
+          </a:ln>
+          <a:effectLst/>
+        </p:spPr>
+        <p:style>
+          <a:lnRef idx="1">
+            <a:schemeClr val="accent1"/>
+          </a:lnRef>
+          <a:fillRef idx="3">
+            <a:schemeClr val="accent1"/>
+          </a:fillRef>
+          <a:effectRef idx="2">
+            <a:schemeClr val="accent1"/>
+          </a:effectRef>
+          <a:fontRef idx="minor">
+            <a:schemeClr val="lt1"/>
+          </a:fontRef>
+        </p:style>
+        <p:txBody>
+          <a:bodyPr rtlCol="0" anchor="ctr" lIns="0" rIns="0" tIns="0" bIns="0"/>
+          <a:lstStyle/>
+          <a:p>
+            <a:pPr algn="ctr"/>
+            <a:r>
+              <a:rPr b="1" sz="1400">
+                <a:solidFill>
+                  <a:srgbClr val="FFFFFF"/>
+                </a:solidFill>
+              </a:rPr>
+              <a:t>03</a:t>
+            </a:r>
+          </a:p>
+        </p:txBody>
+      </p:sp>
     </p:spTree>
   </p:cSld>
   <p:clrMapOvr>
@@ -20313,6 +22469,104 @@
           </a:p>
         </p:txBody>
       </p:sp>
+      <p:sp>
+        <p:nvSpPr>
+          <p:cNvPr id="29" name="Rectangle 28"/>
+          <p:cNvSpPr/>
+          <p:nvPr/>
+        </p:nvSpPr>
+        <p:spPr>
+          <a:xfrm>
+            <a:off x="0" y="0"/>
+            <a:ext cx="91440" cy="6858000"/>
+          </a:xfrm>
+          <a:prstGeom prst="rect">
+            <a:avLst/>
+          </a:prstGeom>
+          <a:solidFill>
+            <a:srgbClr val="D4AF37"/>
+          </a:solidFill>
+          <a:ln>
+            <a:noFill/>
+          </a:ln>
+          <a:effectLst/>
+        </p:spPr>
+        <p:style>
+          <a:lnRef idx="1">
+            <a:schemeClr val="accent1"/>
+          </a:lnRef>
+          <a:fillRef idx="3">
+            <a:schemeClr val="accent1"/>
+          </a:fillRef>
+          <a:effectRef idx="2">
+            <a:schemeClr val="accent1"/>
+          </a:effectRef>
+          <a:fontRef idx="minor">
+            <a:schemeClr val="lt1"/>
+          </a:fontRef>
+        </p:style>
+        <p:txBody>
+          <a:bodyPr rtlCol="0" anchor="ctr"/>
+          <a:lstStyle/>
+          <a:p>
+            <a:pPr algn="ctr"/>
+          </a:p>
+        </p:txBody>
+      </p:sp>
+      <p:sp>
+        <p:nvSpPr>
+          <p:cNvPr id="30" name="Rounded Rectangle 29"/>
+          <p:cNvSpPr/>
+          <p:nvPr/>
+        </p:nvSpPr>
+        <p:spPr>
+          <a:xfrm>
+            <a:off x="141440" y="6458000"/>
+            <a:ext cx="600000" cy="320000"/>
+          </a:xfrm>
+          <a:prstGeom prst="roundRect">
+            <a:avLst/>
+          </a:prstGeom>
+          <a:solidFill>
+            <a:srgbClr val="0EA5E9"/>
+          </a:solidFill>
+          <a:ln w="12700">
+            <a:solidFill>
+              <a:srgbClr val="D4AF37"/>
+            </a:solidFill>
+          </a:ln>
+          <a:effectLst/>
+        </p:spPr>
+        <p:style>
+          <a:lnRef idx="1">
+            <a:schemeClr val="accent1"/>
+          </a:lnRef>
+          <a:fillRef idx="3">
+            <a:schemeClr val="accent1"/>
+          </a:fillRef>
+          <a:effectRef idx="2">
+            <a:schemeClr val="accent1"/>
+          </a:effectRef>
+          <a:fontRef idx="minor">
+            <a:schemeClr val="lt1"/>
+          </a:fontRef>
+        </p:style>
+        <p:txBody>
+          <a:bodyPr rtlCol="0" anchor="ctr" lIns="0" rIns="0" tIns="0" bIns="0"/>
+          <a:lstStyle/>
+          <a:p>
+            <a:pPr algn="ctr"/>
+            <a:r>
+              <a:rPr b="1" sz="1400">
+                <a:solidFill>
+                  <a:srgbClr val="FFFFFF"/>
+                </a:solidFill>
+              </a:rPr>
+              <a:t>04</a:t>
+            </a:r>
+          </a:p>
+        </p:txBody>
+      </p:sp>
     </p:spTree>
   </p:cSld>
   <p:clrMapOvr>
@@ -21379,6 +23633,104 @@
           </a:p>
         </p:txBody>
       </p:sp>
+      <p:sp>
+        <p:nvSpPr>
+          <p:cNvPr id="28" name="Rectangle 27"/>
+          <p:cNvSpPr/>
+          <p:nvPr/>
+        </p:nvSpPr>
+        <p:spPr>
+          <a:xfrm>
+            <a:off x="0" y="0"/>
+            <a:ext cx="91440" cy="6858000"/>
+          </a:xfrm>
+          <a:prstGeom prst="rect">
+            <a:avLst/>
+          </a:prstGeom>
+          <a:solidFill>
+            <a:srgbClr val="D4AF37"/>
+          </a:solidFill>
+          <a:ln>
+            <a:noFill/>
+          </a:ln>
+          <a:effectLst/>
+        </p:spPr>
+        <p:style>
+          <a:lnRef idx="1">
+            <a:schemeClr val="accent1"/>
+          </a:lnRef>
+          <a:fillRef idx="3">
+            <a:schemeClr val="accent1"/>
+          </a:fillRef>
+          <a:effectRef idx="2">
+            <a:schemeClr val="accent1"/>
+          </a:effectRef>
+          <a:fontRef idx="minor">
+            <a:schemeClr val="lt1"/>
+          </a:fontRef>
+        </p:style>
+        <p:txBody>
+          <a:bodyPr rtlCol="0" anchor="ctr"/>
+          <a:lstStyle/>
+          <a:p>
+            <a:pPr algn="ctr"/>
+          </a:p>
+        </p:txBody>
+      </p:sp>
+      <p:sp>
+        <p:nvSpPr>
+          <p:cNvPr id="29" name="Rounded Rectangle 28"/>
+          <p:cNvSpPr/>
+          <p:nvPr/>
+        </p:nvSpPr>
+        <p:spPr>
+          <a:xfrm>
+            <a:off x="141440" y="6458000"/>
+            <a:ext cx="600000" cy="320000"/>
+          </a:xfrm>
+          <a:prstGeom prst="roundRect">
+            <a:avLst/>
+          </a:prstGeom>
+          <a:solidFill>
+            <a:srgbClr val="0EA5E9"/>
+          </a:solidFill>
+          <a:ln w="12700">
+            <a:solidFill>
+              <a:srgbClr val="D4AF37"/>
+            </a:solidFill>
+          </a:ln>
+          <a:effectLst/>
+        </p:spPr>
+        <p:style>
+          <a:lnRef idx="1">
+            <a:schemeClr val="accent1"/>
+          </a:lnRef>
+          <a:fillRef idx="3">
+            <a:schemeClr val="accent1"/>
+          </a:fillRef>
+          <a:effectRef idx="2">
+            <a:schemeClr val="accent1"/>
+          </a:effectRef>
+          <a:fontRef idx="minor">
+            <a:schemeClr val="lt1"/>
+          </a:fontRef>
+        </p:style>
+        <p:txBody>
+          <a:bodyPr rtlCol="0" anchor="ctr" lIns="0" rIns="0" tIns="0" bIns="0"/>
+          <a:lstStyle/>
+          <a:p>
+            <a:pPr algn="ctr"/>
+            <a:r>
+              <a:rPr b="1" sz="1400">
+                <a:solidFill>
+                  <a:srgbClr val="FFFFFF"/>
+                </a:solidFill>
+              </a:rPr>
+              <a:t>05</a:t>
+            </a:r>
+          </a:p>
+        </p:txBody>
+      </p:sp>
     </p:spTree>
   </p:cSld>
   <p:clrMapOvr>
@@ -22256,6 +24608,104 @@
           </a:p>
         </p:txBody>
       </p:sp>
+      <p:sp>
+        <p:nvSpPr>
+          <p:cNvPr id="20" name="Rectangle 19"/>
+          <p:cNvSpPr/>
+          <p:nvPr/>
+        </p:nvSpPr>
+        <p:spPr>
+          <a:xfrm>
+            <a:off x="0" y="0"/>
+            <a:ext cx="91440" cy="6858000"/>
+          </a:xfrm>
+          <a:prstGeom prst="rect">
+            <a:avLst/>
+          </a:prstGeom>
+          <a:solidFill>
+            <a:srgbClr val="D4AF37"/>
+          </a:solidFill>
+          <a:ln>
+            <a:noFill/>
+          </a:ln>
+          <a:effectLst/>
+        </p:spPr>
+        <p:style>
+          <a:lnRef idx="1">
+            <a:schemeClr val="accent1"/>
+          </a:lnRef>
+          <a:fillRef idx="3">
+            <a:schemeClr val="accent1"/>
+          </a:fillRef>
+          <a:effectRef idx="2">
+            <a:schemeClr val="accent1"/>
+          </a:effectRef>
+          <a:fontRef idx="minor">
+            <a:schemeClr val="lt1"/>
+          </a:fontRef>
+        </p:style>
+        <p:txBody>
+          <a:bodyPr rtlCol="0" anchor="ctr"/>
+          <a:lstStyle/>
+          <a:p>
+            <a:pPr algn="ctr"/>
+          </a:p>
+        </p:txBody>
+      </p:sp>
+      <p:sp>
+        <p:nvSpPr>
+          <p:cNvPr id="21" name="Rounded Rectangle 20"/>
+          <p:cNvSpPr/>
+          <p:nvPr/>
+        </p:nvSpPr>
+        <p:spPr>
+          <a:xfrm>
+            <a:off x="141440" y="6458000"/>
+            <a:ext cx="600000" cy="320000"/>
+          </a:xfrm>
+          <a:prstGeom prst="roundRect">
+            <a:avLst/>
+          </a:prstGeom>
+          <a:solidFill>
+            <a:srgbClr val="0EA5E9"/>
+          </a:solidFill>
+          <a:ln w="12700">
+            <a:solidFill>
+              <a:srgbClr val="D4AF37"/>
+            </a:solidFill>
+          </a:ln>
+          <a:effectLst/>
+        </p:spPr>
+        <p:style>
+          <a:lnRef idx="1">
+            <a:schemeClr val="accent1"/>
+          </a:lnRef>
+          <a:fillRef idx="3">
+            <a:schemeClr val="accent1"/>
+          </a:fillRef>
+          <a:effectRef idx="2">
+            <a:schemeClr val="accent1"/>
+          </a:effectRef>
+          <a:fontRef idx="minor">
+            <a:schemeClr val="lt1"/>
+          </a:fontRef>
+        </p:style>
+        <p:txBody>
+          <a:bodyPr rtlCol="0" anchor="ctr" lIns="0" rIns="0" tIns="0" bIns="0"/>
+          <a:lstStyle/>
+          <a:p>
+            <a:pPr algn="ctr"/>
+            <a:r>
+              <a:rPr b="1" sz="1400">
+                <a:solidFill>
+                  <a:srgbClr val="FFFFFF"/>
+                </a:solidFill>
+              </a:rPr>
+              <a:t>06</a:t>
+            </a:r>
+          </a:p>
+        </p:txBody>
+      </p:sp>
     </p:spTree>
   </p:cSld>
   <p:clrMapOvr>
@@ -23274,6 +25724,104 @@
           </a:p>
         </p:txBody>
       </p:sp>
+      <p:sp>
+        <p:nvSpPr>
+          <p:cNvPr id="23" name="Rectangle 22"/>
+          <p:cNvSpPr/>
+          <p:nvPr/>
+        </p:nvSpPr>
+        <p:spPr>
+          <a:xfrm>
+            <a:off x="0" y="0"/>
+            <a:ext cx="91440" cy="6858000"/>
+          </a:xfrm>
+          <a:prstGeom prst="rect">
+            <a:avLst/>
+          </a:prstGeom>
+          <a:solidFill>
+            <a:srgbClr val="D4AF37"/>
+          </a:solidFill>
+          <a:ln>
+            <a:noFill/>
+          </a:ln>
+          <a:effectLst/>
+        </p:spPr>
+        <p:style>
+          <a:lnRef idx="1">
+            <a:schemeClr val="accent1"/>
+          </a:lnRef>
+          <a:fillRef idx="3">
+            <a:schemeClr val="accent1"/>
+          </a:fillRef>
+          <a:effectRef idx="2">
+            <a:schemeClr val="accent1"/>
+          </a:effectRef>
+          <a:fontRef idx="minor">
+            <a:schemeClr val="lt1"/>
+          </a:fontRef>
+        </p:style>
+        <p:txBody>
+          <a:bodyPr rtlCol="0" anchor="ctr"/>
+          <a:lstStyle/>
+          <a:p>
+            <a:pPr algn="ctr"/>
+          </a:p>
+        </p:txBody>
+      </p:sp>
+      <p:sp>
+        <p:nvSpPr>
+          <p:cNvPr id="24" name="Rounded Rectangle 23"/>
+          <p:cNvSpPr/>
+          <p:nvPr/>
+        </p:nvSpPr>
+        <p:spPr>
+          <a:xfrm>
+            <a:off x="141440" y="6458000"/>
+            <a:ext cx="600000" cy="320000"/>
+          </a:xfrm>
+          <a:prstGeom prst="roundRect">
+            <a:avLst/>
+          </a:prstGeom>
+          <a:solidFill>
+            <a:srgbClr val="0EA5E9"/>
+          </a:solidFill>
+          <a:ln w="12700">
+            <a:solidFill>
+              <a:srgbClr val="D4AF37"/>
+            </a:solidFill>
+          </a:ln>
+          <a:effectLst/>
+        </p:spPr>
+        <p:style>
+          <a:lnRef idx="1">
+            <a:schemeClr val="accent1"/>
+          </a:lnRef>
+          <a:fillRef idx="3">
+            <a:schemeClr val="accent1"/>
+          </a:fillRef>
+          <a:effectRef idx="2">
+            <a:schemeClr val="accent1"/>
+          </a:effectRef>
+          <a:fontRef idx="minor">
+            <a:schemeClr val="lt1"/>
+          </a:fontRef>
+        </p:style>
+        <p:txBody>
+          <a:bodyPr rtlCol="0" anchor="ctr" lIns="0" rIns="0" tIns="0" bIns="0"/>
+          <a:lstStyle/>
+          <a:p>
+            <a:pPr algn="ctr"/>
+            <a:r>
+              <a:rPr b="1" sz="1400">
+                <a:solidFill>
+                  <a:srgbClr val="FFFFFF"/>
+                </a:solidFill>
+              </a:rPr>
+              <a:t>07</a:t>
+            </a:r>
+          </a:p>
+        </p:txBody>
+      </p:sp>
     </p:spTree>
   </p:cSld>
   <p:clrMapOvr>
@@ -24112,6 +26660,104 @@
           </a:p>
         </p:txBody>
       </p:sp>
+      <p:sp>
+        <p:nvSpPr>
+          <p:cNvPr id="20" name="Rectangle 19"/>
+          <p:cNvSpPr/>
+          <p:nvPr/>
+        </p:nvSpPr>
+        <p:spPr>
+          <a:xfrm>
+            <a:off x="0" y="0"/>
+            <a:ext cx="91440" cy="6858000"/>
+          </a:xfrm>
+          <a:prstGeom prst="rect">
+            <a:avLst/>
+          </a:prstGeom>
+          <a:solidFill>
+            <a:srgbClr val="D4AF37"/>
+          </a:solidFill>
+          <a:ln>
+            <a:noFill/>
+          </a:ln>
+          <a:effectLst/>
+        </p:spPr>
+        <p:style>
+          <a:lnRef idx="1">
+            <a:schemeClr val="accent1"/>
+          </a:lnRef>
+          <a:fillRef idx="3">
+            <a:schemeClr val="accent1"/>
+          </a:fillRef>
+          <a:effectRef idx="2">
+            <a:schemeClr val="accent1"/>
+          </a:effectRef>
+          <a:fontRef idx="minor">
+            <a:schemeClr val="lt1"/>
+          </a:fontRef>
+        </p:style>
+        <p:txBody>
+          <a:bodyPr rtlCol="0" anchor="ctr"/>
+          <a:lstStyle/>
+          <a:p>
+            <a:pPr algn="ctr"/>
+          </a:p>
+        </p:txBody>
+      </p:sp>
+      <p:sp>
+        <p:nvSpPr>
+          <p:cNvPr id="21" name="Rounded Rectangle 20"/>
+          <p:cNvSpPr/>
+          <p:nvPr/>
+        </p:nvSpPr>
+        <p:spPr>
+          <a:xfrm>
+            <a:off x="141440" y="6458000"/>
+            <a:ext cx="600000" cy="320000"/>
+          </a:xfrm>
+          <a:prstGeom prst="roundRect">
+            <a:avLst/>
+          </a:prstGeom>
+          <a:solidFill>
+            <a:srgbClr val="0EA5E9"/>
+          </a:solidFill>
+          <a:ln w="12700">
+            <a:solidFill>
+              <a:srgbClr val="D4AF37"/>
+            </a:solidFill>
+          </a:ln>
+          <a:effectLst/>
+        </p:spPr>
+        <p:style>
+          <a:lnRef idx="1">
+            <a:schemeClr val="accent1"/>
+          </a:lnRef>
+          <a:fillRef idx="3">
+            <a:schemeClr val="accent1"/>
+          </a:fillRef>
+          <a:effectRef idx="2">
+            <a:schemeClr val="accent1"/>
+          </a:effectRef>
+          <a:fontRef idx="minor">
+            <a:schemeClr val="lt1"/>
+          </a:fontRef>
+        </p:style>
+        <p:txBody>
+          <a:bodyPr rtlCol="0" anchor="ctr" lIns="0" rIns="0" tIns="0" bIns="0"/>
+          <a:lstStyle/>
+          <a:p>
+            <a:pPr algn="ctr"/>
+            <a:r>
+              <a:rPr b="1" sz="1400">
+                <a:solidFill>
+                  <a:srgbClr val="FFFFFF"/>
+                </a:solidFill>
+              </a:rPr>
+              <a:t>08</a:t>
+            </a:r>
+          </a:p>
+        </p:txBody>
+      </p:sp>
     </p:spTree>
   </p:cSld>
   <p:clrMapOvr>
@@ -24525,6 +27171,104 @@
                 <a:latin typeface="Calibri"/>
               </a:rPr>
               <a:t>9 / 28</a:t>
+            </a:r>
+          </a:p>
+        </p:txBody>
+      </p:sp>
+      <p:sp>
+        <p:nvSpPr>
+          <p:cNvPr id="12" name="Rectangle 11"/>
+          <p:cNvSpPr/>
+          <p:nvPr/>
+        </p:nvSpPr>
+        <p:spPr>
+          <a:xfrm>
+            <a:off x="0" y="0"/>
+            <a:ext cx="91440" cy="6858000"/>
+          </a:xfrm>
+          <a:prstGeom prst="rect">
+            <a:avLst/>
+          </a:prstGeom>
+          <a:solidFill>
+            <a:srgbClr val="D4AF37"/>
+          </a:solidFill>
+          <a:ln>
+            <a:noFill/>
+          </a:ln>
+          <a:effectLst/>
+        </p:spPr>
+        <p:style>
+          <a:lnRef idx="1">
+            <a:schemeClr val="accent1"/>
+          </a:lnRef>
+          <a:fillRef idx="3">
+            <a:schemeClr val="accent1"/>
+          </a:fillRef>
+          <a:effectRef idx="2">
+            <a:schemeClr val="accent1"/>
+          </a:effectRef>
+          <a:fontRef idx="minor">
+            <a:schemeClr val="lt1"/>
+          </a:fontRef>
+        </p:style>
+        <p:txBody>
+          <a:bodyPr rtlCol="0" anchor="ctr"/>
+          <a:lstStyle/>
+          <a:p>
+            <a:pPr algn="ctr"/>
+          </a:p>
+        </p:txBody>
+      </p:sp>
+      <p:sp>
+        <p:nvSpPr>
+          <p:cNvPr id="13" name="Rounded Rectangle 12"/>
+          <p:cNvSpPr/>
+          <p:nvPr/>
+        </p:nvSpPr>
+        <p:spPr>
+          <a:xfrm>
+            <a:off x="141440" y="6458000"/>
+            <a:ext cx="600000" cy="320000"/>
+          </a:xfrm>
+          <a:prstGeom prst="roundRect">
+            <a:avLst/>
+          </a:prstGeom>
+          <a:solidFill>
+            <a:srgbClr val="0EA5E9"/>
+          </a:solidFill>
+          <a:ln w="12700">
+            <a:solidFill>
+              <a:srgbClr val="D4AF37"/>
+            </a:solidFill>
+          </a:ln>
+          <a:effectLst/>
+        </p:spPr>
+        <p:style>
+          <a:lnRef idx="1">
+            <a:schemeClr val="accent1"/>
+          </a:lnRef>
+          <a:fillRef idx="3">
+            <a:schemeClr val="accent1"/>
+          </a:fillRef>
+          <a:effectRef idx="2">
+            <a:schemeClr val="accent1"/>
+          </a:effectRef>
+          <a:fontRef idx="minor">
+            <a:schemeClr val="lt1"/>
+          </a:fontRef>
+        </p:style>
+        <p:txBody>
+          <a:bodyPr rtlCol="0" anchor="ctr" lIns="0" rIns="0" tIns="0" bIns="0"/>
+          <a:lstStyle/>
+          <a:p>
+            <a:pPr algn="ctr"/>
+            <a:r>
+              <a:rPr b="1" sz="1400">
+                <a:solidFill>
+                  <a:srgbClr val="FFFFFF"/>
+                </a:solidFill>
+              </a:rPr>
+              <a:t>09</a:t>
             </a:r>
           </a:p>
         </p:txBody>

</xml_diff>

<commit_message>
Fix critical legibility bug: 109 text runs that were white/light-gray on the now-bright canvas were invisible - darkened+bolded all body text/bullets/footers that sit on plain background, while preserving white text that legitimately sits on the blue panels
</commit_message>
<xml_diff>
--- a/avm_morgan_docs/AVM_MORGAN_SECURITY_KEYNOTE_30MIN_v3_WITH_REFERENCES.pptx
+++ b/avm_morgan_docs/AVM_MORGAN_SECURITY_KEYNOTE_30MIN_v3_WITH_REFERENCES.pptx
@@ -3812,9 +3812,9 @@
               </a:lnSpc>
             </a:pPr>
             <a:r>
-              <a:rPr sz="2000" b="0" i="0">
-                <a:solidFill>
-                  <a:srgbClr val="9AA5B1"/>
+              <a:rPr sz="2000" b="1" i="0">
+                <a:solidFill>
+                  <a:srgbClr val="0B1F3A"/>
                 </a:solidFill>
                 <a:latin typeface="Calibri"/>
               </a:rPr>
@@ -3851,9 +3851,9 @@
               </a:lnSpc>
             </a:pPr>
             <a:r>
-              <a:rPr sz="2000" b="0" i="0">
-                <a:solidFill>
-                  <a:srgbClr val="9AA5B1"/>
+              <a:rPr sz="2000" b="1" i="0">
+                <a:solidFill>
+                  <a:srgbClr val="0B1F3A"/>
                 </a:solidFill>
                 <a:latin typeface="Calibri"/>
               </a:rPr>
@@ -3893,9 +3893,9 @@
               </a:spcAft>
             </a:pPr>
             <a:r>
-              <a:rPr sz="2000">
-                <a:solidFill>
-                  <a:srgbClr val="FFFFFF"/>
+              <a:rPr sz="2000" b="1">
+                <a:solidFill>
+                  <a:srgbClr val="0B1F3A"/>
                 </a:solidFill>
                 <a:latin typeface="Calibri"/>
               </a:rPr>
@@ -3912,9 +3912,9 @@
               </a:spcAft>
             </a:pPr>
             <a:r>
-              <a:rPr sz="2000">
-                <a:solidFill>
-                  <a:srgbClr val="FFFFFF"/>
+              <a:rPr sz="2000" b="1">
+                <a:solidFill>
+                  <a:srgbClr val="0B1F3A"/>
                 </a:solidFill>
                 <a:latin typeface="Calibri"/>
               </a:rPr>
@@ -3931,9 +3931,9 @@
               </a:spcAft>
             </a:pPr>
             <a:r>
-              <a:rPr sz="2000">
-                <a:solidFill>
-                  <a:srgbClr val="FFFFFF"/>
+              <a:rPr sz="2000" b="1">
+                <a:solidFill>
+                  <a:srgbClr val="0B1F3A"/>
                 </a:solidFill>
                 <a:latin typeface="Calibri"/>
               </a:rPr>
@@ -3950,9 +3950,9 @@
               </a:spcAft>
             </a:pPr>
             <a:r>
-              <a:rPr sz="2000">
-                <a:solidFill>
-                  <a:srgbClr val="FFFFFF"/>
+              <a:rPr sz="2000" b="1">
+                <a:solidFill>
+                  <a:srgbClr val="0B1F3A"/>
                 </a:solidFill>
                 <a:latin typeface="Calibri"/>
               </a:rPr>
@@ -3969,9 +3969,9 @@
               </a:spcAft>
             </a:pPr>
             <a:r>
-              <a:rPr sz="2000">
-                <a:solidFill>
-                  <a:srgbClr val="FFFFFF"/>
+              <a:rPr sz="2000" b="1">
+                <a:solidFill>
+                  <a:srgbClr val="0B1F3A"/>
                 </a:solidFill>
                 <a:latin typeface="Calibri"/>
               </a:rPr>
@@ -4958,9 +4958,9 @@
               </a:lnSpc>
             </a:pPr>
             <a:r>
-              <a:rPr sz="2000" b="0" i="0">
-                <a:solidFill>
-                  <a:srgbClr val="9AA5B1"/>
+              <a:rPr sz="2000" b="1" i="0">
+                <a:solidFill>
+                  <a:srgbClr val="0B1F3A"/>
                 </a:solidFill>
                 <a:latin typeface="Calibri"/>
               </a:rPr>
@@ -4997,9 +4997,9 @@
               </a:lnSpc>
             </a:pPr>
             <a:r>
-              <a:rPr sz="2000" b="0" i="0">
-                <a:solidFill>
-                  <a:srgbClr val="9AA5B1"/>
+              <a:rPr sz="2000" b="1" i="0">
+                <a:solidFill>
+                  <a:srgbClr val="0B1F3A"/>
                 </a:solidFill>
                 <a:latin typeface="Calibri"/>
               </a:rPr>
@@ -5399,9 +5399,9 @@
               </a:lnSpc>
             </a:pPr>
             <a:r>
-              <a:rPr sz="2000" b="0" i="0">
-                <a:solidFill>
-                  <a:srgbClr val="9AA5B1"/>
+              <a:rPr sz="2000" b="1" i="0">
+                <a:solidFill>
+                  <a:srgbClr val="0B1F3A"/>
                 </a:solidFill>
                 <a:latin typeface="Calibri"/>
               </a:rPr>
@@ -5800,9 +5800,9 @@
               </a:lnSpc>
             </a:pPr>
             <a:r>
-              <a:rPr sz="2000" b="0" i="0">
-                <a:solidFill>
-                  <a:srgbClr val="9AA5B1"/>
+              <a:rPr sz="2000" b="1" i="0">
+                <a:solidFill>
+                  <a:srgbClr val="0B1F3A"/>
                 </a:solidFill>
                 <a:latin typeface="Calibri"/>
               </a:rPr>
@@ -5839,9 +5839,9 @@
               </a:lnSpc>
             </a:pPr>
             <a:r>
-              <a:rPr sz="2000" b="0" i="0">
-                <a:solidFill>
-                  <a:srgbClr val="9AA5B1"/>
+              <a:rPr sz="2000" b="1" i="0">
+                <a:solidFill>
+                  <a:srgbClr val="0B1F3A"/>
                 </a:solidFill>
                 <a:latin typeface="Calibri"/>
               </a:rPr>
@@ -5919,7 +5919,7 @@
             <a:r>
               <a:rPr sz="2000" b="1" i="0">
                 <a:solidFill>
-                  <a:srgbClr val="FFFFFF"/>
+                  <a:srgbClr val="0B1F3A"/>
                 </a:solidFill>
                 <a:latin typeface="Calibri"/>
               </a:rPr>
@@ -5960,9 +5960,9 @@
               </a:spcAft>
             </a:pPr>
             <a:r>
-              <a:rPr sz="2000">
-                <a:solidFill>
-                  <a:srgbClr val="FFFFFF"/>
+              <a:rPr sz="2000" b="1">
+                <a:solidFill>
+                  <a:srgbClr val="0B1F3A"/>
                 </a:solidFill>
                 <a:latin typeface="Calibri"/>
               </a:rPr>
@@ -5979,9 +5979,9 @@
               </a:spcAft>
             </a:pPr>
             <a:r>
-              <a:rPr sz="2000">
-                <a:solidFill>
-                  <a:srgbClr val="FFFFFF"/>
+              <a:rPr sz="2000" b="1">
+                <a:solidFill>
+                  <a:srgbClr val="0B1F3A"/>
                 </a:solidFill>
                 <a:latin typeface="Calibri"/>
               </a:rPr>
@@ -5998,9 +5998,9 @@
               </a:spcAft>
             </a:pPr>
             <a:r>
-              <a:rPr sz="2000">
-                <a:solidFill>
-                  <a:srgbClr val="FFFFFF"/>
+              <a:rPr sz="2000" b="1">
+                <a:solidFill>
+                  <a:srgbClr val="0B1F3A"/>
                 </a:solidFill>
                 <a:latin typeface="Calibri"/>
               </a:rPr>
@@ -6017,9 +6017,9 @@
               </a:spcAft>
             </a:pPr>
             <a:r>
-              <a:rPr sz="2000">
-                <a:solidFill>
-                  <a:srgbClr val="FFFFFF"/>
+              <a:rPr sz="2000" b="1">
+                <a:solidFill>
+                  <a:srgbClr val="0B1F3A"/>
                 </a:solidFill>
                 <a:latin typeface="Calibri"/>
               </a:rPr>
@@ -6059,9 +6059,9 @@
               </a:spcAft>
             </a:pPr>
             <a:r>
-              <a:rPr sz="2000">
-                <a:solidFill>
-                  <a:srgbClr val="FFFFFF"/>
+              <a:rPr sz="2000" b="1">
+                <a:solidFill>
+                  <a:srgbClr val="0B1F3A"/>
                 </a:solidFill>
                 <a:latin typeface="Calibri"/>
               </a:rPr>
@@ -6078,9 +6078,9 @@
               </a:spcAft>
             </a:pPr>
             <a:r>
-              <a:rPr sz="2000">
-                <a:solidFill>
-                  <a:srgbClr val="FFFFFF"/>
+              <a:rPr sz="2000" b="1">
+                <a:solidFill>
+                  <a:srgbClr val="0B1F3A"/>
                 </a:solidFill>
                 <a:latin typeface="Calibri"/>
               </a:rPr>
@@ -6097,9 +6097,9 @@
               </a:spcAft>
             </a:pPr>
             <a:r>
-              <a:rPr sz="2000">
-                <a:solidFill>
-                  <a:srgbClr val="FFFFFF"/>
+              <a:rPr sz="2000" b="1">
+                <a:solidFill>
+                  <a:srgbClr val="0B1F3A"/>
                 </a:solidFill>
                 <a:latin typeface="Calibri"/>
               </a:rPr>
@@ -6116,9 +6116,9 @@
               </a:spcAft>
             </a:pPr>
             <a:r>
-              <a:rPr sz="2000">
-                <a:solidFill>
-                  <a:srgbClr val="FFFFFF"/>
+              <a:rPr sz="2000" b="1">
+                <a:solidFill>
+                  <a:srgbClr val="0B1F3A"/>
                 </a:solidFill>
                 <a:latin typeface="Calibri"/>
               </a:rPr>
@@ -6562,9 +6562,9 @@
               </a:lnSpc>
             </a:pPr>
             <a:r>
-              <a:rPr sz="2000" b="0" i="0">
-                <a:solidFill>
-                  <a:srgbClr val="9AA5B1"/>
+              <a:rPr sz="2000" b="1" i="0">
+                <a:solidFill>
+                  <a:srgbClr val="0B1F3A"/>
                 </a:solidFill>
                 <a:latin typeface="Calibri"/>
               </a:rPr>
@@ -6601,9 +6601,9 @@
               </a:lnSpc>
             </a:pPr>
             <a:r>
-              <a:rPr sz="2000" b="0" i="0">
-                <a:solidFill>
-                  <a:srgbClr val="9AA5B1"/>
+              <a:rPr sz="2000" b="1" i="0">
+                <a:solidFill>
+                  <a:srgbClr val="0B1F3A"/>
                 </a:solidFill>
                 <a:latin typeface="Calibri"/>
               </a:rPr>
@@ -7536,9 +7536,9 @@
               </a:lnSpc>
             </a:pPr>
             <a:r>
-              <a:rPr sz="2000" b="0" i="0">
-                <a:solidFill>
-                  <a:srgbClr val="9AA5B1"/>
+              <a:rPr sz="2000" b="1" i="0">
+                <a:solidFill>
+                  <a:srgbClr val="0B1F3A"/>
                 </a:solidFill>
                 <a:latin typeface="Calibri"/>
               </a:rPr>
@@ -7575,9 +7575,9 @@
               </a:lnSpc>
             </a:pPr>
             <a:r>
-              <a:rPr sz="2000" b="0" i="0">
-                <a:solidFill>
-                  <a:srgbClr val="9AA5B1"/>
+              <a:rPr sz="2000" b="1" i="0">
+                <a:solidFill>
+                  <a:srgbClr val="0B1F3A"/>
                 </a:solidFill>
                 <a:latin typeface="Calibri"/>
               </a:rPr>
@@ -7617,9 +7617,9 @@
               </a:spcAft>
             </a:pPr>
             <a:r>
-              <a:rPr sz="2000">
-                <a:solidFill>
-                  <a:srgbClr val="FFFFFF"/>
+              <a:rPr sz="2000" b="1">
+                <a:solidFill>
+                  <a:srgbClr val="0B1F3A"/>
                 </a:solidFill>
                 <a:latin typeface="Calibri"/>
               </a:rPr>
@@ -7636,9 +7636,9 @@
               </a:spcAft>
             </a:pPr>
             <a:r>
-              <a:rPr sz="2000">
-                <a:solidFill>
-                  <a:srgbClr val="FFFFFF"/>
+              <a:rPr sz="2000" b="1">
+                <a:solidFill>
+                  <a:srgbClr val="0B1F3A"/>
                 </a:solidFill>
                 <a:latin typeface="Calibri"/>
               </a:rPr>
@@ -7655,9 +7655,9 @@
               </a:spcAft>
             </a:pPr>
             <a:r>
-              <a:rPr sz="2000">
-                <a:solidFill>
-                  <a:srgbClr val="FFFFFF"/>
+              <a:rPr sz="2000" b="1">
+                <a:solidFill>
+                  <a:srgbClr val="0B1F3A"/>
                 </a:solidFill>
                 <a:latin typeface="Calibri"/>
               </a:rPr>
@@ -8224,9 +8224,9 @@
               </a:lnSpc>
             </a:pPr>
             <a:r>
-              <a:rPr sz="2000" b="0" i="0">
-                <a:solidFill>
-                  <a:srgbClr val="9AA5B1"/>
+              <a:rPr sz="2000" b="1" i="0">
+                <a:solidFill>
+                  <a:srgbClr val="0B1F3A"/>
                 </a:solidFill>
                 <a:latin typeface="Calibri"/>
               </a:rPr>
@@ -8263,9 +8263,9 @@
               </a:lnSpc>
             </a:pPr>
             <a:r>
-              <a:rPr sz="2000" b="0" i="0">
-                <a:solidFill>
-                  <a:srgbClr val="9AA5B1"/>
+              <a:rPr sz="2000" b="1" i="0">
+                <a:solidFill>
+                  <a:srgbClr val="0B1F3A"/>
                 </a:solidFill>
                 <a:latin typeface="Calibri"/>
               </a:rPr>
@@ -8304,7 +8304,7 @@
             <a:r>
               <a:rPr sz="2000" b="1" i="0">
                 <a:solidFill>
-                  <a:srgbClr val="FFFFFF"/>
+                  <a:srgbClr val="0B1F3A"/>
                 </a:solidFill>
                 <a:latin typeface="Calibri"/>
               </a:rPr>
@@ -8421,7 +8421,7 @@
             <a:r>
               <a:rPr sz="2000" b="1" i="0">
                 <a:solidFill>
-                  <a:srgbClr val="FFFFFF"/>
+                  <a:srgbClr val="0B1F3A"/>
                 </a:solidFill>
                 <a:latin typeface="Calibri"/>
               </a:rPr>
@@ -8538,7 +8538,7 @@
             <a:r>
               <a:rPr sz="2000" b="1" i="0">
                 <a:solidFill>
-                  <a:srgbClr val="FFFFFF"/>
+                  <a:srgbClr val="0B1F3A"/>
                 </a:solidFill>
                 <a:latin typeface="Calibri"/>
               </a:rPr>
@@ -8655,7 +8655,7 @@
             <a:r>
               <a:rPr sz="2000" b="1" i="0">
                 <a:solidFill>
-                  <a:srgbClr val="FFFFFF"/>
+                  <a:srgbClr val="0B1F3A"/>
                 </a:solidFill>
                 <a:latin typeface="Calibri"/>
               </a:rPr>
@@ -8772,7 +8772,7 @@
             <a:r>
               <a:rPr sz="2000" b="1" i="0">
                 <a:solidFill>
-                  <a:srgbClr val="FFFFFF"/>
+                  <a:srgbClr val="0B1F3A"/>
                 </a:solidFill>
                 <a:latin typeface="Calibri"/>
               </a:rPr>
@@ -8889,7 +8889,7 @@
             <a:r>
               <a:rPr sz="2000" b="1" i="0">
                 <a:solidFill>
-                  <a:srgbClr val="FFFFFF"/>
+                  <a:srgbClr val="0B1F3A"/>
                 </a:solidFill>
                 <a:latin typeface="Calibri"/>
               </a:rPr>
@@ -9006,7 +9006,7 @@
             <a:r>
               <a:rPr sz="2000" b="1" i="0">
                 <a:solidFill>
-                  <a:srgbClr val="FFFFFF"/>
+                  <a:srgbClr val="0B1F3A"/>
                 </a:solidFill>
                 <a:latin typeface="Calibri"/>
               </a:rPr>
@@ -9405,9 +9405,9 @@
               </a:lnSpc>
             </a:pPr>
             <a:r>
-              <a:rPr sz="2000" b="0" i="0">
-                <a:solidFill>
-                  <a:srgbClr val="9AA5B1"/>
+              <a:rPr sz="2000" b="1" i="0">
+                <a:solidFill>
+                  <a:srgbClr val="0B1F3A"/>
                 </a:solidFill>
                 <a:latin typeface="Calibri"/>
               </a:rPr>
@@ -9444,9 +9444,9 @@
               </a:lnSpc>
             </a:pPr>
             <a:r>
-              <a:rPr sz="2000" b="0" i="0">
-                <a:solidFill>
-                  <a:srgbClr val="9AA5B1"/>
+              <a:rPr sz="2000" b="1" i="0">
+                <a:solidFill>
+                  <a:srgbClr val="0B1F3A"/>
                 </a:solidFill>
                 <a:latin typeface="Calibri"/>
               </a:rPr>
@@ -9483,9 +9483,9 @@
               </a:lnSpc>
             </a:pPr>
             <a:r>
-              <a:rPr sz="2000" b="0" i="1">
-                <a:solidFill>
-                  <a:srgbClr val="E8EAEE"/>
+              <a:rPr sz="2000" b="1" i="1">
+                <a:solidFill>
+                  <a:srgbClr val="0B1F3A"/>
                 </a:solidFill>
                 <a:latin typeface="Calibri"/>
               </a:rPr>
@@ -10405,9 +10405,9 @@
               </a:lnSpc>
             </a:pPr>
             <a:r>
-              <a:rPr sz="2000" b="0" i="0">
-                <a:solidFill>
-                  <a:srgbClr val="9AA5B1"/>
+              <a:rPr sz="2000" b="1" i="0">
+                <a:solidFill>
+                  <a:srgbClr val="0B1F3A"/>
                 </a:solidFill>
                 <a:latin typeface="Calibri"/>
               </a:rPr>
@@ -10444,9 +10444,9 @@
               </a:lnSpc>
             </a:pPr>
             <a:r>
-              <a:rPr sz="2000" b="0" i="0">
-                <a:solidFill>
-                  <a:srgbClr val="9AA5B1"/>
+              <a:rPr sz="2000" b="1" i="0">
+                <a:solidFill>
+                  <a:srgbClr val="0B1F3A"/>
                 </a:solidFill>
                 <a:latin typeface="Calibri"/>
               </a:rPr>
@@ -11356,9 +11356,9 @@
               </a:lnSpc>
             </a:pPr>
             <a:r>
-              <a:rPr sz="2000" b="0" i="0">
-                <a:solidFill>
-                  <a:srgbClr val="9AA5B1"/>
+              <a:rPr sz="2000" b="1" i="0">
+                <a:solidFill>
+                  <a:srgbClr val="0B1F3A"/>
                 </a:solidFill>
                 <a:latin typeface="Calibri"/>
               </a:rPr>
@@ -11395,9 +11395,9 @@
               </a:lnSpc>
             </a:pPr>
             <a:r>
-              <a:rPr sz="2000" b="0" i="0">
-                <a:solidFill>
-                  <a:srgbClr val="9AA5B1"/>
+              <a:rPr sz="2000" b="1" i="0">
+                <a:solidFill>
+                  <a:srgbClr val="0B1F3A"/>
                 </a:solidFill>
                 <a:latin typeface="Calibri"/>
               </a:rPr>
@@ -12200,9 +12200,9 @@
               </a:lnSpc>
             </a:pPr>
             <a:r>
-              <a:rPr sz="2000" b="0" i="0">
-                <a:solidFill>
-                  <a:srgbClr val="9AA5B1"/>
+              <a:rPr sz="2000" b="1" i="0">
+                <a:solidFill>
+                  <a:srgbClr val="0B1F3A"/>
                 </a:solidFill>
                 <a:latin typeface="Calibri"/>
               </a:rPr>
@@ -12239,9 +12239,9 @@
               </a:lnSpc>
             </a:pPr>
             <a:r>
-              <a:rPr sz="2000" b="0" i="0">
-                <a:solidFill>
-                  <a:srgbClr val="9AA5B1"/>
+              <a:rPr sz="2000" b="1" i="0">
+                <a:solidFill>
+                  <a:srgbClr val="0B1F3A"/>
                 </a:solidFill>
                 <a:latin typeface="Calibri"/>
               </a:rPr>
@@ -13010,9 +13010,9 @@
               </a:lnSpc>
             </a:pPr>
             <a:r>
-              <a:rPr sz="2000" b="0" i="0">
-                <a:solidFill>
-                  <a:srgbClr val="9AA5B1"/>
+              <a:rPr sz="2000" b="1" i="0">
+                <a:solidFill>
+                  <a:srgbClr val="0B1F3A"/>
                 </a:solidFill>
                 <a:latin typeface="Calibri"/>
               </a:rPr>
@@ -13049,9 +13049,9 @@
               </a:lnSpc>
             </a:pPr>
             <a:r>
-              <a:rPr sz="2000" b="0" i="0">
-                <a:solidFill>
-                  <a:srgbClr val="9AA5B1"/>
+              <a:rPr sz="2000" b="1" i="0">
+                <a:solidFill>
+                  <a:srgbClr val="0B1F3A"/>
                 </a:solidFill>
                 <a:latin typeface="Calibri"/>
               </a:rPr>
@@ -13813,9 +13813,9 @@
               </a:lnSpc>
             </a:pPr>
             <a:r>
-              <a:rPr sz="2000" b="0" i="0">
-                <a:solidFill>
-                  <a:srgbClr val="9AA5B1"/>
+              <a:rPr sz="2000" b="1" i="0">
+                <a:solidFill>
+                  <a:srgbClr val="0B1F3A"/>
                 </a:solidFill>
                 <a:latin typeface="Calibri"/>
               </a:rPr>
@@ -13852,9 +13852,9 @@
               </a:lnSpc>
             </a:pPr>
             <a:r>
-              <a:rPr sz="2000" b="0" i="0">
-                <a:solidFill>
-                  <a:srgbClr val="9AA5B1"/>
+              <a:rPr sz="2000" b="1" i="0">
+                <a:solidFill>
+                  <a:srgbClr val="0B1F3A"/>
                 </a:solidFill>
                 <a:latin typeface="Calibri"/>
               </a:rPr>
@@ -14622,9 +14622,9 @@
               </a:lnSpc>
             </a:pPr>
             <a:r>
-              <a:rPr sz="2000" b="0" i="0">
-                <a:solidFill>
-                  <a:srgbClr val="9AA5B1"/>
+              <a:rPr sz="2000" b="1" i="0">
+                <a:solidFill>
+                  <a:srgbClr val="0B1F3A"/>
                 </a:solidFill>
                 <a:latin typeface="Calibri"/>
               </a:rPr>
@@ -14661,9 +14661,9 @@
               </a:lnSpc>
             </a:pPr>
             <a:r>
-              <a:rPr sz="2000" b="0" i="0">
-                <a:solidFill>
-                  <a:srgbClr val="9AA5B1"/>
+              <a:rPr sz="2000" b="1" i="0">
+                <a:solidFill>
+                  <a:srgbClr val="0B1F3A"/>
                 </a:solidFill>
                 <a:latin typeface="Calibri"/>
               </a:rPr>
@@ -15296,9 +15296,9 @@
               </a:lnSpc>
             </a:pPr>
             <a:r>
-              <a:rPr sz="2000" b="0" i="0">
-                <a:solidFill>
-                  <a:srgbClr val="9AA5B1"/>
+              <a:rPr sz="2000" b="1" i="0">
+                <a:solidFill>
+                  <a:srgbClr val="0B1F3A"/>
                 </a:solidFill>
                 <a:latin typeface="Calibri"/>
               </a:rPr>
@@ -15335,9 +15335,9 @@
               </a:lnSpc>
             </a:pPr>
             <a:r>
-              <a:rPr sz="2000" b="0" i="0">
-                <a:solidFill>
-                  <a:srgbClr val="9AA5B1"/>
+              <a:rPr sz="2000" b="1" i="0">
+                <a:solidFill>
+                  <a:srgbClr val="0B1F3A"/>
                 </a:solidFill>
                 <a:latin typeface="Calibri"/>
               </a:rPr>
@@ -15638,9 +15638,9 @@
               </a:lnSpc>
             </a:pPr>
             <a:r>
-              <a:rPr sz="2000" b="0" i="1">
-                <a:solidFill>
-                  <a:srgbClr val="FFFFFF"/>
+              <a:rPr sz="2000" b="1" i="1">
+                <a:solidFill>
+                  <a:srgbClr val="0B1F3A"/>
                 </a:solidFill>
                 <a:latin typeface="Calibri"/>
               </a:rPr>
@@ -16039,9 +16039,9 @@
               </a:lnSpc>
             </a:pPr>
             <a:r>
-              <a:rPr sz="2000" b="0" i="0">
-                <a:solidFill>
-                  <a:srgbClr val="9AA5B1"/>
+              <a:rPr sz="2000" b="1" i="0">
+                <a:solidFill>
+                  <a:srgbClr val="0B1F3A"/>
                 </a:solidFill>
                 <a:latin typeface="Calibri"/>
               </a:rPr>
@@ -16078,9 +16078,9 @@
               </a:lnSpc>
             </a:pPr>
             <a:r>
-              <a:rPr sz="2000" b="0" i="0">
-                <a:solidFill>
-                  <a:srgbClr val="9AA5B1"/>
+              <a:rPr sz="2000" b="1" i="0">
+                <a:solidFill>
+                  <a:srgbClr val="0B1F3A"/>
                 </a:solidFill>
                 <a:latin typeface="Calibri"/>
               </a:rPr>
@@ -17099,9 +17099,9 @@
               </a:lnSpc>
             </a:pPr>
             <a:r>
-              <a:rPr sz="2000" b="0" i="0">
-                <a:solidFill>
-                  <a:srgbClr val="9AA5B1"/>
+              <a:rPr sz="2000" b="1" i="0">
+                <a:solidFill>
+                  <a:srgbClr val="0B1F3A"/>
                 </a:solidFill>
                 <a:latin typeface="Calibri"/>
               </a:rPr>
@@ -17138,9 +17138,9 @@
               </a:lnSpc>
             </a:pPr>
             <a:r>
-              <a:rPr sz="2000" b="0" i="0">
-                <a:solidFill>
-                  <a:srgbClr val="9AA5B1"/>
+              <a:rPr sz="2000" b="1" i="0">
+                <a:solidFill>
+                  <a:srgbClr val="0B1F3A"/>
                 </a:solidFill>
                 <a:latin typeface="Calibri"/>
               </a:rPr>
@@ -18071,9 +18071,9 @@
               </a:lnSpc>
             </a:pPr>
             <a:r>
-              <a:rPr sz="2000" b="0" i="0">
-                <a:solidFill>
-                  <a:srgbClr val="9AA5B1"/>
+              <a:rPr sz="2000" b="1" i="0">
+                <a:solidFill>
+                  <a:srgbClr val="0B1F3A"/>
                 </a:solidFill>
                 <a:latin typeface="Calibri"/>
               </a:rPr>
@@ -18110,9 +18110,9 @@
               </a:lnSpc>
             </a:pPr>
             <a:r>
-              <a:rPr sz="2000" b="0" i="0">
-                <a:solidFill>
-                  <a:srgbClr val="9AA5B1"/>
+              <a:rPr sz="2000" b="1" i="0">
+                <a:solidFill>
+                  <a:srgbClr val="0B1F3A"/>
                 </a:solidFill>
                 <a:latin typeface="Calibri"/>
               </a:rPr>
@@ -18152,9 +18152,9 @@
               </a:spcAft>
             </a:pPr>
             <a:r>
-              <a:rPr sz="2000">
-                <a:solidFill>
-                  <a:srgbClr val="FFFFFF"/>
+              <a:rPr sz="2000" b="1">
+                <a:solidFill>
+                  <a:srgbClr val="0B1F3A"/>
                 </a:solidFill>
                 <a:latin typeface="Calibri"/>
               </a:rPr>
@@ -18171,9 +18171,9 @@
               </a:spcAft>
             </a:pPr>
             <a:r>
-              <a:rPr sz="2000">
-                <a:solidFill>
-                  <a:srgbClr val="FFFFFF"/>
+              <a:rPr sz="2000" b="1">
+                <a:solidFill>
+                  <a:srgbClr val="0B1F3A"/>
                 </a:solidFill>
                 <a:latin typeface="Calibri"/>
               </a:rPr>
@@ -18190,9 +18190,9 @@
               </a:spcAft>
             </a:pPr>
             <a:r>
-              <a:rPr sz="2000">
-                <a:solidFill>
-                  <a:srgbClr val="FFFFFF"/>
+              <a:rPr sz="2000" b="1">
+                <a:solidFill>
+                  <a:srgbClr val="0B1F3A"/>
                 </a:solidFill>
                 <a:latin typeface="Calibri"/>
               </a:rPr>
@@ -18209,9 +18209,9 @@
               </a:spcAft>
             </a:pPr>
             <a:r>
-              <a:rPr sz="2000">
-                <a:solidFill>
-                  <a:srgbClr val="FFFFFF"/>
+              <a:rPr sz="2000" b="1">
+                <a:solidFill>
+                  <a:srgbClr val="0B1F3A"/>
                 </a:solidFill>
                 <a:latin typeface="Calibri"/>
               </a:rPr>
@@ -18228,9 +18228,9 @@
               </a:spcAft>
             </a:pPr>
             <a:r>
-              <a:rPr sz="2000">
-                <a:solidFill>
-                  <a:srgbClr val="FFFFFF"/>
+              <a:rPr sz="2000" b="1">
+                <a:solidFill>
+                  <a:srgbClr val="0B1F3A"/>
                 </a:solidFill>
                 <a:latin typeface="Calibri"/>
               </a:rPr>
@@ -18270,9 +18270,9 @@
               </a:spcAft>
             </a:pPr>
             <a:r>
-              <a:rPr sz="2000">
-                <a:solidFill>
-                  <a:srgbClr val="FFFFFF"/>
+              <a:rPr sz="2000" b="1">
+                <a:solidFill>
+                  <a:srgbClr val="0B1F3A"/>
                 </a:solidFill>
                 <a:latin typeface="Calibri"/>
               </a:rPr>
@@ -18289,9 +18289,9 @@
               </a:spcAft>
             </a:pPr>
             <a:r>
-              <a:rPr sz="2000">
-                <a:solidFill>
-                  <a:srgbClr val="FFFFFF"/>
+              <a:rPr sz="2000" b="1">
+                <a:solidFill>
+                  <a:srgbClr val="0B1F3A"/>
                 </a:solidFill>
                 <a:latin typeface="Calibri"/>
               </a:rPr>
@@ -18308,9 +18308,9 @@
               </a:spcAft>
             </a:pPr>
             <a:r>
-              <a:rPr sz="2000">
-                <a:solidFill>
-                  <a:srgbClr val="FFFFFF"/>
+              <a:rPr sz="2000" b="1">
+                <a:solidFill>
+                  <a:srgbClr val="0B1F3A"/>
                 </a:solidFill>
                 <a:latin typeface="Calibri"/>
               </a:rPr>
@@ -18327,9 +18327,9 @@
               </a:spcAft>
             </a:pPr>
             <a:r>
-              <a:rPr sz="2000">
-                <a:solidFill>
-                  <a:srgbClr val="FFFFFF"/>
+              <a:rPr sz="2000" b="1">
+                <a:solidFill>
+                  <a:srgbClr val="0B1F3A"/>
                 </a:solidFill>
                 <a:latin typeface="Calibri"/>
               </a:rPr>
@@ -18346,9 +18346,9 @@
               </a:spcAft>
             </a:pPr>
             <a:r>
-              <a:rPr sz="2000">
-                <a:solidFill>
-                  <a:srgbClr val="FFFFFF"/>
+              <a:rPr sz="2000" b="1">
+                <a:solidFill>
+                  <a:srgbClr val="0B1F3A"/>
                 </a:solidFill>
                 <a:latin typeface="Calibri"/>
               </a:rPr>
@@ -18747,9 +18747,9 @@
               </a:lnSpc>
             </a:pPr>
             <a:r>
-              <a:rPr sz="2000" b="0" i="0">
-                <a:solidFill>
-                  <a:srgbClr val="9AA5B1"/>
+              <a:rPr sz="2000" b="1" i="0">
+                <a:solidFill>
+                  <a:srgbClr val="0B1F3A"/>
                 </a:solidFill>
                 <a:latin typeface="Calibri"/>
               </a:rPr>
@@ -18786,9 +18786,9 @@
               </a:lnSpc>
             </a:pPr>
             <a:r>
-              <a:rPr sz="2000" b="0" i="0">
-                <a:solidFill>
-                  <a:srgbClr val="9AA5B1"/>
+              <a:rPr sz="2000" b="1" i="0">
+                <a:solidFill>
+                  <a:srgbClr val="0B1F3A"/>
                 </a:solidFill>
                 <a:latin typeface="Calibri"/>
               </a:rPr>
@@ -18825,9 +18825,9 @@
               </a:lnSpc>
             </a:pPr>
             <a:r>
-              <a:rPr sz="2000" b="0" i="1">
-                <a:solidFill>
-                  <a:srgbClr val="9AA5B1"/>
+              <a:rPr sz="2000" b="1" i="1">
+                <a:solidFill>
+                  <a:srgbClr val="0B1F3A"/>
                 </a:solidFill>
                 <a:latin typeface="Calibri"/>
               </a:rPr>
@@ -18950,9 +18950,9 @@
               </a:lnSpc>
             </a:pPr>
             <a:r>
-              <a:rPr sz="2000" b="0" i="1">
-                <a:solidFill>
-                  <a:srgbClr val="9AA5B1"/>
+              <a:rPr sz="2000" b="1" i="1">
+                <a:solidFill>
+                  <a:srgbClr val="0B1F3A"/>
                 </a:solidFill>
                 <a:latin typeface="Calibri"/>
               </a:rPr>
@@ -19075,9 +19075,9 @@
               </a:lnSpc>
             </a:pPr>
             <a:r>
-              <a:rPr sz="2000" b="0" i="1">
-                <a:solidFill>
-                  <a:srgbClr val="9AA5B1"/>
+              <a:rPr sz="2000" b="1" i="1">
+                <a:solidFill>
+                  <a:srgbClr val="0B1F3A"/>
                 </a:solidFill>
                 <a:latin typeface="Calibri"/>
               </a:rPr>
@@ -19200,9 +19200,9 @@
               </a:lnSpc>
             </a:pPr>
             <a:r>
-              <a:rPr sz="2000" b="0" i="1">
-                <a:solidFill>
-                  <a:srgbClr val="9AA5B1"/>
+              <a:rPr sz="2000" b="1" i="1">
+                <a:solidFill>
+                  <a:srgbClr val="0B1F3A"/>
                 </a:solidFill>
                 <a:latin typeface="Calibri"/>
               </a:rPr>
@@ -19325,9 +19325,9 @@
               </a:lnSpc>
             </a:pPr>
             <a:r>
-              <a:rPr sz="2000" b="0" i="1">
-                <a:solidFill>
-                  <a:srgbClr val="9AA5B1"/>
+              <a:rPr sz="2000" b="1" i="1">
+                <a:solidFill>
+                  <a:srgbClr val="0B1F3A"/>
                 </a:solidFill>
                 <a:latin typeface="Calibri"/>
               </a:rPr>
@@ -20185,9 +20185,9 @@
               </a:lnSpc>
             </a:pPr>
             <a:r>
-              <a:rPr sz="2000" b="0" i="0">
-                <a:solidFill>
-                  <a:srgbClr val="9AA5B1"/>
+              <a:rPr sz="2000" b="1" i="0">
+                <a:solidFill>
+                  <a:srgbClr val="0B1F3A"/>
                 </a:solidFill>
                 <a:latin typeface="Calibri"/>
               </a:rPr>
@@ -20224,9 +20224,9 @@
               </a:lnSpc>
             </a:pPr>
             <a:r>
-              <a:rPr sz="2000" b="0" i="0">
-                <a:solidFill>
-                  <a:srgbClr val="9AA5B1"/>
+              <a:rPr sz="2000" b="1" i="0">
+                <a:solidFill>
+                  <a:srgbClr val="0B1F3A"/>
                 </a:solidFill>
                 <a:latin typeface="Calibri"/>
               </a:rPr>
@@ -20266,31 +20266,41 @@
               </a:spcAft>
             </a:pPr>
             <a:r>
-              <a:rPr sz="1300"/>
+              <a:rPr sz="1300">
+                <a:solidFill/>
+              </a:rPr>
               <a:t>Amnesty International (2024) Nigeria: scores killed in coordinated Plateau State attacks. London: Amnesty International.</a:t>
             </a:r>
           </a:p>
           <a:p>
             <a:r>
-              <a:rPr sz="1300"/>
+              <a:rPr sz="1300">
+                <a:solidFill/>
+              </a:rPr>
               <a:t>Reuters (2026) Nigeria charges nine men with terrorism over Yelwata massacre. London: Reuters.</a:t>
             </a:r>
           </a:p>
           <a:p>
             <a:r>
-              <a:rPr sz="1300"/>
+              <a:rPr sz="1300">
+                <a:solidFill/>
+              </a:rPr>
               <a:t>BBC (2025) Yelwata massacre: what we know about the Benue State killings. London: BBC News.</a:t>
             </a:r>
           </a:p>
           <a:p>
             <a:r>
-              <a:rPr sz="1300"/>
+              <a:rPr sz="1300">
+                <a:solidFill/>
+              </a:rPr>
               <a:t>NPR (2025) Pope Leo prays for victims of Nigeria massacre at Sunday Angelus. Washington DC: National Public Radio.</a:t>
             </a:r>
           </a:p>
           <a:p>
             <a:r>
-              <a:rPr sz="1300"/>
+              <a:rPr sz="1300">
+                <a:solidFill/>
+              </a:rPr>
               <a:t>Vatican News (2025) Pope's Angelus address on violence in Nigeria. Vatican City: Vatican News.</a:t>
             </a:r>
           </a:p>
@@ -20327,43 +20337,57 @@
               </a:spcAft>
             </a:pPr>
             <a:r>
-              <a:rPr sz="1300"/>
+              <a:rPr sz="1300">
+                <a:solidFill/>
+              </a:rPr>
               <a:t>International Organization for Migration (2025) Displacement Tracking Matrix: North-Central and North-West Nigeria. Geneva: IOM.</a:t>
             </a:r>
           </a:p>
           <a:p>
             <a:r>
-              <a:rPr sz="1300"/>
+              <a:rPr sz="1300">
+                <a:solidFill/>
+              </a:rPr>
               <a:t>The Kukah Centre (2025) Conflict trends and community resilience in Nigeria's Middle Belt. Abuja: The Kukah Centre for Faith, Leadership and Public Policy.</a:t>
             </a:r>
           </a:p>
           <a:p>
             <a:r>
-              <a:rPr sz="1300"/>
+              <a:rPr sz="1300">
+                <a:solidFill/>
+              </a:rPr>
               <a:t>United Nations Peacebuilding Support Office (2025) Nigeria peacebuilding fund report. New York: UN Peacebuilding.</a:t>
             </a:r>
           </a:p>
           <a:p>
             <a:r>
-              <a:rPr sz="1300"/>
+              <a:rPr sz="1300">
+                <a:solidFill/>
+              </a:rPr>
               <a:t>Channels Television (2024) Mangu attacks: death toll rises in renewed Plateau violence. Lagos: Channels Television.</a:t>
             </a:r>
           </a:p>
           <a:p>
             <a:r>
-              <a:rPr sz="1300"/>
+              <a:rPr sz="1300">
+                <a:solidFill/>
+              </a:rPr>
               <a:t>Premium Times (2025) Benue killings: a data investigation, 2023–2025. Abuja: Premium Times.</a:t>
             </a:r>
           </a:p>
           <a:p>
             <a:r>
-              <a:rPr sz="1300"/>
+              <a:rPr sz="1300">
+                <a:solidFill/>
+              </a:rPr>
               <a:t>National Assembly of Nigeria (2026) Constitution of the Federal Republic of Nigeria (Alteration) (State Police) Bill, 2026. Abuja: National Assembly.</a:t>
             </a:r>
           </a:p>
           <a:p>
             <a:r>
-              <a:rPr sz="1300"/>
+              <a:rPr sz="1300">
+                <a:solidFill/>
+              </a:rPr>
               <a:t>Kaduna State Government and Katsina State Government (2025) Early Warning and Early Response System: outcomes report. Kaduna/Katsina: State Governments.</a:t>
             </a:r>
           </a:p>
@@ -20759,9 +20783,9 @@
               </a:lnSpc>
             </a:pPr>
             <a:r>
-              <a:rPr sz="2000" b="0" i="0">
-                <a:solidFill>
-                  <a:srgbClr val="9AA5B1"/>
+              <a:rPr sz="2000" b="1" i="0">
+                <a:solidFill>
+                  <a:srgbClr val="0B1F3A"/>
                 </a:solidFill>
                 <a:latin typeface="Calibri"/>
               </a:rPr>
@@ -20798,9 +20822,9 @@
               </a:lnSpc>
             </a:pPr>
             <a:r>
-              <a:rPr sz="2000" b="0" i="0">
-                <a:solidFill>
-                  <a:srgbClr val="9AA5B1"/>
+              <a:rPr sz="2000" b="1" i="0">
+                <a:solidFill>
+                  <a:srgbClr val="0B1F3A"/>
                 </a:solidFill>
                 <a:latin typeface="Calibri"/>
               </a:rPr>
@@ -20879,9 +20903,9 @@
               </a:spcAft>
             </a:pPr>
             <a:r>
-              <a:rPr sz="2000" dirty="0">
-                <a:solidFill>
-                  <a:srgbClr val="FFFFFF"/>
+              <a:rPr sz="2000" dirty="0" b="1">
+                <a:solidFill>
+                  <a:srgbClr val="0B1F3A"/>
                 </a:solidFill>
                 <a:latin typeface="Calibri"/>
               </a:rPr>
@@ -20898,9 +20922,9 @@
               </a:spcAft>
             </a:pPr>
             <a:r>
-              <a:rPr sz="2000" dirty="0">
-                <a:solidFill>
-                  <a:srgbClr val="FFFFFF"/>
+              <a:rPr sz="2000" dirty="0" b="1">
+                <a:solidFill>
+                  <a:srgbClr val="0B1F3A"/>
                 </a:solidFill>
                 <a:latin typeface="Calibri"/>
               </a:rPr>
@@ -20917,9 +20941,9 @@
               </a:spcAft>
             </a:pPr>
             <a:r>
-              <a:rPr sz="2000" dirty="0">
-                <a:solidFill>
-                  <a:srgbClr val="FFFFFF"/>
+              <a:rPr sz="2000" dirty="0" b="1">
+                <a:solidFill>
+                  <a:srgbClr val="0B1F3A"/>
                 </a:solidFill>
                 <a:latin typeface="Calibri"/>
               </a:rPr>
@@ -20936,9 +20960,9 @@
               </a:spcAft>
             </a:pPr>
             <a:r>
-              <a:rPr sz="2000" dirty="0">
-                <a:solidFill>
-                  <a:srgbClr val="FFFFFF"/>
+              <a:rPr sz="2000" dirty="0" b="1">
+                <a:solidFill>
+                  <a:srgbClr val="0B1F3A"/>
                 </a:solidFill>
                 <a:latin typeface="Calibri"/>
               </a:rPr>
@@ -20955,9 +20979,9 @@
               </a:spcAft>
             </a:pPr>
             <a:r>
-              <a:rPr sz="2000" dirty="0">
-                <a:solidFill>
-                  <a:srgbClr val="FFFFFF"/>
+              <a:rPr sz="2000" dirty="0" b="1">
+                <a:solidFill>
+                  <a:srgbClr val="0B1F3A"/>
                 </a:solidFill>
                 <a:latin typeface="Calibri"/>
               </a:rPr>
@@ -20974,9 +20998,9 @@
               </a:spcAft>
             </a:pPr>
             <a:r>
-              <a:rPr sz="2000" dirty="0">
-                <a:solidFill>
-                  <a:srgbClr val="FFFFFF"/>
+              <a:rPr sz="2000" dirty="0" b="1">
+                <a:solidFill>
+                  <a:srgbClr val="0B1F3A"/>
                 </a:solidFill>
                 <a:latin typeface="Calibri"/>
               </a:rPr>
@@ -21506,9 +21530,9 @@
               </a:lnSpc>
             </a:pPr>
             <a:r>
-              <a:rPr sz="2000" b="0" i="0">
-                <a:solidFill>
-                  <a:srgbClr val="9AA5B1"/>
+              <a:rPr sz="2000" b="1" i="0">
+                <a:solidFill>
+                  <a:srgbClr val="0B1F3A"/>
                 </a:solidFill>
                 <a:latin typeface="Calibri"/>
               </a:rPr>
@@ -21545,9 +21569,9 @@
               </a:lnSpc>
             </a:pPr>
             <a:r>
-              <a:rPr sz="2000" b="0" i="0">
-                <a:solidFill>
-                  <a:srgbClr val="9AA5B1"/>
+              <a:rPr sz="2000" b="1" i="0">
+                <a:solidFill>
+                  <a:srgbClr val="0B1F3A"/>
                 </a:solidFill>
                 <a:latin typeface="Calibri"/>
               </a:rPr>
@@ -22928,9 +22952,9 @@
               </a:lnSpc>
             </a:pPr>
             <a:r>
-              <a:rPr sz="2000" b="0" i="0">
-                <a:solidFill>
-                  <a:srgbClr val="9AA5B1"/>
+              <a:rPr sz="2000" b="1" i="0">
+                <a:solidFill>
+                  <a:srgbClr val="0B1F3A"/>
                 </a:solidFill>
                 <a:latin typeface="Calibri"/>
               </a:rPr>
@@ -22967,9 +22991,9 @@
               </a:lnSpc>
             </a:pPr>
             <a:r>
-              <a:rPr sz="2000" b="0" i="0">
-                <a:solidFill>
-                  <a:srgbClr val="9AA5B1"/>
+              <a:rPr sz="2000" b="1" i="0">
+                <a:solidFill>
+                  <a:srgbClr val="0B1F3A"/>
                 </a:solidFill>
                 <a:latin typeface="Calibri"/>
               </a:rPr>
@@ -23006,9 +23030,9 @@
               </a:lnSpc>
             </a:pPr>
             <a:r>
-              <a:rPr sz="2000" b="0" i="1">
-                <a:solidFill>
-                  <a:srgbClr val="E8EAEE"/>
+              <a:rPr sz="2000" b="1" i="1">
+                <a:solidFill>
+                  <a:srgbClr val="0B1F3A"/>
                 </a:solidFill>
                 <a:latin typeface="Calibri"/>
               </a:rPr>
@@ -23130,9 +23154,9 @@
               </a:lnSpc>
             </a:pPr>
             <a:r>
-              <a:rPr sz="2000" b="0" i="0">
-                <a:solidFill>
-                  <a:srgbClr val="FFFFFF"/>
+              <a:rPr sz="2000" b="1" i="0">
+                <a:solidFill>
+                  <a:srgbClr val="0B1F3A"/>
                 </a:solidFill>
                 <a:latin typeface="Calibri"/>
               </a:rPr>
@@ -23253,9 +23277,9 @@
               </a:lnSpc>
             </a:pPr>
             <a:r>
-              <a:rPr sz="2000" b="0" i="0">
-                <a:solidFill>
-                  <a:srgbClr val="FFFFFF"/>
+              <a:rPr sz="2000" b="1" i="0">
+                <a:solidFill>
+                  <a:srgbClr val="0B1F3A"/>
                 </a:solidFill>
                 <a:latin typeface="Calibri"/>
               </a:rPr>
@@ -23376,9 +23400,9 @@
               </a:lnSpc>
             </a:pPr>
             <a:r>
-              <a:rPr sz="2000" b="0" i="0">
-                <a:solidFill>
-                  <a:srgbClr val="FFFFFF"/>
+              <a:rPr sz="2000" b="1" i="0">
+                <a:solidFill>
+                  <a:srgbClr val="0B1F3A"/>
                 </a:solidFill>
                 <a:latin typeface="Calibri"/>
               </a:rPr>
@@ -23499,9 +23523,9 @@
               </a:lnSpc>
             </a:pPr>
             <a:r>
-              <a:rPr sz="2000" b="0" i="0">
-                <a:solidFill>
-                  <a:srgbClr val="FFFFFF"/>
+              <a:rPr sz="2000" b="1" i="0">
+                <a:solidFill>
+                  <a:srgbClr val="0B1F3A"/>
                 </a:solidFill>
                 <a:latin typeface="Calibri"/>
               </a:rPr>
@@ -23622,9 +23646,9 @@
               </a:lnSpc>
             </a:pPr>
             <a:r>
-              <a:rPr sz="2000" b="0" i="0">
-                <a:solidFill>
-                  <a:srgbClr val="FFFFFF"/>
+              <a:rPr sz="2000" b="1" i="0">
+                <a:solidFill>
+                  <a:srgbClr val="0B1F3A"/>
                 </a:solidFill>
                 <a:latin typeface="Calibri"/>
               </a:rPr>
@@ -24023,9 +24047,9 @@
               </a:lnSpc>
             </a:pPr>
             <a:r>
-              <a:rPr sz="2000" b="0" i="0">
-                <a:solidFill>
-                  <a:srgbClr val="9AA5B1"/>
+              <a:rPr sz="2000" b="1" i="0">
+                <a:solidFill>
+                  <a:srgbClr val="0B1F3A"/>
                 </a:solidFill>
                 <a:latin typeface="Calibri"/>
               </a:rPr>
@@ -24062,9 +24086,9 @@
               </a:lnSpc>
             </a:pPr>
             <a:r>
-              <a:rPr sz="2000" b="0" i="0">
-                <a:solidFill>
-                  <a:srgbClr val="9AA5B1"/>
+              <a:rPr sz="2000" b="1" i="0">
+                <a:solidFill>
+                  <a:srgbClr val="0B1F3A"/>
                 </a:solidFill>
                 <a:latin typeface="Calibri"/>
               </a:rPr>
@@ -24998,9 +25022,9 @@
               </a:lnSpc>
             </a:pPr>
             <a:r>
-              <a:rPr sz="2000" b="0" i="0">
-                <a:solidFill>
-                  <a:srgbClr val="9AA5B1"/>
+              <a:rPr sz="2000" b="1" i="0">
+                <a:solidFill>
+                  <a:srgbClr val="0B1F3A"/>
                 </a:solidFill>
                 <a:latin typeface="Calibri"/>
               </a:rPr>
@@ -25037,9 +25061,9 @@
               </a:lnSpc>
             </a:pPr>
             <a:r>
-              <a:rPr sz="2000" b="0" i="0">
-                <a:solidFill>
-                  <a:srgbClr val="9AA5B1"/>
+              <a:rPr sz="2000" b="1" i="0">
+                <a:solidFill>
+                  <a:srgbClr val="0B1F3A"/>
                 </a:solidFill>
                 <a:latin typeface="Calibri"/>
               </a:rPr>
@@ -25130,7 +25154,7 @@
             <a:r>
               <a:rPr sz="2000" b="1" i="0">
                 <a:solidFill>
-                  <a:srgbClr val="FFFFFF"/>
+                  <a:srgbClr val="0B1F3A"/>
                 </a:solidFill>
                 <a:latin typeface="Calibri"/>
               </a:rPr>
@@ -25221,7 +25245,7 @@
             <a:r>
               <a:rPr sz="2000" b="1" i="0">
                 <a:solidFill>
-                  <a:srgbClr val="FFFFFF"/>
+                  <a:srgbClr val="0B1F3A"/>
                 </a:solidFill>
                 <a:latin typeface="Calibri"/>
               </a:rPr>
@@ -25312,7 +25336,7 @@
             <a:r>
               <a:rPr sz="2000" b="1" i="0">
                 <a:solidFill>
-                  <a:srgbClr val="FFFFFF"/>
+                  <a:srgbClr val="0B1F3A"/>
                 </a:solidFill>
                 <a:latin typeface="Calibri"/>
               </a:rPr>
@@ -25403,7 +25427,7 @@
             <a:r>
               <a:rPr sz="2000" b="1" i="0">
                 <a:solidFill>
-                  <a:srgbClr val="FFFFFF"/>
+                  <a:srgbClr val="0B1F3A"/>
                 </a:solidFill>
                 <a:latin typeface="Calibri"/>
               </a:rPr>
@@ -25494,7 +25518,7 @@
             <a:r>
               <a:rPr sz="2000" b="1" i="0">
                 <a:solidFill>
-                  <a:srgbClr val="FFFFFF"/>
+                  <a:srgbClr val="0B1F3A"/>
                 </a:solidFill>
                 <a:latin typeface="Calibri"/>
               </a:rPr>
@@ -26114,9 +26138,9 @@
               </a:lnSpc>
             </a:pPr>
             <a:r>
-              <a:rPr sz="2000" b="0" i="0">
-                <a:solidFill>
-                  <a:srgbClr val="9AA5B1"/>
+              <a:rPr sz="2000" b="1" i="0">
+                <a:solidFill>
+                  <a:srgbClr val="0B1F3A"/>
                 </a:solidFill>
                 <a:latin typeface="Calibri"/>
               </a:rPr>
@@ -26153,9 +26177,9 @@
               </a:lnSpc>
             </a:pPr>
             <a:r>
-              <a:rPr sz="2000" b="0" i="0">
-                <a:solidFill>
-                  <a:srgbClr val="9AA5B1"/>
+              <a:rPr sz="2000" b="1" i="0">
+                <a:solidFill>
+                  <a:srgbClr val="0B1F3A"/>
                 </a:solidFill>
                 <a:latin typeface="Calibri"/>
               </a:rPr>

</xml_diff>

<commit_message>
Right-side sky-blue panels now use dark gold text (B8860B) instead of white for a richer thematic look, per Tom's direction - left side/header text untouched
</commit_message>
<xml_diff>
--- a/avm_morgan_docs/AVM_MORGAN_SECURITY_KEYNOTE_30MIN_v3_WITH_REFERENCES.pptx
+++ b/avm_morgan_docs/AVM_MORGAN_SECURITY_KEYNOTE_30MIN_v3_WITH_REFERENCES.pptx
@@ -4055,7 +4055,7 @@
             <a:r>
               <a:rPr sz="2000" b="1" i="0">
                 <a:solidFill>
-                  <a:srgbClr val="D4AF37"/>
+                  <a:srgbClr val="B8860B"/>
                 </a:solidFill>
                 <a:latin typeface="Calibri"/>
               </a:rPr>
@@ -4139,7 +4139,7 @@
             <a:r>
               <a:rPr sz="2000" b="1" i="0">
                 <a:solidFill>
-                  <a:srgbClr val="FFFFFF"/>
+                  <a:srgbClr val="B8860B"/>
                 </a:solidFill>
                 <a:latin typeface="Calibri"/>
               </a:rPr>
@@ -4223,7 +4223,7 @@
             <a:r>
               <a:rPr sz="2000" b="1" i="0">
                 <a:solidFill>
-                  <a:srgbClr val="FFFFFF"/>
+                  <a:srgbClr val="B8860B"/>
                 </a:solidFill>
                 <a:latin typeface="Calibri"/>
               </a:rPr>
@@ -4307,7 +4307,7 @@
             <a:r>
               <a:rPr sz="2000" b="1" i="0">
                 <a:solidFill>
-                  <a:srgbClr val="FFFFFF"/>
+                  <a:srgbClr val="B8860B"/>
                 </a:solidFill>
                 <a:latin typeface="Calibri"/>
               </a:rPr>
@@ -4391,7 +4391,7 @@
             <a:r>
               <a:rPr sz="2000" b="1" i="0">
                 <a:solidFill>
-                  <a:srgbClr val="FFFFFF"/>
+                  <a:srgbClr val="B8860B"/>
                 </a:solidFill>
                 <a:latin typeface="Calibri"/>
               </a:rPr>
@@ -4475,7 +4475,7 @@
             <a:r>
               <a:rPr sz="2000" b="1" i="0">
                 <a:solidFill>
-                  <a:srgbClr val="FFFFFF"/>
+                  <a:srgbClr val="B8860B"/>
                 </a:solidFill>
                 <a:latin typeface="Calibri"/>
               </a:rPr>
@@ -4559,7 +4559,7 @@
             <a:r>
               <a:rPr sz="2000" b="1" i="0">
                 <a:solidFill>
-                  <a:srgbClr val="FFFFFF"/>
+                  <a:srgbClr val="B8860B"/>
                 </a:solidFill>
                 <a:latin typeface="Calibri"/>
               </a:rPr>
@@ -5147,7 +5147,7 @@
             <a:r>
               <a:rPr sz="1800" b="1">
                 <a:solidFill>
-                  <a:srgbClr val="FFFFFF"/>
+                  <a:srgbClr val="B8860B"/>
                 </a:solidFill>
               </a:rPr>
               <a:t>Niger – Kaduna – FCT</a:t>
@@ -5255,7 +5255,7 @@
             <a:r>
               <a:rPr sz="1800" b="1">
                 <a:solidFill>
-                  <a:srgbClr val="FFFFFF"/>
+                  <a:srgbClr val="B8860B"/>
                 </a:solidFill>
               </a:rPr>
               <a:t>Benue – Taraba</a:t>
@@ -5363,7 +5363,7 @@
             <a:r>
               <a:rPr sz="1800" b="1">
                 <a:solidFill>
-                  <a:srgbClr val="FFFFFF"/>
+                  <a:srgbClr val="B8860B"/>
                 </a:solidFill>
               </a:rPr>
               <a:t>Kogi – Nasarawa – Benue</a:t>
@@ -6768,7 +6768,7 @@
             <a:r>
               <a:rPr sz="1400" b="1">
                 <a:solidFill>
-                  <a:srgbClr val="FFFFFF"/>
+                  <a:srgbClr val="B8860B"/>
                 </a:solidFill>
               </a:rPr>
               <a:t>Secure
@@ -6933,7 +6933,7 @@
             <a:r>
               <a:rPr sz="1400" b="1">
                 <a:solidFill>
-                  <a:srgbClr val="FFFFFF"/>
+                  <a:srgbClr val="B8860B"/>
                 </a:solidFill>
               </a:rPr>
               <a:t>Lawful Telecoms
@@ -7098,7 +7098,7 @@
             <a:r>
               <a:rPr sz="1400" b="1">
                 <a:solidFill>
-                  <a:srgbClr val="FFFFFF"/>
+                  <a:srgbClr val="B8860B"/>
                 </a:solidFill>
               </a:rPr>
               <a:t>AI Pattern
@@ -7741,7 +7741,7 @@
             <a:r>
               <a:rPr sz="2000" b="1" i="0">
                 <a:solidFill>
-                  <a:srgbClr val="D4AF37"/>
+                  <a:srgbClr val="B8860B"/>
                 </a:solidFill>
                 <a:latin typeface="Calibri"/>
               </a:rPr>
@@ -7780,7 +7780,7 @@
             <a:r>
               <a:rPr sz="2000" b="1" i="0">
                 <a:solidFill>
-                  <a:srgbClr val="FFFFFF"/>
+                  <a:srgbClr val="B8860B"/>
                 </a:solidFill>
                 <a:latin typeface="Calibri"/>
               </a:rPr>
@@ -7820,9 +7820,9 @@
               </a:lnSpc>
             </a:pPr>
             <a:r>
-              <a:rPr sz="2000" b="0" i="0">
-                <a:solidFill>
-                  <a:srgbClr val="FFFFFF"/>
+              <a:rPr sz="2000" b="1" i="0">
+                <a:solidFill>
+                  <a:srgbClr val="B8860B"/>
                 </a:solidFill>
                 <a:latin typeface="Calibri"/>
               </a:rPr>
@@ -9700,9 +9700,9 @@
           <a:p>
             <a:pPr algn="ctr"/>
             <a:r>
-              <a:rPr sz="1300">
-                <a:solidFill>
-                  <a:srgbClr val="FFFFFF"/>
+              <a:rPr sz="1300" b="1">
+                <a:solidFill>
+                  <a:srgbClr val="B8860B"/>
                 </a:solidFill>
               </a:rPr>
               <a:t>Crop Destruction</a:t>
@@ -9754,9 +9754,9 @@
           <a:p>
             <a:pPr algn="ctr"/>
             <a:r>
-              <a:rPr sz="1300">
-                <a:solidFill>
-                  <a:srgbClr val="FFFFFF"/>
+              <a:rPr sz="1300" b="1">
+                <a:solidFill>
+                  <a:srgbClr val="B8860B"/>
                 </a:solidFill>
               </a:rPr>
               <a:t>Cattle Rustling</a:t>
@@ -11683,7 +11683,7 @@
             <a:r>
               <a:rPr sz="2000" b="1" i="0">
                 <a:solidFill>
-                  <a:srgbClr val="FFFFFF"/>
+                  <a:srgbClr val="B8860B"/>
                 </a:solidFill>
                 <a:latin typeface="Calibri"/>
               </a:rPr>
@@ -11723,9 +11723,9 @@
               </a:spcAft>
             </a:pPr>
             <a:r>
-              <a:rPr sz="2000">
-                <a:solidFill>
-                  <a:srgbClr val="FFFFFF"/>
+              <a:rPr sz="2000" b="1">
+                <a:solidFill>
+                  <a:srgbClr val="B8860B"/>
                 </a:solidFill>
                 <a:latin typeface="Calibri"/>
               </a:rPr>
@@ -11742,9 +11742,9 @@
               </a:spcAft>
             </a:pPr>
             <a:r>
-              <a:rPr sz="2000">
-                <a:solidFill>
-                  <a:srgbClr val="FFFFFF"/>
+              <a:rPr sz="2000" b="1">
+                <a:solidFill>
+                  <a:srgbClr val="B8860B"/>
                 </a:solidFill>
                 <a:latin typeface="Calibri"/>
               </a:rPr>
@@ -11761,9 +11761,9 @@
               </a:spcAft>
             </a:pPr>
             <a:r>
-              <a:rPr sz="2000">
-                <a:solidFill>
-                  <a:srgbClr val="FFFFFF"/>
+              <a:rPr sz="2000" b="1">
+                <a:solidFill>
+                  <a:srgbClr val="B8860B"/>
                 </a:solidFill>
                 <a:latin typeface="Calibri"/>
               </a:rPr>
@@ -11780,9 +11780,9 @@
               </a:spcAft>
             </a:pPr>
             <a:r>
-              <a:rPr sz="2000">
-                <a:solidFill>
-                  <a:srgbClr val="FFFFFF"/>
+              <a:rPr sz="2000" b="1">
+                <a:solidFill>
+                  <a:srgbClr val="B8860B"/>
                 </a:solidFill>
                 <a:latin typeface="Calibri"/>
               </a:rPr>
@@ -11799,9 +11799,9 @@
               </a:spcAft>
             </a:pPr>
             <a:r>
-              <a:rPr sz="2000">
-                <a:solidFill>
-                  <a:srgbClr val="FFFFFF"/>
+              <a:rPr sz="2000" b="1">
+                <a:solidFill>
+                  <a:srgbClr val="B8860B"/>
                 </a:solidFill>
                 <a:latin typeface="Calibri"/>
               </a:rPr>
@@ -12446,7 +12446,7 @@
             <a:r>
               <a:rPr sz="1400" b="1">
                 <a:solidFill>
-                  <a:srgbClr val="FFFFFF"/>
+                  <a:srgbClr val="B8860B"/>
                 </a:solidFill>
               </a:rPr>
               <a:t>Professional
@@ -12611,7 +12611,7 @@
             <a:r>
               <a:rPr sz="1400" b="1">
                 <a:solidFill>
-                  <a:srgbClr val="FFFFFF"/>
+                  <a:srgbClr val="B8860B"/>
                 </a:solidFill>
               </a:rPr>
               <a:t>Legislative &amp;
@@ -13370,7 +13370,7 @@
             <a:r>
               <a:rPr sz="2000" b="1" i="0">
                 <a:solidFill>
-                  <a:srgbClr val="FFFFFF"/>
+                  <a:srgbClr val="B8860B"/>
                 </a:solidFill>
                 <a:latin typeface="Calibri"/>
               </a:rPr>
@@ -13409,7 +13409,7 @@
             <a:r>
               <a:rPr sz="2000" b="1" i="0">
                 <a:solidFill>
-                  <a:srgbClr val="FFFFFF"/>
+                  <a:srgbClr val="B8860B"/>
                 </a:solidFill>
                 <a:latin typeface="Calibri"/>
               </a:rPr>
@@ -14105,7 +14105,7 @@
             <a:r>
               <a:rPr sz="2000" b="1" i="0">
                 <a:solidFill>
-                  <a:srgbClr val="D4AF37"/>
+                  <a:srgbClr val="B8860B"/>
                 </a:solidFill>
                 <a:latin typeface="Calibri"/>
               </a:rPr>
@@ -14145,9 +14145,9 @@
               </a:spcAft>
             </a:pPr>
             <a:r>
-              <a:rPr sz="2000">
-                <a:solidFill>
-                  <a:srgbClr val="FFFFFF"/>
+              <a:rPr sz="2000" b="1">
+                <a:solidFill>
+                  <a:srgbClr val="B8860B"/>
                 </a:solidFill>
                 <a:latin typeface="Calibri"/>
               </a:rPr>
@@ -14164,9 +14164,9 @@
               </a:spcAft>
             </a:pPr>
             <a:r>
-              <a:rPr sz="2000">
-                <a:solidFill>
-                  <a:srgbClr val="FFFFFF"/>
+              <a:rPr sz="2000" b="1">
+                <a:solidFill>
+                  <a:srgbClr val="B8860B"/>
                 </a:solidFill>
                 <a:latin typeface="Calibri"/>
               </a:rPr>
@@ -14183,9 +14183,9 @@
               </a:spcAft>
             </a:pPr>
             <a:r>
-              <a:rPr sz="2000">
-                <a:solidFill>
-                  <a:srgbClr val="FFFFFF"/>
+              <a:rPr sz="2000" b="1">
+                <a:solidFill>
+                  <a:srgbClr val="B8860B"/>
                 </a:solidFill>
                 <a:latin typeface="Calibri"/>
               </a:rPr>
@@ -14202,9 +14202,9 @@
               </a:spcAft>
             </a:pPr>
             <a:r>
-              <a:rPr sz="2000">
-                <a:solidFill>
-                  <a:srgbClr val="FFFFFF"/>
+              <a:rPr sz="2000" b="1">
+                <a:solidFill>
+                  <a:srgbClr val="B8860B"/>
                 </a:solidFill>
                 <a:latin typeface="Calibri"/>
               </a:rPr>
@@ -14221,9 +14221,9 @@
               </a:spcAft>
             </a:pPr>
             <a:r>
-              <a:rPr sz="2000">
-                <a:solidFill>
-                  <a:srgbClr val="FFFFFF"/>
+              <a:rPr sz="2000" b="1">
+                <a:solidFill>
+                  <a:srgbClr val="B8860B"/>
                 </a:solidFill>
                 <a:latin typeface="Calibri"/>
               </a:rPr>
@@ -15458,7 +15458,7 @@
             <a:r>
               <a:rPr sz="2000" b="1">
                 <a:solidFill>
-                  <a:srgbClr val="FFFFFF"/>
+                  <a:srgbClr val="B8860B"/>
                 </a:solidFill>
               </a:rPr>
               <a:t>06:00 – 12:00</a:t>
@@ -15467,9 +15467,9 @@
           <a:p>
             <a:pPr algn="ctr"/>
             <a:r>
-              <a:rPr sz="1400">
-                <a:solidFill>
-                  <a:srgbClr val="FFFFFF"/>
+              <a:rPr sz="1400" b="1">
+                <a:solidFill>
+                  <a:srgbClr val="B8860B"/>
                 </a:solidFill>
               </a:rPr>
               <a:t>Community Reporting &amp;
@@ -15590,7 +15590,7 @@
             <a:r>
               <a:rPr sz="2000" b="1">
                 <a:solidFill>
-                  <a:srgbClr val="FFFFFF"/>
+                  <a:srgbClr val="B8860B"/>
                 </a:solidFill>
               </a:rPr>
               <a:t>18:00 – 00:00</a:t>
@@ -15599,9 +15599,9 @@
           <a:p>
             <a:pPr algn="ctr"/>
             <a:r>
-              <a:rPr sz="1400">
-                <a:solidFill>
-                  <a:srgbClr val="FFFFFF"/>
+              <a:rPr sz="1400" b="1">
+                <a:solidFill>
+                  <a:srgbClr val="B8860B"/>
                 </a:solidFill>
               </a:rPr>
               <a:t>Night Security Posture &amp;
@@ -16197,15 +16197,15 @@
             <a:r>
               <a:rPr sz="1400" b="1">
                 <a:solidFill>
-                  <a:srgbClr val="FFFFFF"/>
+                  <a:srgbClr val="B8860B"/>
                 </a:solidFill>
               </a:rPr>
               <a:t>2.  </a:t>
             </a:r>
             <a:r>
-              <a:rPr sz="1300">
-                <a:solidFill>
-                  <a:srgbClr val="FFFFFF"/>
+              <a:rPr sz="1300" b="1">
+                <a:solidFill>
+                  <a:srgbClr val="B8860B"/>
                 </a:solidFill>
               </a:rPr>
               <a:t>Establish a regional intelligence-fusion mechanism</a:t>
@@ -16321,15 +16321,15 @@
             <a:r>
               <a:rPr sz="1400" b="1">
                 <a:solidFill>
-                  <a:srgbClr val="FFFFFF"/>
+                  <a:srgbClr val="B8860B"/>
                 </a:solidFill>
               </a:rPr>
               <a:t>4.  </a:t>
             </a:r>
             <a:r>
-              <a:rPr sz="1300">
-                <a:solidFill>
-                  <a:srgbClr val="FFFFFF"/>
+              <a:rPr sz="1300" b="1">
+                <a:solidFill>
+                  <a:srgbClr val="B8860B"/>
                 </a:solidFill>
               </a:rPr>
               <a:t>Identify the 100 most vulnerable communities</a:t>
@@ -16445,15 +16445,15 @@
             <a:r>
               <a:rPr sz="1400" b="1">
                 <a:solidFill>
-                  <a:srgbClr val="FFFFFF"/>
+                  <a:srgbClr val="B8860B"/>
                 </a:solidFill>
               </a:rPr>
               <a:t>6.  </a:t>
             </a:r>
             <a:r>
-              <a:rPr sz="1300">
-                <a:solidFill>
-                  <a:srgbClr val="FFFFFF"/>
+              <a:rPr sz="1300" b="1">
+                <a:solidFill>
+                  <a:srgbClr val="B8860B"/>
                 </a:solidFill>
               </a:rPr>
               <a:t>Establish rapid-response protocols</a:t>
@@ -16569,15 +16569,15 @@
             <a:r>
               <a:rPr sz="1400" b="1">
                 <a:solidFill>
-                  <a:srgbClr val="FFFFFF"/>
+                  <a:srgbClr val="B8860B"/>
                 </a:solidFill>
               </a:rPr>
               <a:t>8.  </a:t>
             </a:r>
             <a:r>
-              <a:rPr sz="1300">
-                <a:solidFill>
-                  <a:srgbClr val="FFFFFF"/>
+              <a:rPr sz="1300" b="1">
+                <a:solidFill>
+                  <a:srgbClr val="B8860B"/>
                 </a:solidFill>
               </a:rPr>
               <a:t>Common training for military, police &amp; liaisons</a:t>
@@ -16693,15 +16693,15 @@
             <a:r>
               <a:rPr sz="1400" b="1">
                 <a:solidFill>
-                  <a:srgbClr val="FFFFFF"/>
+                  <a:srgbClr val="B8860B"/>
                 </a:solidFill>
               </a:rPr>
               <a:t>10.  </a:t>
             </a:r>
             <a:r>
-              <a:rPr sz="1300">
-                <a:solidFill>
-                  <a:srgbClr val="FFFFFF"/>
+              <a:rPr sz="1300" b="1">
+                <a:solidFill>
+                  <a:srgbClr val="B8860B"/>
                 </a:solidFill>
               </a:rPr>
               <a:t>Publish measurable security indicators quarterly</a:t>
@@ -17347,7 +17347,7 @@
             <a:r>
               <a:rPr sz="2600" b="1">
                 <a:solidFill>
-                  <a:srgbClr val="FFFFFF"/>
+                  <a:srgbClr val="B8860B"/>
                 </a:solidFill>
               </a:rPr>
               <a:t>3</a:t>
@@ -17358,7 +17358,7 @@
             <a:r>
               <a:rPr sz="1300" b="1">
                 <a:solidFill>
-                  <a:srgbClr val="FFFFFF"/>
+                  <a:srgbClr val="B8860B"/>
                 </a:solidFill>
               </a:rPr>
               <a:t>One Rapid-Response Philosophy</a:t>
@@ -17367,9 +17367,9 @@
           <a:p>
             <a:pPr algn="ctr"/>
             <a:r>
-              <a:rPr sz="1050">
-                <a:solidFill>
-                  <a:srgbClr val="FFFFFF"/>
+              <a:rPr sz="1050" b="1">
+                <a:solidFill>
+                  <a:srgbClr val="B8860B"/>
                 </a:solidFill>
               </a:rPr>
               <a:t>We respond before massacres</a:t>
@@ -17423,7 +17423,7 @@
             <a:r>
               <a:rPr sz="2600" b="1">
                 <a:solidFill>
-                  <a:srgbClr val="FFFFFF"/>
+                  <a:srgbClr val="B8860B"/>
                 </a:solidFill>
               </a:rPr>
               <a:t>4</a:t>
@@ -17434,7 +17434,7 @@
             <a:r>
               <a:rPr sz="1300" b="1">
                 <a:solidFill>
-                  <a:srgbClr val="FFFFFF"/>
+                  <a:srgbClr val="B8860B"/>
                 </a:solidFill>
               </a:rPr>
               <a:t>One Professional Standard</a:t>
@@ -17443,9 +17443,9 @@
           <a:p>
             <a:pPr algn="ctr"/>
             <a:r>
-              <a:rPr sz="1050">
-                <a:solidFill>
-                  <a:srgbClr val="FFFFFF"/>
+              <a:rPr sz="1050" b="1">
+                <a:solidFill>
+                  <a:srgbClr val="B8860B"/>
                 </a:solidFill>
               </a:rPr>
               <a:t>Discipline, law, dignity</a:t>
@@ -21084,7 +21084,7 @@
             <a:r>
               <a:rPr sz="2000" b="1" i="0">
                 <a:solidFill>
-                  <a:srgbClr val="FFFFFF"/>
+                  <a:srgbClr val="B8860B"/>
                 </a:solidFill>
                 <a:latin typeface="Calibri"/>
               </a:rPr>
@@ -21121,9 +21121,9 @@
               </a:lnSpc>
             </a:pPr>
             <a:r>
-              <a:rPr sz="2000" b="0" i="0">
-                <a:solidFill>
-                  <a:srgbClr val="FFFFFF"/>
+              <a:rPr sz="2000" b="1" i="0">
+                <a:solidFill>
+                  <a:srgbClr val="B8860B"/>
                 </a:solidFill>
                 <a:latin typeface="Calibri"/>
               </a:rPr>
@@ -22026,7 +22026,7 @@
             <a:r>
               <a:rPr sz="1200" b="1">
                 <a:solidFill>
-                  <a:srgbClr val="FFFFFF"/>
+                  <a:srgbClr val="B8860B"/>
                 </a:solidFill>
               </a:rPr>
               <a:t>Attackers
@@ -22126,7 +22126,7 @@
             <a:r>
               <a:rPr sz="1200" b="1">
                 <a:solidFill>
-                  <a:srgbClr val="FFFFFF"/>
+                  <a:srgbClr val="B8860B"/>
                 </a:solidFill>
               </a:rPr>
               <a:t>Community
@@ -22226,7 +22226,7 @@
             <a:r>
               <a:rPr sz="1200" b="1">
                 <a:solidFill>
-                  <a:srgbClr val="FFFFFF"/>
+                  <a:srgbClr val="B8860B"/>
                 </a:solidFill>
               </a:rPr>
               <a:t>We Wait</a:t>
@@ -22481,7 +22481,7 @@
             <a:r>
               <a:rPr sz="2000" b="1" i="0">
                 <a:solidFill>
-                  <a:srgbClr val="D4AF37"/>
+                  <a:srgbClr val="B8860B"/>
                 </a:solidFill>
                 <a:latin typeface="Calibri"/>
               </a:rPr>
@@ -24253,7 +24253,7 @@
             <a:r>
               <a:rPr sz="1500" b="1">
                 <a:solidFill>
-                  <a:srgbClr val="FFFFFF"/>
+                  <a:srgbClr val="B8860B"/>
                 </a:solidFill>
               </a:rPr>
               <a:t>DSS</a:t>
@@ -24416,7 +24416,7 @@
             <a:r>
               <a:rPr sz="1500" b="1">
                 <a:solidFill>
-                  <a:srgbClr val="FFFFFF"/>
+                  <a:srgbClr val="B8860B"/>
                 </a:solidFill>
               </a:rPr>
               <a:t>State
@@ -24582,7 +24582,7 @@
             <a:r>
               <a:rPr sz="1500" b="1">
                 <a:solidFill>
-                  <a:srgbClr val="FFFFFF"/>
+                  <a:srgbClr val="B8860B"/>
                 </a:solidFill>
               </a:rPr>
               <a:t>Community
@@ -25602,7 +25602,7 @@
             <a:r>
               <a:rPr sz="2000" b="1" i="0">
                 <a:solidFill>
-                  <a:srgbClr val="D4AF37"/>
+                  <a:srgbClr val="B8860B"/>
                 </a:solidFill>
                 <a:latin typeface="Calibri"/>
               </a:rPr>
@@ -25642,9 +25642,9 @@
               </a:spcAft>
             </a:pPr>
             <a:r>
-              <a:rPr sz="2000">
-                <a:solidFill>
-                  <a:srgbClr val="FFFFFF"/>
+              <a:rPr sz="2000" b="1">
+                <a:solidFill>
+                  <a:srgbClr val="B8860B"/>
                 </a:solidFill>
                 <a:latin typeface="Calibri"/>
               </a:rPr>
@@ -25661,9 +25661,9 @@
               </a:spcAft>
             </a:pPr>
             <a:r>
-              <a:rPr sz="2000">
-                <a:solidFill>
-                  <a:srgbClr val="FFFFFF"/>
+              <a:rPr sz="2000" b="1">
+                <a:solidFill>
+                  <a:srgbClr val="B8860B"/>
                 </a:solidFill>
                 <a:latin typeface="Calibri"/>
               </a:rPr>
@@ -25680,9 +25680,9 @@
               </a:spcAft>
             </a:pPr>
             <a:r>
-              <a:rPr sz="2000">
-                <a:solidFill>
-                  <a:srgbClr val="FFFFFF"/>
+              <a:rPr sz="2000" b="1">
+                <a:solidFill>
+                  <a:srgbClr val="B8860B"/>
                 </a:solidFill>
                 <a:latin typeface="Calibri"/>
               </a:rPr>
@@ -25699,9 +25699,9 @@
               </a:spcAft>
             </a:pPr>
             <a:r>
-              <a:rPr sz="2000">
-                <a:solidFill>
-                  <a:srgbClr val="FFFFFF"/>
+              <a:rPr sz="2000" b="1">
+                <a:solidFill>
+                  <a:srgbClr val="B8860B"/>
                 </a:solidFill>
                 <a:latin typeface="Calibri"/>
               </a:rPr>
@@ -25718,9 +25718,9 @@
               </a:spcAft>
             </a:pPr>
             <a:r>
-              <a:rPr sz="2000">
-                <a:solidFill>
-                  <a:srgbClr val="FFFFFF"/>
+              <a:rPr sz="2000" b="1">
+                <a:solidFill>
+                  <a:srgbClr val="B8860B"/>
                 </a:solidFill>
                 <a:latin typeface="Calibri"/>
               </a:rPr>
@@ -25737,9 +25737,9 @@
               </a:spcAft>
             </a:pPr>
             <a:r>
-              <a:rPr sz="2000">
-                <a:solidFill>
-                  <a:srgbClr val="FFFFFF"/>
+              <a:rPr sz="2000" b="1">
+                <a:solidFill>
+                  <a:srgbClr val="B8860B"/>
                 </a:solidFill>
                 <a:latin typeface="Calibri"/>
               </a:rPr>
@@ -26482,7 +26482,7 @@
             <a:r>
               <a:rPr sz="1150" b="1">
                 <a:solidFill>
-                  <a:srgbClr val="FFFFFF"/>
+                  <a:srgbClr val="B8860B"/>
                 </a:solidFill>
               </a:rPr>
               <a:t>Security
@@ -26588,7 +26588,7 @@
             <a:r>
               <a:rPr sz="1150" b="1">
                 <a:solidFill>
-                  <a:srgbClr val="FFFFFF"/>
+                  <a:srgbClr val="B8860B"/>
                 </a:solidFill>
               </a:rPr>
               <a:t>Confirmation

</xml_diff>